<commit_message>
feat(pitch-deck): rewrite Slide 2 to ground problem in Kenyan urban water reality (Ngong, Rongai)
</commit_message>
<xml_diff>
--- a/Drop_Pitch_Deck.pptx
+++ b/Drop_Pitch_Deck.pptx
@@ -11583,7 +11583,7 @@
         <p:spPr>
           <a:xfrm>
             <a:off x="731520" y="548640"/>
-            <a:ext cx="10058400" cy="731520"/>
+            <a:ext cx="10058400" cy="685800"/>
           </a:xfrm>
           <a:prstGeom prst="rect">
             <a:avLst/>
@@ -11598,12 +11598,12 @@
           <a:p>
             <a:pPr algn="l">
               <a:lnSpc>
-                <a:spcPts val="4320"/>
-              </a:lnSpc>
-              <a:spcAft>
-                <a:spcPts val="0"/>
-              </a:spcAft>
-              <a:defRPr sz="3600" b="1">
+                <a:spcPts val="4079"/>
+              </a:lnSpc>
+              <a:spcAft>
+                <a:spcPts val="0"/>
+              </a:spcAft>
+              <a:defRPr sz="3400" b="1">
                 <a:solidFill>
                   <a:srgbClr val="1E293B"/>
                 </a:solidFill>
@@ -11611,7 +11611,7 @@
               </a:defRPr>
             </a:pPr>
             <a:r>
-              <a:t>The Problem</a:t>
+              <a:t>The Problem: Kenya's Urban Water Crisis</a:t>
             </a:r>
           </a:p>
         </p:txBody>
@@ -11661,14 +11661,56 @@
       </p:sp>
       <p:sp>
         <p:nvSpPr>
-          <p:cNvPr id="4" name="Rounded Rectangle 3"/>
+          <p:cNvPr id="4" name="TextBox 3"/>
+          <p:cNvSpPr txBox="1"/>
+          <p:nvPr/>
+        </p:nvSpPr>
+        <p:spPr>
+          <a:xfrm>
+            <a:off x="731520" y="1325880"/>
+            <a:ext cx="10698480" cy="502920"/>
+          </a:xfrm>
+          <a:prstGeom prst="rect">
+            <a:avLst/>
+          </a:prstGeom>
+          <a:noFill/>
+        </p:spPr>
+        <p:txBody>
+          <a:bodyPr wrap="square">
+            <a:spAutoFit/>
+          </a:bodyPr>
+          <a:lstStyle/>
+          <a:p>
+            <a:pPr algn="l">
+              <a:lnSpc>
+                <a:spcPts val="1560"/>
+              </a:lnSpc>
+              <a:spcAft>
+                <a:spcPts val="0"/>
+              </a:spcAft>
+              <a:defRPr sz="1300" b="0">
+                <a:solidFill>
+                  <a:srgbClr val="64748B"/>
+                </a:solidFill>
+                <a:latin typeface="Karla"/>
+              </a:defRPr>
+            </a:pPr>
+            <a:r>
+              <a:t>In rapid-growth satellite towns like Rongai and Ngong, municipal taps stay dry for weeks. Over 15M urban Kenyans depend on informal vendors — enduring predatory cartels, unverified water quality, and logistics chaos.</a:t>
+            </a:r>
+          </a:p>
+        </p:txBody>
+      </p:sp>
+      <p:sp>
+        <p:nvSpPr>
+          <p:cNvPr id="5" name="Rounded Rectangle 4"/>
           <p:cNvSpPr/>
           <p:nvPr/>
         </p:nvSpPr>
         <p:spPr>
           <a:xfrm>
-            <a:off x="731520" y="1737360"/>
-            <a:ext cx="5029200" cy="2011680"/>
+            <a:off x="731520" y="1965960"/>
+            <a:ext cx="5212080" cy="2057400"/>
           </a:xfrm>
           <a:prstGeom prst="roundRect">
             <a:avLst/>
@@ -11704,14 +11746,14 @@
       </p:sp>
       <p:sp>
         <p:nvSpPr>
-          <p:cNvPr id="5" name="TextBox 4"/>
-          <p:cNvSpPr txBox="1"/>
-          <p:nvPr/>
-        </p:nvSpPr>
-        <p:spPr>
-          <a:xfrm>
-            <a:off x="1097280" y="2011680"/>
-            <a:ext cx="4297680" cy="457200"/>
+          <p:cNvPr id="6" name="TextBox 5"/>
+          <p:cNvSpPr txBox="1"/>
+          <p:nvPr/>
+        </p:nvSpPr>
+        <p:spPr>
+          <a:xfrm>
+            <a:off x="1051560" y="2167128"/>
+            <a:ext cx="4572000" cy="365760"/>
           </a:xfrm>
           <a:prstGeom prst="rect">
             <a:avLst/>
@@ -11726,12 +11768,12 @@
           <a:p>
             <a:pPr algn="l">
               <a:lnSpc>
-                <a:spcPts val="2160"/>
-              </a:lnSpc>
-              <a:spcAft>
-                <a:spcPts val="0"/>
-              </a:spcAft>
-              <a:defRPr sz="1800" b="1">
+                <a:spcPts val="1800"/>
+              </a:lnSpc>
+              <a:spcAft>
+                <a:spcPts val="0"/>
+              </a:spcAft>
+              <a:defRPr sz="1500" b="1">
                 <a:solidFill>
                   <a:srgbClr val="1D4ED8"/>
                 </a:solidFill>
@@ -11739,21 +11781,21 @@
               </a:defRPr>
             </a:pPr>
             <a:r>
-              <a:t>🚰  Unreliable Supply</a:t>
-            </a:r>
-          </a:p>
-        </p:txBody>
-      </p:sp>
-      <p:sp>
-        <p:nvSpPr>
-          <p:cNvPr id="6" name="TextBox 5"/>
-          <p:cNvSpPr txBox="1"/>
-          <p:nvPr/>
-        </p:nvSpPr>
-        <p:spPr>
-          <a:xfrm>
-            <a:off x="1097280" y="2560320"/>
-            <a:ext cx="4297680" cy="1097280"/>
+              <a:t>⚠️  Chronic Rationing &amp; Cartel Price Gouging</a:t>
+            </a:r>
+          </a:p>
+        </p:txBody>
+      </p:sp>
+      <p:sp>
+        <p:nvSpPr>
+          <p:cNvPr id="7" name="TextBox 6"/>
+          <p:cNvSpPr txBox="1"/>
+          <p:nvPr/>
+        </p:nvSpPr>
+        <p:spPr>
+          <a:xfrm>
+            <a:off x="1051560" y="2624328"/>
+            <a:ext cx="4572000" cy="1325880"/>
           </a:xfrm>
           <a:prstGeom prst="rect">
             <a:avLst/>
@@ -11768,12 +11810,12 @@
           <a:p>
             <a:pPr algn="l">
               <a:lnSpc>
-                <a:spcPts val="1820"/>
-              </a:lnSpc>
-              <a:spcAft>
-                <a:spcPts val="0"/>
-              </a:spcAft>
-              <a:defRPr sz="1300" b="0">
+                <a:spcPts val="1495"/>
+              </a:lnSpc>
+              <a:spcAft>
+                <a:spcPts val="0"/>
+              </a:spcAft>
+              <a:defRPr sz="1150" b="0">
                 <a:solidFill>
                   <a:srgbClr val="64748B"/>
                 </a:solidFill>
@@ -11781,21 +11823,21 @@
               </a:defRPr>
             </a:pPr>
             <a:r>
-              <a:t>Millions of Kenyans face chronic water shortages. Urban and peri-urban residents rely on informal vendors with no transparency on quality, pricing, or delivery timelines.</a:t>
-            </a:r>
-          </a:p>
-        </p:txBody>
-      </p:sp>
-      <p:sp>
-        <p:nvSpPr>
-          <p:cNvPr id="7" name="Rounded Rectangle 6"/>
+              <a:t>Municipal piped supply (Oloolaiser, NCWSC) dries up for weeks on end. Households and apartments are forced onto unregulated vendors who arbitrarily double or triple prices during shortages (KSh 20 jumping to KSh 60–80 per 20L; bowsers surging from KSh 2,500 to KSh 6,000+) with zero price transparency.</a:t>
+            </a:r>
+          </a:p>
+        </p:txBody>
+      </p:sp>
+      <p:sp>
+        <p:nvSpPr>
+          <p:cNvPr id="8" name="Rounded Rectangle 7"/>
           <p:cNvSpPr/>
           <p:nvPr/>
         </p:nvSpPr>
         <p:spPr>
           <a:xfrm>
-            <a:off x="6126480" y="1737360"/>
-            <a:ext cx="5029200" cy="2011680"/>
+            <a:off x="6217920" y="1965960"/>
+            <a:ext cx="5212080" cy="2057400"/>
           </a:xfrm>
           <a:prstGeom prst="roundRect">
             <a:avLst/>
@@ -11831,14 +11873,14 @@
       </p:sp>
       <p:sp>
         <p:nvSpPr>
-          <p:cNvPr id="8" name="TextBox 7"/>
-          <p:cNvSpPr txBox="1"/>
-          <p:nvPr/>
-        </p:nvSpPr>
-        <p:spPr>
-          <a:xfrm>
-            <a:off x="6492240" y="2011680"/>
-            <a:ext cx="4297680" cy="457200"/>
+          <p:cNvPr id="9" name="TextBox 8"/>
+          <p:cNvSpPr txBox="1"/>
+          <p:nvPr/>
+        </p:nvSpPr>
+        <p:spPr>
+          <a:xfrm>
+            <a:off x="6537960" y="2167128"/>
+            <a:ext cx="4572000" cy="365760"/>
           </a:xfrm>
           <a:prstGeom prst="rect">
             <a:avLst/>
@@ -11853,12 +11895,12 @@
           <a:p>
             <a:pPr algn="l">
               <a:lnSpc>
-                <a:spcPts val="2160"/>
-              </a:lnSpc>
-              <a:spcAft>
-                <a:spcPts val="0"/>
-              </a:spcAft>
-              <a:defRPr sz="1800" b="1">
+                <a:spcPts val="1800"/>
+              </a:lnSpc>
+              <a:spcAft>
+                <a:spcPts val="0"/>
+              </a:spcAft>
+              <a:defRPr sz="1500" b="1">
                 <a:solidFill>
                   <a:srgbClr val="1D4ED8"/>
                 </a:solidFill>
@@ -11866,21 +11908,21 @@
               </a:defRPr>
             </a:pPr>
             <a:r>
-              <a:t>💸  Fragmented Market</a:t>
-            </a:r>
-          </a:p>
-        </p:txBody>
-      </p:sp>
-      <p:sp>
-        <p:nvSpPr>
-          <p:cNvPr id="9" name="TextBox 8"/>
-          <p:cNvSpPr txBox="1"/>
-          <p:nvPr/>
-        </p:nvSpPr>
-        <p:spPr>
-          <a:xfrm>
-            <a:off x="6492240" y="2560320"/>
-            <a:ext cx="4297680" cy="1097280"/>
+              <a:t>🧪  Water Quality Roulette &amp; Health Hazards</a:t>
+            </a:r>
+          </a:p>
+        </p:txBody>
+      </p:sp>
+      <p:sp>
+        <p:nvSpPr>
+          <p:cNvPr id="10" name="TextBox 9"/>
+          <p:cNvSpPr txBox="1"/>
+          <p:nvPr/>
+        </p:nvSpPr>
+        <p:spPr>
+          <a:xfrm>
+            <a:off x="6537960" y="2624328"/>
+            <a:ext cx="4572000" cy="1325880"/>
           </a:xfrm>
           <a:prstGeom prst="rect">
             <a:avLst/>
@@ -11895,12 +11937,12 @@
           <a:p>
             <a:pPr algn="l">
               <a:lnSpc>
-                <a:spcPts val="1820"/>
-              </a:lnSpc>
-              <a:spcAft>
-                <a:spcPts val="0"/>
-              </a:spcAft>
-              <a:defRPr sz="1300" b="0">
+                <a:spcPts val="1495"/>
+              </a:lnSpc>
+              <a:spcAft>
+                <a:spcPts val="0"/>
+              </a:spcAft>
+              <a:defRPr sz="1150" b="0">
                 <a:solidFill>
                   <a:srgbClr val="64748B"/>
                 </a:solidFill>
@@ -11908,21 +11950,21 @@
               </a:defRPr>
             </a:pPr>
             <a:r>
-              <a:t>Water vending is hyper-local and unorganized. Vendors operate in silos with no digital presence, making discovery impossible for customers and scaling impossible for vendors.</a:t>
-            </a:r>
-          </a:p>
-        </p:txBody>
-      </p:sp>
-      <p:sp>
-        <p:nvSpPr>
-          <p:cNvPr id="10" name="Rounded Rectangle 9"/>
+              <a:t>Groundwater across the Rongai–Ngong corridor suffers from dangerous fluoride concentrations and high salinity. Informal vendors routinely source from uncertified boreholes or mix untreated water into dirty jerricans, with zero KEBS verification, testing logs, or hygiene oversight.</a:t>
+            </a:r>
+          </a:p>
+        </p:txBody>
+      </p:sp>
+      <p:sp>
+        <p:nvSpPr>
+          <p:cNvPr id="11" name="Rounded Rectangle 10"/>
           <p:cNvSpPr/>
           <p:nvPr/>
         </p:nvSpPr>
         <p:spPr>
           <a:xfrm>
-            <a:off x="731520" y="4023360"/>
-            <a:ext cx="5029200" cy="2011680"/>
+            <a:off x="731520" y="4206240"/>
+            <a:ext cx="5212080" cy="2057400"/>
           </a:xfrm>
           <a:prstGeom prst="roundRect">
             <a:avLst/>
@@ -11958,14 +12000,14 @@
       </p:sp>
       <p:sp>
         <p:nvSpPr>
-          <p:cNvPr id="11" name="TextBox 10"/>
-          <p:cNvSpPr txBox="1"/>
-          <p:nvPr/>
-        </p:nvSpPr>
-        <p:spPr>
-          <a:xfrm>
-            <a:off x="1097280" y="4297680"/>
-            <a:ext cx="4297680" cy="457200"/>
+          <p:cNvPr id="12" name="TextBox 11"/>
+          <p:cNvSpPr txBox="1"/>
+          <p:nvPr/>
+        </p:nvSpPr>
+        <p:spPr>
+          <a:xfrm>
+            <a:off x="1051560" y="4407408"/>
+            <a:ext cx="4572000" cy="365760"/>
           </a:xfrm>
           <a:prstGeom prst="rect">
             <a:avLst/>
@@ -11980,12 +12022,12 @@
           <a:p>
             <a:pPr algn="l">
               <a:lnSpc>
-                <a:spcPts val="2160"/>
-              </a:lnSpc>
-              <a:spcAft>
-                <a:spcPts val="0"/>
-              </a:spcAft>
-              <a:defRPr sz="1800" b="1">
+                <a:spcPts val="1800"/>
+              </a:lnSpc>
+              <a:spcAft>
+                <a:spcPts val="0"/>
+              </a:spcAft>
+              <a:defRPr sz="1500" b="1">
                 <a:solidFill>
                   <a:srgbClr val="1D4ED8"/>
                 </a:solidFill>
@@ -11993,21 +12035,21 @@
               </a:defRPr>
             </a:pPr>
             <a:r>
-              <a:t>🚫  Zero Accountability</a:t>
-            </a:r>
-          </a:p>
-        </p:txBody>
-      </p:sp>
-      <p:sp>
-        <p:nvSpPr>
-          <p:cNvPr id="12" name="TextBox 11"/>
-          <p:cNvSpPr txBox="1"/>
-          <p:nvPr/>
-        </p:nvSpPr>
-        <p:spPr>
-          <a:xfrm>
-            <a:off x="1097280" y="4846320"/>
-            <a:ext cx="4297680" cy="1097280"/>
+              <a:t>⏳  Broken "Call-and-Pray" Delivery</a:t>
+            </a:r>
+          </a:p>
+        </p:txBody>
+      </p:sp>
+      <p:sp>
+        <p:nvSpPr>
+          <p:cNvPr id="13" name="TextBox 12"/>
+          <p:cNvSpPr txBox="1"/>
+          <p:nvPr/>
+        </p:nvSpPr>
+        <p:spPr>
+          <a:xfrm>
+            <a:off x="1051560" y="4864608"/>
+            <a:ext cx="4572000" cy="1325880"/>
           </a:xfrm>
           <a:prstGeom prst="rect">
             <a:avLst/>
@@ -12022,12 +12064,12 @@
           <a:p>
             <a:pPr algn="l">
               <a:lnSpc>
-                <a:spcPts val="1820"/>
-              </a:lnSpc>
-              <a:spcAft>
-                <a:spcPts val="0"/>
-              </a:spcAft>
-              <a:defRPr sz="1300" b="0">
+                <a:spcPts val="1495"/>
+              </a:lnSpc>
+              <a:spcAft>
+                <a:spcPts val="0"/>
+              </a:spcAft>
+              <a:defRPr sz="1150" b="0">
                 <a:solidFill>
                   <a:srgbClr val="64748B"/>
                 </a:solidFill>
@@ -12035,21 +12077,21 @@
               </a:defRPr>
             </a:pPr>
             <a:r>
-              <a:t>No tracking, no proof of delivery, no dispute resolution. Cash-only transactions leave no audit trail. Bottle deposits are lost. Customers have no recourse.</a:t>
-            </a:r>
-          </a:p>
-        </p:txBody>
-      </p:sp>
-      <p:sp>
-        <p:nvSpPr>
-          <p:cNvPr id="13" name="Rounded Rectangle 12"/>
+              <a:t>Residents must call faded phone numbers scrawled on electricity poles and estate gates. Vendors promise "niko njiani" but arrive 4–8 hours late or abandon orders for higher bidders. Furthermore, high-value 20L dispenser bottles (KSh 1,200+ deposit) are frequently stolen or swapped for counterfeit jugs.</a:t>
+            </a:r>
+          </a:p>
+        </p:txBody>
+      </p:sp>
+      <p:sp>
+        <p:nvSpPr>
+          <p:cNvPr id="14" name="Rounded Rectangle 13"/>
           <p:cNvSpPr/>
           <p:nvPr/>
         </p:nvSpPr>
         <p:spPr>
           <a:xfrm>
-            <a:off x="6126480" y="4023360"/>
-            <a:ext cx="5029200" cy="2011680"/>
+            <a:off x="6217920" y="4206240"/>
+            <a:ext cx="5212080" cy="2057400"/>
           </a:xfrm>
           <a:prstGeom prst="roundRect">
             <a:avLst/>
@@ -12085,14 +12127,14 @@
       </p:sp>
       <p:sp>
         <p:nvSpPr>
-          <p:cNvPr id="14" name="TextBox 13"/>
-          <p:cNvSpPr txBox="1"/>
-          <p:nvPr/>
-        </p:nvSpPr>
-        <p:spPr>
-          <a:xfrm>
-            <a:off x="6492240" y="4297680"/>
-            <a:ext cx="4297680" cy="457200"/>
+          <p:cNvPr id="15" name="TextBox 14"/>
+          <p:cNvSpPr txBox="1"/>
+          <p:nvPr/>
+        </p:nvSpPr>
+        <p:spPr>
+          <a:xfrm>
+            <a:off x="6537960" y="4407408"/>
+            <a:ext cx="4572000" cy="365760"/>
           </a:xfrm>
           <a:prstGeom prst="rect">
             <a:avLst/>
@@ -12107,12 +12149,12 @@
           <a:p>
             <a:pPr algn="l">
               <a:lnSpc>
-                <a:spcPts val="2160"/>
-              </a:lnSpc>
-              <a:spcAft>
-                <a:spcPts val="0"/>
-              </a:spcAft>
-              <a:defRPr sz="1800" b="1">
+                <a:spcPts val="1800"/>
+              </a:lnSpc>
+              <a:spcAft>
+                <a:spcPts val="0"/>
+              </a:spcAft>
+              <a:defRPr sz="1500" b="1">
                 <a:solidFill>
                   <a:srgbClr val="1D4ED8"/>
                 </a:solidFill>
@@ -12120,21 +12162,21 @@
               </a:defRPr>
             </a:pPr>
             <a:r>
-              <a:t>📱  Digital Divide</a:t>
-            </a:r>
-          </a:p>
-        </p:txBody>
-      </p:sp>
-      <p:sp>
-        <p:nvSpPr>
-          <p:cNvPr id="15" name="TextBox 14"/>
-          <p:cNvSpPr txBox="1"/>
-          <p:nvPr/>
-        </p:nvSpPr>
-        <p:spPr>
-          <a:xfrm>
-            <a:off x="6492240" y="4846320"/>
-            <a:ext cx="4297680" cy="1097280"/>
+              <a:t>📱  Offline Chaos in a Mobile-First Economy</a:t>
+            </a:r>
+          </a:p>
+        </p:txBody>
+      </p:sp>
+      <p:sp>
+        <p:nvSpPr>
+          <p:cNvPr id="16" name="TextBox 15"/>
+          <p:cNvSpPr txBox="1"/>
+          <p:nvPr/>
+        </p:nvSpPr>
+        <p:spPr>
+          <a:xfrm>
+            <a:off x="6537960" y="4864608"/>
+            <a:ext cx="4572000" cy="1325880"/>
           </a:xfrm>
           <a:prstGeom prst="rect">
             <a:avLst/>
@@ -12149,12 +12191,12 @@
           <a:p>
             <a:pPr algn="l">
               <a:lnSpc>
-                <a:spcPts val="1820"/>
-              </a:lnSpc>
-              <a:spcAft>
-                <a:spcPts val="0"/>
-              </a:spcAft>
-              <a:defRPr sz="1300" b="0">
+                <a:spcPts val="1495"/>
+              </a:lnSpc>
+              <a:spcAft>
+                <a:spcPts val="0"/>
+              </a:spcAft>
+              <a:defRPr sz="1150" b="0">
                 <a:solidFill>
                   <a:srgbClr val="64748B"/>
                 </a:solidFill>
@@ -12162,14 +12204,14 @@
               </a:defRPr>
             </a:pPr>
             <a:r>
-              <a:t>Despite 90%+ mobile penetration in Kenya, no platform connects water customers to vendors with real-time tracking, mobile payments, and quality assurance.</a:t>
-            </a:r>
-          </a:p>
-        </p:txBody>
-      </p:sp>
-      <p:sp>
-        <p:nvSpPr>
-          <p:cNvPr id="16" name="TextBox 15"/>
+              <a:t>Kenya is the world leader in mobile money, yet water delivery remains stubbornly analog. Direct peer-to-peer M-Pesa transfers offer zero buyer escrow, no real-time delivery tracking, no proof-of-delivery receipts, and zero dispute recourse when orders fail or water is foul.</a:t>
+            </a:r>
+          </a:p>
+        </p:txBody>
+      </p:sp>
+      <p:sp>
+        <p:nvSpPr>
+          <p:cNvPr id="17" name="TextBox 16"/>
           <p:cNvSpPr txBox="1"/>
           <p:nvPr/>
         </p:nvSpPr>
@@ -12211,7 +12253,7 @@
       </p:sp>
       <p:sp>
         <p:nvSpPr>
-          <p:cNvPr id="17" name="TextBox 16"/>
+          <p:cNvPr id="18" name="TextBox 17"/>
           <p:cNvSpPr txBox="1"/>
           <p:nvPr/>
         </p:nvSpPr>
@@ -13701,7 +13743,7 @@
               </a:defRPr>
             </a:pPr>
             <a:r>
-              <a:t>Nairobi metro + satellite towns (Ngong, Kiambu, Thika) — our first 24-month target.</a:t>
+              <a:t>Nairobi metro + satellite boomtowns (Rongai, Ngong, Ruiru, Kiambu) — our first 24-month target.</a:t>
             </a:r>
           </a:p>
         </p:txBody>

</xml_diff>

<commit_message>
feat(pitch-deck): center problem and solution on water refill station logistics and 20kg doorstep delivery
</commit_message>
<xml_diff>
--- a/Drop_Pitch_Deck.pptx
+++ b/Drop_Pitch_Deck.pptx
@@ -3179,8 +3179,8 @@
         </p:nvSpPr>
         <p:spPr>
           <a:xfrm>
-            <a:off x="2286000" y="3931920"/>
-            <a:ext cx="7315200" cy="914400"/>
+            <a:off x="1828800" y="3931920"/>
+            <a:ext cx="8503920" cy="1097280"/>
           </a:xfrm>
           <a:prstGeom prst="rect">
             <a:avLst/>
@@ -3208,11 +3208,11 @@
               </a:defRPr>
             </a:pPr>
             <a:r>
-              <a:t>Kenya's first multivendor water delivery marketplace.</a:t>
+              <a:t>On-demand delivery platform for neighborhood water refill stations.</a:t>
             </a:r>
             <a:br/>
             <a:r>
-              <a:t>Connecting communities with clean water through technology.</a:t>
+              <a:t>Scan nearby stations, compare refill prices, and eliminate the 20kg hauling struggle.</a:t>
             </a:r>
           </a:p>
         </p:txBody>
@@ -11583,7 +11583,7 @@
         <p:spPr>
           <a:xfrm>
             <a:off x="731520" y="548640"/>
-            <a:ext cx="10058400" cy="685800"/>
+            <a:ext cx="10789920" cy="594360"/>
           </a:xfrm>
           <a:prstGeom prst="rect">
             <a:avLst/>
@@ -11598,12 +11598,12 @@
           <a:p>
             <a:pPr algn="l">
               <a:lnSpc>
-                <a:spcPts val="4079"/>
-              </a:lnSpc>
-              <a:spcAft>
-                <a:spcPts val="0"/>
-              </a:spcAft>
-              <a:defRPr sz="3400" b="1">
+                <a:spcPts val="3719"/>
+              </a:lnSpc>
+              <a:spcAft>
+                <a:spcPts val="0"/>
+              </a:spcAft>
+              <a:defRPr sz="3100" b="1">
                 <a:solidFill>
                   <a:srgbClr val="1E293B"/>
                 </a:solidFill>
@@ -11611,7 +11611,7 @@
               </a:defRPr>
             </a:pPr>
             <a:r>
-              <a:t>The Problem: Kenya's Urban Water Crisis</a:t>
+              <a:t>The Problem: Water Refill Station Logistics</a:t>
             </a:r>
           </a:p>
         </p:txBody>
@@ -11624,7 +11624,7 @@
         </p:nvSpPr>
         <p:spPr>
           <a:xfrm>
-            <a:off x="731520" y="1234440"/>
+            <a:off x="731520" y="1188720"/>
             <a:ext cx="548640" cy="50800"/>
           </a:xfrm>
           <a:prstGeom prst="rect">
@@ -11667,7 +11667,7 @@
         </p:nvSpPr>
         <p:spPr>
           <a:xfrm>
-            <a:off x="731520" y="1325880"/>
+            <a:off x="731520" y="1298448"/>
             <a:ext cx="10698480" cy="502920"/>
           </a:xfrm>
           <a:prstGeom prst="rect">
@@ -11696,7 +11696,7 @@
               </a:defRPr>
             </a:pPr>
             <a:r>
-              <a:t>In rapid-growth satellite towns like Rongai and Ngong, municipal taps stay dry for weeks. Over 15M urban Kenyans depend on informal vendors — enduring predatory cartels, unverified water quality, and logistics chaos.</a:t>
+              <a:t>Millions of urban Kenyans rely on local refill stations for clean 20L drinking water. But getting it home is exhausting: walking with empties, carrying 20kg back, or bargaining with random street bodas.</a:t>
             </a:r>
           </a:p>
         </p:txBody>
@@ -11781,7 +11781,7 @@
               </a:defRPr>
             </a:pPr>
             <a:r>
-              <a:t>⚠️  Chronic Rationing &amp; Cartel Price Gouging</a:t>
+              <a:t>🚶‍♂️  The Exhausting "20kg Walk"</a:t>
             </a:r>
           </a:p>
         </p:txBody>
@@ -11823,7 +11823,7 @@
               </a:defRPr>
             </a:pPr>
             <a:r>
-              <a:t>Municipal piped supply (Oloolaiser, NCWSC) dries up for weeks on end. Households and apartments are forced onto unregulated vendors who arbitrarily double or triple prices during shortages (KSh 20 jumping to KSh 60–80 per 20L; bowsers surging from KSh 2,500 to KSh 6,000+) with zero price transparency.</a:t>
+              <a:t>To get clean drinking water, customers must carry an empty 20L bottle, walk to a neighborhood refill shop, wait in line, and physically haul a back-breaking 20kg (44 lbs) refilled container back home on foot — often climbing several flights of apartment stairs.</a:t>
             </a:r>
           </a:p>
         </p:txBody>
@@ -11908,7 +11908,7 @@
               </a:defRPr>
             </a:pPr>
             <a:r>
-              <a:t>🧪  Water Quality Roulette &amp; Health Hazards</a:t>
+              <a:t>🏍️  The Inconvenient Boda Compromise</a:t>
             </a:r>
           </a:p>
         </p:txBody>
@@ -11950,7 +11950,7 @@
               </a:defRPr>
             </a:pPr>
             <a:r>
-              <a:t>Groundwater across the Rongai–Ngong corridor suffers from dangerous fluoride concentrations and high salinity. Informal vendors routinely source from uncertified boreholes or mix untreated water into dirty jerricans, with zero KEBS verification, testing logs, or hygiene oversight.</a:t>
+              <a:t>To avoid the 20kg walk, customers must walk to a roadside stage, hail a motorbike rider, haggle over arbitrary fares, and dangerously balance a 20L bottle on the bike — turning an affordable KSh 80 refill into an expensive, risky ordeal.</a:t>
             </a:r>
           </a:p>
         </p:txBody>
@@ -12035,7 +12035,7 @@
               </a:defRPr>
             </a:pPr>
             <a:r>
-              <a:t>⏳  Broken "Call-and-Pray" Delivery</a:t>
+              <a:t>🏪  Refill Stations Lack Delivery Fleets</a:t>
             </a:r>
           </a:p>
         </p:txBody>
@@ -12077,7 +12077,7 @@
               </a:defRPr>
             </a:pPr>
             <a:r>
-              <a:t>Residents must call faded phone numbers scrawled on electricity poles and estate gates. Vendors promise "niko njiani" but arrive 4–8 hours late or abandon orders for higher bidders. Furthermore, high-value 20L dispenser bottles (KSh 1,200+ deposit) are frequently stolen or swapped for counterfeit jugs.</a:t>
+              <a:t>Neighborhood water refill shops and ATMs have pure purification capacity, but operate strictly as walk-in counters. With no delivery fleet or dispatch tools, they cannot reach busy families, offices, or customers living beyond walking distance.</a:t>
             </a:r>
           </a:p>
         </p:txBody>
@@ -12162,7 +12162,7 @@
               </a:defRPr>
             </a:pPr>
             <a:r>
-              <a:t>📱  Offline Chaos in a Mobile-First Economy</a:t>
+              <a:t>🔍  Blind Discovery &amp; Price Opacity</a:t>
             </a:r>
           </a:p>
         </p:txBody>
@@ -12204,7 +12204,7 @@
               </a:defRPr>
             </a:pPr>
             <a:r>
-              <a:t>Kenya is the world leader in mobile money, yet water delivery remains stubbornly analog. Direct peer-to-peer M-Pesa transfers offer zero buyer escrow, no real-time delivery tracking, no proof-of-delivery receipts, and zero dispute recourse when orders fail or water is foul.</a:t>
+              <a:t>Customers cannot easily scan or compare nearby refill stations (prices vary from KSh 60 to KSh 120+). They have no way to verify station operating status, track queue times, or coordinate reliable empty bottle exchanges.</a:t>
             </a:r>
           </a:p>
         </p:txBody>
@@ -12356,7 +12356,7 @@
               </a:defRPr>
             </a:pPr>
             <a:r>
-              <a:t>The Solution</a:t>
+              <a:t>The Solution: On-Demand Refill Delivery</a:t>
             </a:r>
           </a:p>
         </p:txBody>
@@ -12428,12 +12428,12 @@
           <a:p>
             <a:pPr algn="l">
               <a:lnSpc>
-                <a:spcPts val="1920"/>
-              </a:lnSpc>
-              <a:spcAft>
-                <a:spcPts val="0"/>
-              </a:spcAft>
-              <a:defRPr sz="1600" b="0">
+                <a:spcPts val="1800"/>
+              </a:lnSpc>
+              <a:spcAft>
+                <a:spcPts val="0"/>
+              </a:spcAft>
+              <a:defRPr sz="1500" b="0">
                 <a:solidFill>
                   <a:srgbClr val="64748B"/>
                 </a:solidFill>
@@ -12441,7 +12441,7 @@
               </a:defRPr>
             </a:pPr>
             <a:r>
-              <a:t>Drop is a full-stack multivendor marketplace for water delivery — purpose-built for Kenya's mobile-first economy.</a:t>
+              <a:t>Drop bridges the gap between water refill stations and thirsty households — scan nearby stations, compare prices in real time, and get heavy 20L bottles delivered straight to your door.</a:t>
             </a:r>
           </a:p>
         </p:txBody>
@@ -12627,7 +12627,7 @@
               </a:defRPr>
             </a:pPr>
             <a:r>
-              <a:t>Browse nearby vendors, compare prices, order with one tap, pay via M-Pesa, and track your rider in real time.</a:t>
+              <a:t>Scan nearby refill stations on the map, compare live prices, order 20L refills with one tap, pay via M-Pesa, and get heavy bottles delivered straight to your door.</a:t>
             </a:r>
           </a:p>
         </p:txBody>
@@ -12813,7 +12813,7 @@
               </a:defRPr>
             </a:pPr>
             <a:r>
-              <a:t>Manage your storefront, accept and fulfill orders, dispatch riders, and grow your business with analytics.</a:t>
+              <a:t>Equips stationary water refill shops with a turnkey on-demand delivery arm — manage orders, track bottle inventory, dispatch riders, and grow far beyond walk-in traffic.</a:t>
             </a:r>
           </a:p>
         </p:txBody>
@@ -12999,7 +12999,7 @@
               </a:defRPr>
             </a:pPr>
             <a:r>
-              <a:t>Accept deliveries, navigate efficiently, earn on your schedule, manage bottle deposits, and build your reputation.</a:t>
+              <a:t>Enables motorbike riders to accept delivery jobs, collect customer empties, exchange them at partner refill stations, and earn steady income handling the heavy hauling.</a:t>
             </a:r>
           </a:p>
         </p:txBody>
@@ -13041,7 +13041,7 @@
               </a:defRPr>
             </a:pPr>
             <a:r>
-              <a:t>+ Admin Operations Console  —  27 screens for real-time business management, KYC verification, dispute resolution, and financial oversight.</a:t>
+              <a:t>+ Admin Operations Console  —  27 screens for refill station management, bottle float tracking, live dispatch, and automated financial settlements.</a:t>
             </a:r>
           </a:p>
         </p:txBody>
@@ -14403,7 +14403,7 @@
               </a:defRPr>
             </a:pPr>
             <a:r>
-              <a:t>How It Works</a:t>
+              <a:t>How It Works: Doorstep Refill in 6 Steps</a:t>
             </a:r>
           </a:p>
         </p:txBody>
@@ -14547,7 +14547,7 @@
               </a:defRPr>
             </a:pPr>
             <a:r>
-              <a:t>Browse &amp; Order</a:t>
+              <a:t>Scan &amp; Compare</a:t>
             </a:r>
           </a:p>
         </p:txBody>
@@ -14589,7 +14589,7 @@
               </a:defRPr>
             </a:pPr>
             <a:r>
-              <a:t>Customer discovers nearby vendors via H3 hex-indexed geospatial search, builds a cart, and checks out.</a:t>
+              <a:t>Customer opens Drop, scans nearby water refill stations on the live map, and compares real-time refill prices.</a:t>
             </a:r>
           </a:p>
         </p:txBody>
@@ -14690,7 +14690,7 @@
               </a:defRPr>
             </a:pPr>
             <a:r>
-              <a:t>Pay via M-Pesa</a:t>
+              <a:t>Order &amp; Pay</a:t>
             </a:r>
           </a:p>
         </p:txBody>
@@ -14732,7 +14732,7 @@
               </a:defRPr>
             </a:pPr>
             <a:r>
-              <a:t>STK Push triggers instant mobile payment. Backend confirms via Safaricom callback. Order moves to 'unassigned'.</a:t>
+              <a:t>Customer selects 20L refill quantity, specifies empty bottle exchange, and checks out securely via M-Pesa STK Push.</a:t>
             </a:r>
           </a:p>
         </p:txBody>
@@ -14875,7 +14875,7 @@
               </a:defRPr>
             </a:pPr>
             <a:r>
-              <a:t>Two-tier dispatch: in-house riders offered first, then Trip Radar broadcasts to nearby gig riders over WebSocket.</a:t>
+              <a:t>Two-tier dispatch broadcasts the delivery to station-employed riders or nearby freelance gig riders.</a:t>
             </a:r>
           </a:p>
         </p:txBody>
@@ -14976,7 +14976,7 @@
               </a:defRPr>
             </a:pPr>
             <a:r>
-              <a:t>Prepare &amp; Collect</a:t>
+              <a:t>Pickup Empties</a:t>
             </a:r>
           </a:p>
         </p:txBody>
@@ -15018,7 +15018,7 @@
               </a:defRPr>
             </a:pPr>
             <a:r>
-              <a:t>Vendor prepares the order and marks it ready. Rider collects and begins navigation to the customer.</a:t>
+              <a:t>Rider collects customer's empty 20L bottles from their doorstep and takes them to the chosen refill station.</a:t>
             </a:r>
           </a:p>
         </p:txBody>
@@ -15119,7 +15119,7 @@
               </a:defRPr>
             </a:pPr>
             <a:r>
-              <a:t>Track &amp; Deliver</a:t>
+              <a:t>Doorstep Delivery</a:t>
             </a:r>
           </a:p>
         </p:txBody>
@@ -15161,7 +15161,7 @@
               </a:defRPr>
             </a:pPr>
             <a:r>
-              <a:t>Customer watches the rider's live location on the map. Rider delivers, collects empties, and captures photo proof.</a:t>
+              <a:t>Customer tracks rider GPS in real time. Rider climbs stairs and delivers the heavy 20kg bottles directly into the home.</a:t>
             </a:r>
           </a:p>
         </p:txBody>
@@ -15262,7 +15262,7 @@
               </a:defRPr>
             </a:pPr>
             <a:r>
-              <a:t>Settle &amp; Rate</a:t>
+              <a:t>Settle &amp; Log</a:t>
             </a:r>
           </a:p>
         </p:txBody>
@@ -15304,7 +15304,7 @@
               </a:defRPr>
             </a:pPr>
             <a:r>
-              <a:t>Revenue split credits wallets atomically. Bottle ledger updates. Customer rates both the store and the rider.</a:t>
+              <a:t>Instant revenue split credits vendor and rider M-Pesa wallets. Digital bottle ledger updates with zero deposit disputes.</a:t>
             </a:r>
           </a:p>
         </p:txBody>

</xml_diff>

<commit_message>
style(pitch-deck): unify all blue color shades to exact website header blue (#006DB0 / oklch(0.50 0.16 235))
</commit_message>
<xml_diff>
--- a/Drop_Pitch_Deck.pptx
+++ b/Drop_Pitch_Deck.pptx
@@ -3098,7 +3098,7 @@
     <p:bg>
       <p:bgPr>
         <a:solidFill>
-          <a:srgbClr val="2563EB"/>
+          <a:srgbClr val="006DB0"/>
         </a:solidFill>
         <a:effectLst/>
       </p:bgPr>
@@ -3202,7 +3202,7 @@
               </a:spcAft>
               <a:defRPr sz="1600" b="0">
                 <a:solidFill>
-                  <a:srgbClr val="DBEAFE"/>
+                  <a:srgbClr val="CFEDFF"/>
                 </a:solidFill>
                 <a:latin typeface="Karla"/>
               </a:defRPr>
@@ -3248,7 +3248,7 @@
               </a:spcAft>
               <a:defRPr sz="1300" b="0">
                 <a:solidFill>
-                  <a:srgbClr val="93C5FD"/>
+                  <a:srgbClr val="CFEDFF"/>
                 </a:solidFill>
                 <a:latin typeface="Karla"/>
               </a:defRPr>
@@ -3384,7 +3384,7 @@
             <a:avLst/>
           </a:prstGeom>
           <a:solidFill>
-            <a:srgbClr val="2563EB"/>
+            <a:srgbClr val="006DB0"/>
           </a:solidFill>
           <a:ln>
             <a:noFill/>
@@ -3427,7 +3427,7 @@
             <a:avLst/>
           </a:prstGeom>
           <a:solidFill>
-            <a:srgbClr val="2563EB"/>
+            <a:srgbClr val="006DB0"/>
           </a:solidFill>
           <a:ln>
             <a:noFill/>
@@ -5856,7 +5856,7 @@
             <a:avLst/>
           </a:prstGeom>
           <a:solidFill>
-            <a:srgbClr val="2563EB"/>
+            <a:srgbClr val="006DB0"/>
           </a:solidFill>
           <a:ln>
             <a:noFill/>
@@ -5899,7 +5899,7 @@
             <a:avLst/>
           </a:prstGeom>
           <a:solidFill>
-            <a:srgbClr val="2563EB"/>
+            <a:srgbClr val="006DB0"/>
           </a:solidFill>
           <a:ln>
             <a:noFill/>
@@ -6000,7 +6000,7 @@
               </a:spcAft>
               <a:defRPr sz="1100" b="0">
                 <a:solidFill>
-                  <a:srgbClr val="DBEAFE"/>
+                  <a:srgbClr val="CFEDFF"/>
                 </a:solidFill>
                 <a:latin typeface="Karla"/>
               </a:defRPr>
@@ -6184,7 +6184,7 @@
             <a:avLst/>
           </a:prstGeom>
           <a:solidFill>
-            <a:srgbClr val="3B82F6"/>
+            <a:srgbClr val="006DB0"/>
           </a:solidFill>
           <a:ln>
             <a:noFill/>
@@ -6285,7 +6285,7 @@
               </a:spcAft>
               <a:defRPr sz="1100" b="0">
                 <a:solidFill>
-                  <a:srgbClr val="DBEAFE"/>
+                  <a:srgbClr val="CFEDFF"/>
                 </a:solidFill>
                 <a:latin typeface="Karla"/>
               </a:defRPr>
@@ -6469,7 +6469,7 @@
             <a:avLst/>
           </a:prstGeom>
           <a:solidFill>
-            <a:srgbClr val="1D4ED8"/>
+            <a:srgbClr val="006DB0"/>
           </a:solidFill>
           <a:ln>
             <a:noFill/>
@@ -6570,7 +6570,7 @@
               </a:spcAft>
               <a:defRPr sz="1100" b="0">
                 <a:solidFill>
-                  <a:srgbClr val="DBEAFE"/>
+                  <a:srgbClr val="CFEDFF"/>
                 </a:solidFill>
                 <a:latin typeface="Karla"/>
               </a:defRPr>
@@ -6906,7 +6906,7 @@
             <a:avLst/>
           </a:prstGeom>
           <a:solidFill>
-            <a:srgbClr val="2563EB"/>
+            <a:srgbClr val="006DB0"/>
           </a:solidFill>
           <a:ln>
             <a:noFill/>
@@ -6949,7 +6949,7 @@
             <a:avLst/>
           </a:prstGeom>
           <a:solidFill>
-            <a:srgbClr val="2563EB"/>
+            <a:srgbClr val="006DB0"/>
           </a:solidFill>
           <a:ln>
             <a:noFill/>
@@ -7796,7 +7796,7 @@
             <a:avLst/>
           </a:prstGeom>
           <a:solidFill>
-            <a:srgbClr val="2563EB"/>
+            <a:srgbClr val="006DB0"/>
           </a:solidFill>
           <a:ln>
             <a:noFill/>
@@ -9573,7 +9573,7 @@
     <p:bg>
       <p:bgPr>
         <a:solidFill>
-          <a:srgbClr val="2563EB"/>
+          <a:srgbClr val="006DB0"/>
         </a:solidFill>
         <a:effectLst/>
       </p:bgPr>
@@ -9642,7 +9642,7 @@
             <a:avLst/>
           </a:prstGeom>
           <a:solidFill>
-            <a:srgbClr val="1D4ED8"/>
+            <a:srgbClr val="005789"/>
           </a:solidFill>
           <a:ln>
             <a:noFill/>
@@ -9743,7 +9743,7 @@
               </a:spcAft>
               <a:defRPr sz="1200" b="0">
                 <a:solidFill>
-                  <a:srgbClr val="DBEAFE"/>
+                  <a:srgbClr val="CFEDFF"/>
                 </a:solidFill>
                 <a:latin typeface="Karla"/>
               </a:defRPr>
@@ -9769,7 +9769,7 @@
             <a:avLst/>
           </a:prstGeom>
           <a:solidFill>
-            <a:srgbClr val="1D4ED8"/>
+            <a:srgbClr val="005789"/>
           </a:solidFill>
           <a:ln>
             <a:noFill/>
@@ -9870,7 +9870,7 @@
               </a:spcAft>
               <a:defRPr sz="1200" b="0">
                 <a:solidFill>
-                  <a:srgbClr val="DBEAFE"/>
+                  <a:srgbClr val="CFEDFF"/>
                 </a:solidFill>
                 <a:latin typeface="Karla"/>
               </a:defRPr>
@@ -9896,7 +9896,7 @@
             <a:avLst/>
           </a:prstGeom>
           <a:solidFill>
-            <a:srgbClr val="1D4ED8"/>
+            <a:srgbClr val="005789"/>
           </a:solidFill>
           <a:ln>
             <a:noFill/>
@@ -9997,7 +9997,7 @@
               </a:spcAft>
               <a:defRPr sz="1200" b="0">
                 <a:solidFill>
-                  <a:srgbClr val="DBEAFE"/>
+                  <a:srgbClr val="CFEDFF"/>
                 </a:solidFill>
                 <a:latin typeface="Karla"/>
               </a:defRPr>
@@ -10023,7 +10023,7 @@
             <a:avLst/>
           </a:prstGeom>
           <a:solidFill>
-            <a:srgbClr val="1D4ED8"/>
+            <a:srgbClr val="005789"/>
           </a:solidFill>
           <a:ln>
             <a:noFill/>
@@ -10124,7 +10124,7 @@
               </a:spcAft>
               <a:defRPr sz="1200" b="0">
                 <a:solidFill>
-                  <a:srgbClr val="DBEAFE"/>
+                  <a:srgbClr val="CFEDFF"/>
                 </a:solidFill>
                 <a:latin typeface="Karla"/>
               </a:defRPr>
@@ -10150,7 +10150,7 @@
             <a:avLst/>
           </a:prstGeom>
           <a:solidFill>
-            <a:srgbClr val="1D4ED8"/>
+            <a:srgbClr val="005789"/>
           </a:solidFill>
           <a:ln>
             <a:noFill/>
@@ -10251,7 +10251,7 @@
               </a:spcAft>
               <a:defRPr sz="1200" b="0">
                 <a:solidFill>
-                  <a:srgbClr val="DBEAFE"/>
+                  <a:srgbClr val="CFEDFF"/>
                 </a:solidFill>
                 <a:latin typeface="Karla"/>
               </a:defRPr>
@@ -10277,7 +10277,7 @@
             <a:avLst/>
           </a:prstGeom>
           <a:solidFill>
-            <a:srgbClr val="1D4ED8"/>
+            <a:srgbClr val="005789"/>
           </a:solidFill>
           <a:ln>
             <a:noFill/>
@@ -10378,7 +10378,7 @@
               </a:spcAft>
               <a:defRPr sz="1200" b="0">
                 <a:solidFill>
-                  <a:srgbClr val="DBEAFE"/>
+                  <a:srgbClr val="CFEDFF"/>
                 </a:solidFill>
                 <a:latin typeface="Karla"/>
               </a:defRPr>
@@ -10514,7 +10514,7 @@
             <a:avLst/>
           </a:prstGeom>
           <a:solidFill>
-            <a:srgbClr val="2563EB"/>
+            <a:srgbClr val="006DB0"/>
           </a:solidFill>
           <a:ln>
             <a:noFill/>
@@ -10573,7 +10573,7 @@
               </a:spcAft>
               <a:defRPr sz="3200" b="1">
                 <a:solidFill>
-                  <a:srgbClr val="2563EB"/>
+                  <a:srgbClr val="006DB0"/>
                 </a:solidFill>
                 <a:latin typeface="Fredoka"/>
               </a:defRPr>
@@ -10618,7 +10618,7 @@
             <a:avLst/>
           </a:prstGeom>
           <a:solidFill>
-            <a:srgbClr val="2563EB"/>
+            <a:srgbClr val="006DB0"/>
           </a:solidFill>
           <a:ln>
             <a:noFill/>
@@ -10693,7 +10693,7 @@
               </a:spcAft>
               <a:defRPr sz="1400" b="1">
                 <a:solidFill>
-                  <a:srgbClr val="1D4ED8"/>
+                  <a:srgbClr val="006DB0"/>
                 </a:solidFill>
                 <a:latin typeface="Fredoka"/>
               </a:defRPr>
@@ -10761,7 +10761,7 @@
             <a:avLst/>
           </a:prstGeom>
           <a:solidFill>
-            <a:srgbClr val="2563EB"/>
+            <a:srgbClr val="006DB0"/>
           </a:solidFill>
           <a:ln>
             <a:noFill/>
@@ -10836,7 +10836,7 @@
               </a:spcAft>
               <a:defRPr sz="1400" b="1">
                 <a:solidFill>
-                  <a:srgbClr val="1D4ED8"/>
+                  <a:srgbClr val="006DB0"/>
                 </a:solidFill>
                 <a:latin typeface="Fredoka"/>
               </a:defRPr>
@@ -10904,7 +10904,7 @@
             <a:avLst/>
           </a:prstGeom>
           <a:solidFill>
-            <a:srgbClr val="2563EB"/>
+            <a:srgbClr val="006DB0"/>
           </a:solidFill>
           <a:ln>
             <a:noFill/>
@@ -10979,7 +10979,7 @@
               </a:spcAft>
               <a:defRPr sz="1400" b="1">
                 <a:solidFill>
-                  <a:srgbClr val="1D4ED8"/>
+                  <a:srgbClr val="006DB0"/>
                 </a:solidFill>
                 <a:latin typeface="Fredoka"/>
               </a:defRPr>
@@ -11047,7 +11047,7 @@
             <a:avLst/>
           </a:prstGeom>
           <a:solidFill>
-            <a:srgbClr val="2563EB"/>
+            <a:srgbClr val="006DB0"/>
           </a:solidFill>
           <a:ln>
             <a:noFill/>
@@ -11122,7 +11122,7 @@
               </a:spcAft>
               <a:defRPr sz="1400" b="1">
                 <a:solidFill>
-                  <a:srgbClr val="1D4ED8"/>
+                  <a:srgbClr val="006DB0"/>
                 </a:solidFill>
                 <a:latin typeface="Fredoka"/>
               </a:defRPr>
@@ -11273,7 +11273,7 @@
     <p:bg>
       <p:bgPr>
         <a:solidFill>
-          <a:srgbClr val="2563EB"/>
+          <a:srgbClr val="006DB0"/>
         </a:solidFill>
         <a:effectLst/>
       </p:bgPr>
@@ -11335,7 +11335,7 @@
               </a:spcAft>
               <a:defRPr sz="2400" b="0">
                 <a:solidFill>
-                  <a:srgbClr val="DBEAFE"/>
+                  <a:srgbClr val="CFEDFF"/>
                 </a:solidFill>
                 <a:latin typeface="Fredoka"/>
               </a:defRPr>
@@ -11396,7 +11396,7 @@
               </a:spcAft>
               <a:defRPr sz="1400" b="0">
                 <a:solidFill>
-                  <a:srgbClr val="DBEAFE"/>
+                  <a:srgbClr val="CFEDFF"/>
                 </a:solidFill>
                 <a:latin typeface="Karla"/>
               </a:defRPr>
@@ -11415,7 +11415,7 @@
               </a:spcAft>
               <a:defRPr sz="1400" b="0">
                 <a:solidFill>
-                  <a:srgbClr val="DBEAFE"/>
+                  <a:srgbClr val="CFEDFF"/>
                 </a:solidFill>
                 <a:latin typeface="Karla"/>
               </a:defRPr>
@@ -11434,7 +11434,7 @@
               </a:spcAft>
               <a:defRPr sz="1400" b="0">
                 <a:solidFill>
-                  <a:srgbClr val="DBEAFE"/>
+                  <a:srgbClr val="CFEDFF"/>
                 </a:solidFill>
                 <a:latin typeface="Karla"/>
               </a:defRPr>
@@ -11453,7 +11453,7 @@
               </a:spcAft>
               <a:defRPr sz="1400" b="0">
                 <a:solidFill>
-                  <a:srgbClr val="DBEAFE"/>
+                  <a:srgbClr val="CFEDFF"/>
                 </a:solidFill>
                 <a:latin typeface="Karla"/>
               </a:defRPr>
@@ -11631,7 +11631,7 @@
             <a:avLst/>
           </a:prstGeom>
           <a:solidFill>
-            <a:srgbClr val="2563EB"/>
+            <a:srgbClr val="006DB0"/>
           </a:solidFill>
           <a:ln>
             <a:noFill/>
@@ -11775,7 +11775,7 @@
               </a:spcAft>
               <a:defRPr sz="1500" b="1">
                 <a:solidFill>
-                  <a:srgbClr val="1D4ED8"/>
+                  <a:srgbClr val="006DB0"/>
                 </a:solidFill>
                 <a:latin typeface="Fredoka"/>
               </a:defRPr>
@@ -11902,7 +11902,7 @@
               </a:spcAft>
               <a:defRPr sz="1500" b="1">
                 <a:solidFill>
-                  <a:srgbClr val="1D4ED8"/>
+                  <a:srgbClr val="006DB0"/>
                 </a:solidFill>
                 <a:latin typeface="Fredoka"/>
               </a:defRPr>
@@ -12029,7 +12029,7 @@
               </a:spcAft>
               <a:defRPr sz="1500" b="1">
                 <a:solidFill>
-                  <a:srgbClr val="1D4ED8"/>
+                  <a:srgbClr val="006DB0"/>
                 </a:solidFill>
                 <a:latin typeface="Fredoka"/>
               </a:defRPr>
@@ -12156,7 +12156,7 @@
               </a:spcAft>
               <a:defRPr sz="1500" b="1">
                 <a:solidFill>
-                  <a:srgbClr val="1D4ED8"/>
+                  <a:srgbClr val="006DB0"/>
                 </a:solidFill>
                 <a:latin typeface="Fredoka"/>
               </a:defRPr>
@@ -12376,7 +12376,7 @@
             <a:avLst/>
           </a:prstGeom>
           <a:solidFill>
-            <a:srgbClr val="2563EB"/>
+            <a:srgbClr val="006DB0"/>
           </a:solidFill>
           <a:ln>
             <a:noFill/>
@@ -12461,7 +12461,7 @@
             <a:avLst/>
           </a:prstGeom>
           <a:solidFill>
-            <a:srgbClr val="EFF6FF"/>
+            <a:srgbClr val="E9F8FF"/>
           </a:solidFill>
           <a:ln>
             <a:noFill/>
@@ -12504,7 +12504,7 @@
             <a:avLst/>
           </a:prstGeom>
           <a:solidFill>
-            <a:srgbClr val="2563EB"/>
+            <a:srgbClr val="006DB0"/>
           </a:solidFill>
           <a:ln>
             <a:noFill/>
@@ -12579,7 +12579,7 @@
               </a:spcAft>
               <a:defRPr sz="1800" b="1">
                 <a:solidFill>
-                  <a:srgbClr val="1D4ED8"/>
+                  <a:srgbClr val="006DB0"/>
                 </a:solidFill>
                 <a:latin typeface="Fredoka"/>
               </a:defRPr>
@@ -12647,7 +12647,7 @@
             <a:avLst/>
           </a:prstGeom>
           <a:solidFill>
-            <a:srgbClr val="EFF6FF"/>
+            <a:srgbClr val="E9F8FF"/>
           </a:solidFill>
           <a:ln>
             <a:noFill/>
@@ -12690,7 +12690,7 @@
             <a:avLst/>
           </a:prstGeom>
           <a:solidFill>
-            <a:srgbClr val="2563EB"/>
+            <a:srgbClr val="006DB0"/>
           </a:solidFill>
           <a:ln>
             <a:noFill/>
@@ -12765,7 +12765,7 @@
               </a:spcAft>
               <a:defRPr sz="1800" b="1">
                 <a:solidFill>
-                  <a:srgbClr val="1D4ED8"/>
+                  <a:srgbClr val="006DB0"/>
                 </a:solidFill>
                 <a:latin typeface="Fredoka"/>
               </a:defRPr>
@@ -12833,7 +12833,7 @@
             <a:avLst/>
           </a:prstGeom>
           <a:solidFill>
-            <a:srgbClr val="EFF6FF"/>
+            <a:srgbClr val="E9F8FF"/>
           </a:solidFill>
           <a:ln>
             <a:noFill/>
@@ -12876,7 +12876,7 @@
             <a:avLst/>
           </a:prstGeom>
           <a:solidFill>
-            <a:srgbClr val="2563EB"/>
+            <a:srgbClr val="006DB0"/>
           </a:solidFill>
           <a:ln>
             <a:noFill/>
@@ -12951,7 +12951,7 @@
               </a:spcAft>
               <a:defRPr sz="1800" b="1">
                 <a:solidFill>
-                  <a:srgbClr val="1D4ED8"/>
+                  <a:srgbClr val="006DB0"/>
                 </a:solidFill>
                 <a:latin typeface="Fredoka"/>
               </a:defRPr>
@@ -13213,7 +13213,7 @@
             <a:avLst/>
           </a:prstGeom>
           <a:solidFill>
-            <a:srgbClr val="2563EB"/>
+            <a:srgbClr val="006DB0"/>
           </a:solidFill>
           <a:ln>
             <a:noFill/>
@@ -13357,7 +13357,7 @@
               </a:spcAft>
               <a:defRPr sz="4200" b="1">
                 <a:solidFill>
-                  <a:srgbClr val="2563EB"/>
+                  <a:srgbClr val="006DB0"/>
                 </a:solidFill>
                 <a:latin typeface="Fredoka"/>
               </a:defRPr>
@@ -13526,7 +13526,7 @@
               </a:spcAft>
               <a:defRPr sz="4200" b="1">
                 <a:solidFill>
-                  <a:srgbClr val="2563EB"/>
+                  <a:srgbClr val="006DB0"/>
                 </a:solidFill>
                 <a:latin typeface="Fredoka"/>
               </a:defRPr>
@@ -13695,7 +13695,7 @@
               </a:spcAft>
               <a:defRPr sz="4200" b="1">
                 <a:solidFill>
-                  <a:srgbClr val="2563EB"/>
+                  <a:srgbClr val="006DB0"/>
                 </a:solidFill>
                 <a:latin typeface="Fredoka"/>
               </a:defRPr>
@@ -13763,7 +13763,7 @@
             <a:avLst/>
           </a:prstGeom>
           <a:solidFill>
-            <a:srgbClr val="EFF6FF"/>
+            <a:srgbClr val="E9F8FF"/>
           </a:solidFill>
           <a:ln>
             <a:noFill/>
@@ -13822,7 +13822,7 @@
               </a:spcAft>
               <a:defRPr sz="2800" b="1">
                 <a:solidFill>
-                  <a:srgbClr val="2563EB"/>
+                  <a:srgbClr val="006DB0"/>
                 </a:solidFill>
                 <a:latin typeface="Fredoka"/>
               </a:defRPr>
@@ -13890,7 +13890,7 @@
             <a:avLst/>
           </a:prstGeom>
           <a:solidFill>
-            <a:srgbClr val="EFF6FF"/>
+            <a:srgbClr val="E9F8FF"/>
           </a:solidFill>
           <a:ln>
             <a:noFill/>
@@ -13949,7 +13949,7 @@
               </a:spcAft>
               <a:defRPr sz="2800" b="1">
                 <a:solidFill>
-                  <a:srgbClr val="2563EB"/>
+                  <a:srgbClr val="006DB0"/>
                 </a:solidFill>
                 <a:latin typeface="Fredoka"/>
               </a:defRPr>
@@ -14017,7 +14017,7 @@
             <a:avLst/>
           </a:prstGeom>
           <a:solidFill>
-            <a:srgbClr val="EFF6FF"/>
+            <a:srgbClr val="E9F8FF"/>
           </a:solidFill>
           <a:ln>
             <a:noFill/>
@@ -14076,7 +14076,7 @@
               </a:spcAft>
               <a:defRPr sz="2800" b="1">
                 <a:solidFill>
-                  <a:srgbClr val="2563EB"/>
+                  <a:srgbClr val="006DB0"/>
                 </a:solidFill>
                 <a:latin typeface="Fredoka"/>
               </a:defRPr>
@@ -14144,7 +14144,7 @@
             <a:avLst/>
           </a:prstGeom>
           <a:solidFill>
-            <a:srgbClr val="EFF6FF"/>
+            <a:srgbClr val="E9F8FF"/>
           </a:solidFill>
           <a:ln>
             <a:noFill/>
@@ -14203,7 +14203,7 @@
               </a:spcAft>
               <a:defRPr sz="2800" b="1">
                 <a:solidFill>
-                  <a:srgbClr val="2563EB"/>
+                  <a:srgbClr val="006DB0"/>
                 </a:solidFill>
                 <a:latin typeface="Fredoka"/>
               </a:defRPr>
@@ -14423,7 +14423,7 @@
             <a:avLst/>
           </a:prstGeom>
           <a:solidFill>
-            <a:srgbClr val="2563EB"/>
+            <a:srgbClr val="006DB0"/>
           </a:solidFill>
           <a:ln>
             <a:noFill/>
@@ -14466,7 +14466,7 @@
             <a:avLst/>
           </a:prstGeom>
           <a:solidFill>
-            <a:srgbClr val="2563EB"/>
+            <a:srgbClr val="006DB0"/>
           </a:solidFill>
           <a:ln>
             <a:noFill/>
@@ -14609,7 +14609,7 @@
             <a:avLst/>
           </a:prstGeom>
           <a:solidFill>
-            <a:srgbClr val="2563EB"/>
+            <a:srgbClr val="006DB0"/>
           </a:solidFill>
           <a:ln>
             <a:noFill/>
@@ -14752,7 +14752,7 @@
             <a:avLst/>
           </a:prstGeom>
           <a:solidFill>
-            <a:srgbClr val="2563EB"/>
+            <a:srgbClr val="006DB0"/>
           </a:solidFill>
           <a:ln>
             <a:noFill/>
@@ -14895,7 +14895,7 @@
             <a:avLst/>
           </a:prstGeom>
           <a:solidFill>
-            <a:srgbClr val="2563EB"/>
+            <a:srgbClr val="006DB0"/>
           </a:solidFill>
           <a:ln>
             <a:noFill/>
@@ -15038,7 +15038,7 @@
             <a:avLst/>
           </a:prstGeom>
           <a:solidFill>
-            <a:srgbClr val="2563EB"/>
+            <a:srgbClr val="006DB0"/>
           </a:solidFill>
           <a:ln>
             <a:noFill/>
@@ -15181,7 +15181,7 @@
             <a:avLst/>
           </a:prstGeom>
           <a:solidFill>
-            <a:srgbClr val="2563EB"/>
+            <a:srgbClr val="006DB0"/>
           </a:solidFill>
           <a:ln>
             <a:noFill/>
@@ -15476,7 +15476,7 @@
             <a:avLst/>
           </a:prstGeom>
           <a:solidFill>
-            <a:srgbClr val="2563EB"/>
+            <a:srgbClr val="006DB0"/>
           </a:solidFill>
           <a:ln>
             <a:noFill/>
@@ -15620,7 +15620,7 @@
               </a:spcAft>
               <a:defRPr sz="1400" b="1">
                 <a:solidFill>
-                  <a:srgbClr val="1D4ED8"/>
+                  <a:srgbClr val="006DB0"/>
                 </a:solidFill>
                 <a:latin typeface="Fredoka"/>
               </a:defRPr>
@@ -15662,7 +15662,7 @@
               </a:spcAft>
               <a:defRPr sz="1300" b="1">
                 <a:solidFill>
-                  <a:srgbClr val="2563EB"/>
+                  <a:srgbClr val="006DB0"/>
                 </a:solidFill>
                 <a:latin typeface="JetBrains Mono"/>
               </a:defRPr>
@@ -15793,7 +15793,7 @@
               </a:spcAft>
               <a:defRPr sz="1400" b="1">
                 <a:solidFill>
-                  <a:srgbClr val="1D4ED8"/>
+                  <a:srgbClr val="006DB0"/>
                 </a:solidFill>
                 <a:latin typeface="Fredoka"/>
               </a:defRPr>
@@ -15835,7 +15835,7 @@
               </a:spcAft>
               <a:defRPr sz="1300" b="1">
                 <a:solidFill>
-                  <a:srgbClr val="2563EB"/>
+                  <a:srgbClr val="006DB0"/>
                 </a:solidFill>
                 <a:latin typeface="JetBrains Mono"/>
               </a:defRPr>
@@ -15966,7 +15966,7 @@
               </a:spcAft>
               <a:defRPr sz="1400" b="1">
                 <a:solidFill>
-                  <a:srgbClr val="1D4ED8"/>
+                  <a:srgbClr val="006DB0"/>
                 </a:solidFill>
                 <a:latin typeface="Fredoka"/>
               </a:defRPr>
@@ -16008,7 +16008,7 @@
               </a:spcAft>
               <a:defRPr sz="1300" b="1">
                 <a:solidFill>
-                  <a:srgbClr val="2563EB"/>
+                  <a:srgbClr val="006DB0"/>
                 </a:solidFill>
                 <a:latin typeface="JetBrains Mono"/>
               </a:defRPr>
@@ -16139,7 +16139,7 @@
               </a:spcAft>
               <a:defRPr sz="1400" b="1">
                 <a:solidFill>
-                  <a:srgbClr val="1D4ED8"/>
+                  <a:srgbClr val="006DB0"/>
                 </a:solidFill>
                 <a:latin typeface="Fredoka"/>
               </a:defRPr>
@@ -16181,7 +16181,7 @@
               </a:spcAft>
               <a:defRPr sz="1300" b="1">
                 <a:solidFill>
-                  <a:srgbClr val="2563EB"/>
+                  <a:srgbClr val="006DB0"/>
                 </a:solidFill>
                 <a:latin typeface="JetBrains Mono"/>
               </a:defRPr>
@@ -16253,7 +16253,7 @@
             <a:avLst/>
           </a:prstGeom>
           <a:solidFill>
-            <a:srgbClr val="EFF6FF"/>
+            <a:srgbClr val="E9F8FF"/>
           </a:solidFill>
           <a:ln>
             <a:noFill/>
@@ -16312,7 +16312,7 @@
               </a:spcAft>
               <a:defRPr sz="1100" b="0">
                 <a:solidFill>
-                  <a:srgbClr val="1D4ED8"/>
+                  <a:srgbClr val="006DB0"/>
                 </a:solidFill>
                 <a:latin typeface="Karla"/>
               </a:defRPr>
@@ -16490,7 +16490,7 @@
             <a:avLst/>
           </a:prstGeom>
           <a:solidFill>
-            <a:srgbClr val="2563EB"/>
+            <a:srgbClr val="006DB0"/>
           </a:solidFill>
           <a:ln>
             <a:noFill/>
@@ -16549,7 +16549,7 @@
               </a:spcAft>
               <a:defRPr sz="1400" b="1">
                 <a:solidFill>
-                  <a:srgbClr val="3B82F6"/>
+                  <a:srgbClr val="A8DCFC"/>
                 </a:solidFill>
                 <a:latin typeface="Fredoka"/>
               </a:defRPr>
@@ -16782,7 +16782,7 @@
               </a:spcAft>
               <a:defRPr sz="1400" b="1">
                 <a:solidFill>
-                  <a:srgbClr val="3B82F6"/>
+                  <a:srgbClr val="A8DCFC"/>
                 </a:solidFill>
                 <a:latin typeface="Fredoka"/>
               </a:defRPr>
@@ -17198,7 +17198,7 @@
             <a:avLst/>
           </a:prstGeom>
           <a:solidFill>
-            <a:srgbClr val="2563EB"/>
+            <a:srgbClr val="006DB0"/>
           </a:solidFill>
           <a:ln>
             <a:noFill/>
@@ -17342,7 +17342,7 @@
               </a:spcAft>
               <a:defRPr sz="1400" b="1">
                 <a:solidFill>
-                  <a:srgbClr val="1D4ED8"/>
+                  <a:srgbClr val="006DB0"/>
                 </a:solidFill>
                 <a:latin typeface="Fredoka"/>
               </a:defRPr>
@@ -17477,7 +17477,7 @@
               </a:spcAft>
               <a:defRPr sz="1400" b="1">
                 <a:solidFill>
-                  <a:srgbClr val="1D4ED8"/>
+                  <a:srgbClr val="006DB0"/>
                 </a:solidFill>
                 <a:latin typeface="Fredoka"/>
               </a:defRPr>
@@ -17608,7 +17608,7 @@
               </a:spcAft>
               <a:defRPr sz="1400" b="1">
                 <a:solidFill>
-                  <a:srgbClr val="1D4ED8"/>
+                  <a:srgbClr val="006DB0"/>
                 </a:solidFill>
                 <a:latin typeface="Fredoka"/>
               </a:defRPr>
@@ -17739,7 +17739,7 @@
               </a:spcAft>
               <a:defRPr sz="1400" b="1">
                 <a:solidFill>
-                  <a:srgbClr val="1D4ED8"/>
+                  <a:srgbClr val="006DB0"/>
                 </a:solidFill>
                 <a:latin typeface="Fredoka"/>
               </a:defRPr>
@@ -17870,7 +17870,7 @@
               </a:spcAft>
               <a:defRPr sz="1400" b="1">
                 <a:solidFill>
-                  <a:srgbClr val="1D4ED8"/>
+                  <a:srgbClr val="006DB0"/>
                 </a:solidFill>
                 <a:latin typeface="Fredoka"/>
               </a:defRPr>
@@ -18094,7 +18094,7 @@
             <a:avLst/>
           </a:prstGeom>
           <a:solidFill>
-            <a:srgbClr val="2563EB"/>
+            <a:srgbClr val="006DB0"/>
           </a:solidFill>
           <a:ln>
             <a:noFill/>
@@ -18238,7 +18238,7 @@
               </a:spcAft>
               <a:defRPr sz="1400" b="1">
                 <a:solidFill>
-                  <a:srgbClr val="1D4ED8"/>
+                  <a:srgbClr val="006DB0"/>
                 </a:solidFill>
                 <a:latin typeface="Fredoka"/>
               </a:defRPr>
@@ -18365,7 +18365,7 @@
               </a:spcAft>
               <a:defRPr sz="1400" b="1">
                 <a:solidFill>
-                  <a:srgbClr val="1D4ED8"/>
+                  <a:srgbClr val="006DB0"/>
                 </a:solidFill>
                 <a:latin typeface="Fredoka"/>
               </a:defRPr>
@@ -18492,7 +18492,7 @@
               </a:spcAft>
               <a:defRPr sz="1400" b="1">
                 <a:solidFill>
-                  <a:srgbClr val="1D4ED8"/>
+                  <a:srgbClr val="006DB0"/>
                 </a:solidFill>
                 <a:latin typeface="Fredoka"/>
               </a:defRPr>
@@ -18619,7 +18619,7 @@
               </a:spcAft>
               <a:defRPr sz="1400" b="1">
                 <a:solidFill>
-                  <a:srgbClr val="1D4ED8"/>
+                  <a:srgbClr val="006DB0"/>
                 </a:solidFill>
                 <a:latin typeface="Fredoka"/>
               </a:defRPr>
@@ -18746,7 +18746,7 @@
               </a:spcAft>
               <a:defRPr sz="1400" b="1">
                 <a:solidFill>
-                  <a:srgbClr val="1D4ED8"/>
+                  <a:srgbClr val="006DB0"/>
                 </a:solidFill>
                 <a:latin typeface="Fredoka"/>
               </a:defRPr>
@@ -18873,7 +18873,7 @@
               </a:spcAft>
               <a:defRPr sz="1400" b="1">
                 <a:solidFill>
-                  <a:srgbClr val="1D4ED8"/>
+                  <a:srgbClr val="006DB0"/>
                 </a:solidFill>
                 <a:latin typeface="Fredoka"/>
               </a:defRPr>

</xml_diff>

<commit_message>
docs(pitch-deck): spell out all initials in full (TAM, SAM, SOM, GMV, KYC, GPS, BFF, etc.)
</commit_message>
<xml_diff>
--- a/Drop_Pitch_Deck.pptx
+++ b/Drop_Pitch_Deck.pptx
@@ -3745,7 +3745,7 @@
               </a:defRPr>
             </a:pPr>
             <a:r>
-              <a:t>Real-time GPS tracking</a:t>
+              <a:t>Real-time GPS (Global Positioning System) tracking</a:t>
             </a:r>
           </a:p>
         </p:txBody>
@@ -6411,7 +6411,7 @@
               </a:defRPr>
             </a:pPr>
             <a:r>
-              <a:t>▸  Wholesale (B2B) channel launch</a:t>
+              <a:t>▸  Wholesale (Business-to-Business) launch</a:t>
             </a:r>
           </a:p>
           <a:p>
@@ -6715,7 +6715,7 @@
               </a:defRPr>
             </a:pPr>
             <a:r>
-              <a:t>▸  East Africa expansion (UG, TZ)</a:t>
+              <a:t>▸  East Africa expansion (Uganda &amp; Tanzania)</a:t>
             </a:r>
           </a:p>
           <a:p>
@@ -7070,8 +7070,8 @@
         </p:nvSpPr>
         <p:spPr>
           <a:xfrm>
-            <a:off x="1005840" y="2468880"/>
-            <a:ext cx="1645920" cy="411480"/>
+            <a:off x="914400" y="2450592"/>
+            <a:ext cx="1737360" cy="457200"/>
           </a:xfrm>
           <a:prstGeom prst="rect">
             <a:avLst/>
@@ -7086,7 +7086,7 @@
           <a:p>
             <a:pPr algn="l">
               <a:lnSpc>
-                <a:spcPts val="1439"/>
+                <a:spcPts val="1320"/>
               </a:lnSpc>
               <a:spcAft>
                 <a:spcPts val="0"/>
@@ -7112,8 +7112,8 @@
         </p:nvSpPr>
         <p:spPr>
           <a:xfrm>
-            <a:off x="2377440" y="2468880"/>
-            <a:ext cx="1463040" cy="411480"/>
+            <a:off x="2468880" y="2468880"/>
+            <a:ext cx="1371600" cy="411480"/>
           </a:xfrm>
           <a:prstGeom prst="rect">
             <a:avLst/>
@@ -7197,8 +7197,8 @@
         </p:nvSpPr>
         <p:spPr>
           <a:xfrm>
-            <a:off x="1005840" y="3108960"/>
-            <a:ext cx="1645920" cy="411480"/>
+            <a:off x="914400" y="3090672"/>
+            <a:ext cx="2011680" cy="457200"/>
           </a:xfrm>
           <a:prstGeom prst="rect">
             <a:avLst/>
@@ -7213,12 +7213,12 @@
           <a:p>
             <a:pPr algn="l">
               <a:lnSpc>
-                <a:spcPts val="1439"/>
-              </a:lnSpc>
-              <a:spcAft>
-                <a:spcPts val="0"/>
-              </a:spcAft>
-              <a:defRPr sz="1200" b="0">
+                <a:spcPts val="1100"/>
+              </a:lnSpc>
+              <a:spcAft>
+                <a:spcPts val="0"/>
+              </a:spcAft>
+              <a:defRPr sz="1000" b="0">
                 <a:solidFill>
                   <a:srgbClr val="64748B"/>
                 </a:solidFill>
@@ -7226,7 +7226,7 @@
               </a:defRPr>
             </a:pPr>
             <a:r>
-              <a:t>GMV</a:t>
+              <a:t>Gross Merchandise Value (GMV)</a:t>
             </a:r>
           </a:p>
         </p:txBody>
@@ -7239,8 +7239,8 @@
         </p:nvSpPr>
         <p:spPr>
           <a:xfrm>
-            <a:off x="2377440" y="3108960"/>
-            <a:ext cx="1463040" cy="411480"/>
+            <a:off x="2743200" y="3108960"/>
+            <a:ext cx="1188720" cy="411480"/>
           </a:xfrm>
           <a:prstGeom prst="rect">
             <a:avLst/>
@@ -7324,8 +7324,8 @@
         </p:nvSpPr>
         <p:spPr>
           <a:xfrm>
-            <a:off x="1005840" y="3749040"/>
-            <a:ext cx="1645920" cy="411480"/>
+            <a:off x="914400" y="3730752"/>
+            <a:ext cx="1737360" cy="457200"/>
           </a:xfrm>
           <a:prstGeom prst="rect">
             <a:avLst/>
@@ -7340,7 +7340,7 @@
           <a:p>
             <a:pPr algn="l">
               <a:lnSpc>
-                <a:spcPts val="1439"/>
+                <a:spcPts val="1320"/>
               </a:lnSpc>
               <a:spcAft>
                 <a:spcPts val="0"/>
@@ -7366,8 +7366,8 @@
         </p:nvSpPr>
         <p:spPr>
           <a:xfrm>
-            <a:off x="2377440" y="3749040"/>
-            <a:ext cx="1463040" cy="411480"/>
+            <a:off x="2468880" y="3749040"/>
+            <a:ext cx="1371600" cy="411480"/>
           </a:xfrm>
           <a:prstGeom prst="rect">
             <a:avLst/>
@@ -7451,8 +7451,8 @@
         </p:nvSpPr>
         <p:spPr>
           <a:xfrm>
-            <a:off x="1005840" y="4389119"/>
-            <a:ext cx="1645920" cy="411480"/>
+            <a:off x="914400" y="4370831"/>
+            <a:ext cx="1737360" cy="457200"/>
           </a:xfrm>
           <a:prstGeom prst="rect">
             <a:avLst/>
@@ -7467,7 +7467,7 @@
           <a:p>
             <a:pPr algn="l">
               <a:lnSpc>
-                <a:spcPts val="1439"/>
+                <a:spcPts val="1320"/>
               </a:lnSpc>
               <a:spcAft>
                 <a:spcPts val="0"/>
@@ -7493,8 +7493,8 @@
         </p:nvSpPr>
         <p:spPr>
           <a:xfrm>
-            <a:off x="2377440" y="4389119"/>
-            <a:ext cx="1463040" cy="411480"/>
+            <a:off x="2468880" y="4389119"/>
+            <a:ext cx="1371600" cy="411480"/>
           </a:xfrm>
           <a:prstGeom prst="rect">
             <a:avLst/>
@@ -7578,8 +7578,8 @@
         </p:nvSpPr>
         <p:spPr>
           <a:xfrm>
-            <a:off x="1005840" y="5029200"/>
-            <a:ext cx="1645920" cy="411480"/>
+            <a:off x="914400" y="5010912"/>
+            <a:ext cx="1737360" cy="457200"/>
           </a:xfrm>
           <a:prstGeom prst="rect">
             <a:avLst/>
@@ -7594,7 +7594,7 @@
           <a:p>
             <a:pPr algn="l">
               <a:lnSpc>
-                <a:spcPts val="1439"/>
+                <a:spcPts val="1320"/>
               </a:lnSpc>
               <a:spcAft>
                 <a:spcPts val="0"/>
@@ -7620,8 +7620,8 @@
         </p:nvSpPr>
         <p:spPr>
           <a:xfrm>
-            <a:off x="2377440" y="5029200"/>
-            <a:ext cx="1463040" cy="411480"/>
+            <a:off x="2468880" y="5029200"/>
+            <a:ext cx="1371600" cy="411480"/>
           </a:xfrm>
           <a:prstGeom prst="rect">
             <a:avLst/>
@@ -7705,8 +7705,8 @@
         </p:nvSpPr>
         <p:spPr>
           <a:xfrm>
-            <a:off x="1005840" y="5669280"/>
-            <a:ext cx="1645920" cy="411480"/>
+            <a:off x="914400" y="5650992"/>
+            <a:ext cx="1737360" cy="457200"/>
           </a:xfrm>
           <a:prstGeom prst="rect">
             <a:avLst/>
@@ -7721,7 +7721,7 @@
           <a:p>
             <a:pPr algn="l">
               <a:lnSpc>
-                <a:spcPts val="1439"/>
+                <a:spcPts val="1320"/>
               </a:lnSpc>
               <a:spcAft>
                 <a:spcPts val="0"/>
@@ -7747,8 +7747,8 @@
         </p:nvSpPr>
         <p:spPr>
           <a:xfrm>
-            <a:off x="2377440" y="5669280"/>
-            <a:ext cx="1463040" cy="411480"/>
+            <a:off x="2468880" y="5669280"/>
+            <a:ext cx="1371600" cy="411480"/>
           </a:xfrm>
           <a:prstGeom prst="rect">
             <a:avLst/>
@@ -7917,8 +7917,8 @@
         </p:nvSpPr>
         <p:spPr>
           <a:xfrm>
-            <a:off x="4663440" y="2468880"/>
-            <a:ext cx="1645920" cy="411480"/>
+            <a:off x="4572000" y="2450592"/>
+            <a:ext cx="1737360" cy="457200"/>
           </a:xfrm>
           <a:prstGeom prst="rect">
             <a:avLst/>
@@ -7933,7 +7933,7 @@
           <a:p>
             <a:pPr algn="l">
               <a:lnSpc>
-                <a:spcPts val="1439"/>
+                <a:spcPts val="1320"/>
               </a:lnSpc>
               <a:spcAft>
                 <a:spcPts val="0"/>
@@ -7959,8 +7959,8 @@
         </p:nvSpPr>
         <p:spPr>
           <a:xfrm>
-            <a:off x="6035040" y="2468880"/>
-            <a:ext cx="1463040" cy="411480"/>
+            <a:off x="6126480" y="2468880"/>
+            <a:ext cx="1371600" cy="411480"/>
           </a:xfrm>
           <a:prstGeom prst="rect">
             <a:avLst/>
@@ -8044,8 +8044,8 @@
         </p:nvSpPr>
         <p:spPr>
           <a:xfrm>
-            <a:off x="4663440" y="3108960"/>
-            <a:ext cx="1645920" cy="411480"/>
+            <a:off x="4572000" y="3090672"/>
+            <a:ext cx="2011680" cy="457200"/>
           </a:xfrm>
           <a:prstGeom prst="rect">
             <a:avLst/>
@@ -8060,12 +8060,12 @@
           <a:p>
             <a:pPr algn="l">
               <a:lnSpc>
-                <a:spcPts val="1439"/>
-              </a:lnSpc>
-              <a:spcAft>
-                <a:spcPts val="0"/>
-              </a:spcAft>
-              <a:defRPr sz="1200" b="0">
+                <a:spcPts val="1100"/>
+              </a:lnSpc>
+              <a:spcAft>
+                <a:spcPts val="0"/>
+              </a:spcAft>
+              <a:defRPr sz="1000" b="0">
                 <a:solidFill>
                   <a:srgbClr val="64748B"/>
                 </a:solidFill>
@@ -8073,7 +8073,7 @@
               </a:defRPr>
             </a:pPr>
             <a:r>
-              <a:t>GMV</a:t>
+              <a:t>Gross Merchandise Value (GMV)</a:t>
             </a:r>
           </a:p>
         </p:txBody>
@@ -8086,8 +8086,8 @@
         </p:nvSpPr>
         <p:spPr>
           <a:xfrm>
-            <a:off x="6035040" y="3108960"/>
-            <a:ext cx="1463040" cy="411480"/>
+            <a:off x="6400800" y="3108960"/>
+            <a:ext cx="1188720" cy="411480"/>
           </a:xfrm>
           <a:prstGeom prst="rect">
             <a:avLst/>
@@ -8171,8 +8171,8 @@
         </p:nvSpPr>
         <p:spPr>
           <a:xfrm>
-            <a:off x="4663440" y="3749040"/>
-            <a:ext cx="1645920" cy="411480"/>
+            <a:off x="4572000" y="3730752"/>
+            <a:ext cx="1737360" cy="457200"/>
           </a:xfrm>
           <a:prstGeom prst="rect">
             <a:avLst/>
@@ -8187,7 +8187,7 @@
           <a:p>
             <a:pPr algn="l">
               <a:lnSpc>
-                <a:spcPts val="1439"/>
+                <a:spcPts val="1320"/>
               </a:lnSpc>
               <a:spcAft>
                 <a:spcPts val="0"/>
@@ -8213,8 +8213,8 @@
         </p:nvSpPr>
         <p:spPr>
           <a:xfrm>
-            <a:off x="6035040" y="3749040"/>
-            <a:ext cx="1463040" cy="411480"/>
+            <a:off x="6126480" y="3749040"/>
+            <a:ext cx="1371600" cy="411480"/>
           </a:xfrm>
           <a:prstGeom prst="rect">
             <a:avLst/>
@@ -8298,8 +8298,8 @@
         </p:nvSpPr>
         <p:spPr>
           <a:xfrm>
-            <a:off x="4663440" y="4389119"/>
-            <a:ext cx="1645920" cy="411480"/>
+            <a:off x="4572000" y="4370831"/>
+            <a:ext cx="1737360" cy="457200"/>
           </a:xfrm>
           <a:prstGeom prst="rect">
             <a:avLst/>
@@ -8314,7 +8314,7 @@
           <a:p>
             <a:pPr algn="l">
               <a:lnSpc>
-                <a:spcPts val="1439"/>
+                <a:spcPts val="1320"/>
               </a:lnSpc>
               <a:spcAft>
                 <a:spcPts val="0"/>
@@ -8340,8 +8340,8 @@
         </p:nvSpPr>
         <p:spPr>
           <a:xfrm>
-            <a:off x="6035040" y="4389119"/>
-            <a:ext cx="1463040" cy="411480"/>
+            <a:off x="6126480" y="4389119"/>
+            <a:ext cx="1371600" cy="411480"/>
           </a:xfrm>
           <a:prstGeom prst="rect">
             <a:avLst/>
@@ -8425,8 +8425,8 @@
         </p:nvSpPr>
         <p:spPr>
           <a:xfrm>
-            <a:off x="4663440" y="5029200"/>
-            <a:ext cx="1645920" cy="411480"/>
+            <a:off x="4572000" y="5010912"/>
+            <a:ext cx="1737360" cy="457200"/>
           </a:xfrm>
           <a:prstGeom prst="rect">
             <a:avLst/>
@@ -8441,7 +8441,7 @@
           <a:p>
             <a:pPr algn="l">
               <a:lnSpc>
-                <a:spcPts val="1439"/>
+                <a:spcPts val="1320"/>
               </a:lnSpc>
               <a:spcAft>
                 <a:spcPts val="0"/>
@@ -8467,8 +8467,8 @@
         </p:nvSpPr>
         <p:spPr>
           <a:xfrm>
-            <a:off x="6035040" y="5029200"/>
-            <a:ext cx="1463040" cy="411480"/>
+            <a:off x="6126480" y="5029200"/>
+            <a:ext cx="1371600" cy="411480"/>
           </a:xfrm>
           <a:prstGeom prst="rect">
             <a:avLst/>
@@ -8552,8 +8552,8 @@
         </p:nvSpPr>
         <p:spPr>
           <a:xfrm>
-            <a:off x="4663440" y="5669280"/>
-            <a:ext cx="1645920" cy="411480"/>
+            <a:off x="4572000" y="5650992"/>
+            <a:ext cx="1737360" cy="457200"/>
           </a:xfrm>
           <a:prstGeom prst="rect">
             <a:avLst/>
@@ -8568,7 +8568,7 @@
           <a:p>
             <a:pPr algn="l">
               <a:lnSpc>
-                <a:spcPts val="1439"/>
+                <a:spcPts val="1320"/>
               </a:lnSpc>
               <a:spcAft>
                 <a:spcPts val="0"/>
@@ -8594,8 +8594,8 @@
         </p:nvSpPr>
         <p:spPr>
           <a:xfrm>
-            <a:off x="6035040" y="5669280"/>
-            <a:ext cx="1463040" cy="411480"/>
+            <a:off x="6126480" y="5669280"/>
+            <a:ext cx="1371600" cy="411480"/>
           </a:xfrm>
           <a:prstGeom prst="rect">
             <a:avLst/>
@@ -8764,8 +8764,8 @@
         </p:nvSpPr>
         <p:spPr>
           <a:xfrm>
-            <a:off x="8321040" y="2468880"/>
-            <a:ext cx="1645920" cy="411480"/>
+            <a:off x="8229600" y="2450592"/>
+            <a:ext cx="1737360" cy="457200"/>
           </a:xfrm>
           <a:prstGeom prst="rect">
             <a:avLst/>
@@ -8780,7 +8780,7 @@
           <a:p>
             <a:pPr algn="l">
               <a:lnSpc>
-                <a:spcPts val="1439"/>
+                <a:spcPts val="1320"/>
               </a:lnSpc>
               <a:spcAft>
                 <a:spcPts val="0"/>
@@ -8806,8 +8806,8 @@
         </p:nvSpPr>
         <p:spPr>
           <a:xfrm>
-            <a:off x="9692640" y="2468880"/>
-            <a:ext cx="1463040" cy="411480"/>
+            <a:off x="9784080" y="2468880"/>
+            <a:ext cx="1371600" cy="411480"/>
           </a:xfrm>
           <a:prstGeom prst="rect">
             <a:avLst/>
@@ -8891,8 +8891,8 @@
         </p:nvSpPr>
         <p:spPr>
           <a:xfrm>
-            <a:off x="8321040" y="3108960"/>
-            <a:ext cx="1645920" cy="411480"/>
+            <a:off x="8229600" y="3090672"/>
+            <a:ext cx="2011680" cy="457200"/>
           </a:xfrm>
           <a:prstGeom prst="rect">
             <a:avLst/>
@@ -8907,12 +8907,12 @@
           <a:p>
             <a:pPr algn="l">
               <a:lnSpc>
-                <a:spcPts val="1439"/>
-              </a:lnSpc>
-              <a:spcAft>
-                <a:spcPts val="0"/>
-              </a:spcAft>
-              <a:defRPr sz="1200" b="0">
+                <a:spcPts val="1100"/>
+              </a:lnSpc>
+              <a:spcAft>
+                <a:spcPts val="0"/>
+              </a:spcAft>
+              <a:defRPr sz="1000" b="0">
                 <a:solidFill>
                   <a:srgbClr val="64748B"/>
                 </a:solidFill>
@@ -8920,7 +8920,7 @@
               </a:defRPr>
             </a:pPr>
             <a:r>
-              <a:t>GMV</a:t>
+              <a:t>Gross Merchandise Value (GMV)</a:t>
             </a:r>
           </a:p>
         </p:txBody>
@@ -8933,8 +8933,8 @@
         </p:nvSpPr>
         <p:spPr>
           <a:xfrm>
-            <a:off x="9692640" y="3108960"/>
-            <a:ext cx="1463040" cy="411480"/>
+            <a:off x="10058400" y="3108960"/>
+            <a:ext cx="1188720" cy="411480"/>
           </a:xfrm>
           <a:prstGeom prst="rect">
             <a:avLst/>
@@ -9018,8 +9018,8 @@
         </p:nvSpPr>
         <p:spPr>
           <a:xfrm>
-            <a:off x="8321040" y="3749040"/>
-            <a:ext cx="1645920" cy="411480"/>
+            <a:off x="8229600" y="3730752"/>
+            <a:ext cx="1737360" cy="457200"/>
           </a:xfrm>
           <a:prstGeom prst="rect">
             <a:avLst/>
@@ -9034,7 +9034,7 @@
           <a:p>
             <a:pPr algn="l">
               <a:lnSpc>
-                <a:spcPts val="1439"/>
+                <a:spcPts val="1320"/>
               </a:lnSpc>
               <a:spcAft>
                 <a:spcPts val="0"/>
@@ -9060,8 +9060,8 @@
         </p:nvSpPr>
         <p:spPr>
           <a:xfrm>
-            <a:off x="9692640" y="3749040"/>
-            <a:ext cx="1463040" cy="411480"/>
+            <a:off x="9784080" y="3749040"/>
+            <a:ext cx="1371600" cy="411480"/>
           </a:xfrm>
           <a:prstGeom prst="rect">
             <a:avLst/>
@@ -9145,8 +9145,8 @@
         </p:nvSpPr>
         <p:spPr>
           <a:xfrm>
-            <a:off x="8321040" y="4389119"/>
-            <a:ext cx="1645920" cy="411480"/>
+            <a:off x="8229600" y="4370831"/>
+            <a:ext cx="1737360" cy="457200"/>
           </a:xfrm>
           <a:prstGeom prst="rect">
             <a:avLst/>
@@ -9161,7 +9161,7 @@
           <a:p>
             <a:pPr algn="l">
               <a:lnSpc>
-                <a:spcPts val="1439"/>
+                <a:spcPts val="1320"/>
               </a:lnSpc>
               <a:spcAft>
                 <a:spcPts val="0"/>
@@ -9187,8 +9187,8 @@
         </p:nvSpPr>
         <p:spPr>
           <a:xfrm>
-            <a:off x="9692640" y="4389119"/>
-            <a:ext cx="1463040" cy="411480"/>
+            <a:off x="9784080" y="4389119"/>
+            <a:ext cx="1371600" cy="411480"/>
           </a:xfrm>
           <a:prstGeom prst="rect">
             <a:avLst/>
@@ -9272,8 +9272,8 @@
         </p:nvSpPr>
         <p:spPr>
           <a:xfrm>
-            <a:off x="8321040" y="5029200"/>
-            <a:ext cx="1645920" cy="411480"/>
+            <a:off x="8229600" y="5010912"/>
+            <a:ext cx="1737360" cy="457200"/>
           </a:xfrm>
           <a:prstGeom prst="rect">
             <a:avLst/>
@@ -9288,7 +9288,7 @@
           <a:p>
             <a:pPr algn="l">
               <a:lnSpc>
-                <a:spcPts val="1439"/>
+                <a:spcPts val="1320"/>
               </a:lnSpc>
               <a:spcAft>
                 <a:spcPts val="0"/>
@@ -9314,8 +9314,8 @@
         </p:nvSpPr>
         <p:spPr>
           <a:xfrm>
-            <a:off x="9692640" y="5029200"/>
-            <a:ext cx="1463040" cy="411480"/>
+            <a:off x="9784080" y="5029200"/>
+            <a:ext cx="1371600" cy="411480"/>
           </a:xfrm>
           <a:prstGeom prst="rect">
             <a:avLst/>
@@ -9399,8 +9399,8 @@
         </p:nvSpPr>
         <p:spPr>
           <a:xfrm>
-            <a:off x="8321040" y="5669280"/>
-            <a:ext cx="1645920" cy="411480"/>
+            <a:off x="8229600" y="5650992"/>
+            <a:ext cx="1737360" cy="457200"/>
           </a:xfrm>
           <a:prstGeom prst="rect">
             <a:avLst/>
@@ -9415,7 +9415,7 @@
           <a:p>
             <a:pPr algn="l">
               <a:lnSpc>
-                <a:spcPts val="1439"/>
+                <a:spcPts val="1320"/>
               </a:lnSpc>
               <a:spcAft>
                 <a:spcPts val="0"/>
@@ -9441,8 +9441,8 @@
         </p:nvSpPr>
         <p:spPr>
           <a:xfrm>
-            <a:off x="9692640" y="5669280"/>
-            <a:ext cx="1463040" cy="411480"/>
+            <a:off x="9784080" y="5669280"/>
+            <a:ext cx="1371600" cy="411480"/>
           </a:xfrm>
           <a:prstGeom prst="rect">
             <a:avLst/>
@@ -9876,7 +9876,7 @@
               </a:defRPr>
             </a:pPr>
             <a:r>
-              <a:t>APKs available for download on the website. Beta credentials active for external testers.</a:t>
+              <a:t>Android Application Packages (APKs) available for download on website. Beta credentials active for external testers.</a:t>
             </a:r>
           </a:p>
         </p:txBody>
@@ -10003,7 +10003,7 @@
               </a:defRPr>
             </a:pPr>
             <a:r>
-              <a:t>Comprehensive test suite including AST structural walkers. CI/CD pipeline on every push.</a:t>
+              <a:t>Comprehensive test suite with Abstract Syntax Tree (AST) structural walkers. Continuous Integration (CI/CD) on every push.</a:t>
             </a:r>
           </a:p>
         </p:txBody>
@@ -10130,7 +10130,7 @@
               </a:defRPr>
             </a:pPr>
             <a:r>
-              <a:t>Complete operations console with KYC, disputes, reconciliation, delivery replay, and more.</a:t>
+              <a:t>Operations console with Know Your Customer (KYC), disputes, reconciliation, delivery replay, and financial controls.</a:t>
             </a:r>
           </a:p>
         </p:txBody>
@@ -10257,7 +10257,7 @@
               </a:defRPr>
             </a:pPr>
             <a:r>
-              <a:t>Clerk auth, BFF pattern, encrypted PII, audited mutations, concurrent-safe workers.</a:t>
+              <a:t>Clerk authentication, Backend-for-Frontend (BFF) pattern, encrypted Personally Identifiable Information (PII), audited mutations.</a:t>
             </a:r>
           </a:p>
         </p:txBody>
@@ -10566,12 +10566,12 @@
           <a:p>
             <a:pPr algn="ctr">
               <a:lnSpc>
-                <a:spcPts val="3840"/>
-              </a:lnSpc>
-              <a:spcAft>
-                <a:spcPts val="0"/>
-              </a:spcAft>
-              <a:defRPr sz="3200" b="1">
+                <a:spcPts val="3600"/>
+              </a:lnSpc>
+              <a:spcAft>
+                <a:spcPts val="0"/>
+              </a:spcAft>
+              <a:defRPr sz="3000" b="1">
                 <a:solidFill>
                   <a:srgbClr val="006DB0"/>
                 </a:solidFill>
@@ -10579,7 +10579,7 @@
               </a:defRPr>
             </a:pPr>
             <a:r>
-              <a:t>Seed Round: KSH 15M (~$115K USD)</a:t>
+              <a:t>Seed Round: KSH 15M (~$115K US Dollars / USD)</a:t>
             </a:r>
           </a:p>
           <a:p>
@@ -10884,7 +10884,7 @@
               </a:defRPr>
             </a:pPr>
             <a:r>
-              <a:t>Android + iOS builds, Play Store listing, push notification infrastructure, payment edge cases, and performance optimization.</a:t>
+              <a:t>Android and iOS mobile builds, Google Play Store listing, push notifications, payment edge cases, and performance.</a:t>
             </a:r>
           </a:p>
         </p:txBody>
@@ -11027,7 +11027,7 @@
               </a:defRPr>
             </a:pPr>
             <a:r>
-              <a:t>Render hosting, Neon Postgres, Redis, AWS S3, Clerk auth, domain registration, and monitoring (Sentry, Prometheus).</a:t>
+              <a:t>Cloud hosting, Neon PostgreSQL database, Redis cache, Amazon Web Services (AWS) S3 storage, and Clerk authentication.</a:t>
             </a:r>
           </a:p>
         </p:txBody>
@@ -11459,7 +11459,7 @@
               </a:defRPr>
             </a:pPr>
             <a:r>
-              <a:t>📱  Beta APKs: Available for download now</a:t>
+              <a:t>📱  Beta Android App (APK) Downloads: Available on website</a:t>
             </a:r>
           </a:p>
         </p:txBody>
@@ -13249,8 +13249,8 @@
         </p:nvSpPr>
         <p:spPr>
           <a:xfrm>
-            <a:off x="731520" y="1737360"/>
-            <a:ext cx="3383280" cy="2377440"/>
+            <a:off x="731520" y="1691640"/>
+            <a:ext cx="3383280" cy="2651760"/>
           </a:xfrm>
           <a:prstGeom prst="roundRect">
             <a:avLst/>
@@ -13292,8 +13292,8 @@
         </p:nvSpPr>
         <p:spPr>
           <a:xfrm>
-            <a:off x="1005840" y="1920240"/>
-            <a:ext cx="2834640" cy="457200"/>
+            <a:off x="914400" y="1783080"/>
+            <a:ext cx="3017520" cy="548640"/>
           </a:xfrm>
           <a:prstGeom prst="rect">
             <a:avLst/>
@@ -13308,12 +13308,12 @@
           <a:p>
             <a:pPr algn="ctr">
               <a:lnSpc>
-                <a:spcPts val="1680"/>
-              </a:lnSpc>
-              <a:spcAft>
-                <a:spcPts val="0"/>
-              </a:spcAft>
-              <a:defRPr sz="1400" b="1">
+                <a:spcPts val="1380"/>
+              </a:lnSpc>
+              <a:spcAft>
+                <a:spcPts val="0"/>
+              </a:spcAft>
+              <a:defRPr sz="1200" b="1">
                 <a:solidFill>
                   <a:srgbClr val="64748B"/>
                 </a:solidFill>
@@ -13321,7 +13321,7 @@
               </a:defRPr>
             </a:pPr>
             <a:r>
-              <a:t>TAM</a:t>
+              <a:t>Total Addressable Market (TAM)</a:t>
             </a:r>
           </a:p>
         </p:txBody>
@@ -13334,8 +13334,8 @@
         </p:nvSpPr>
         <p:spPr>
           <a:xfrm>
-            <a:off x="1005840" y="2286000"/>
-            <a:ext cx="2834640" cy="731520"/>
+            <a:off x="914400" y="2377440"/>
+            <a:ext cx="3017520" cy="731520"/>
           </a:xfrm>
           <a:prstGeom prst="rect">
             <a:avLst/>
@@ -13350,12 +13350,12 @@
           <a:p>
             <a:pPr algn="ctr">
               <a:lnSpc>
-                <a:spcPts val="5040"/>
-              </a:lnSpc>
-              <a:spcAft>
-                <a:spcPts val="0"/>
-              </a:spcAft>
-              <a:defRPr sz="4200" b="1">
+                <a:spcPts val="4800"/>
+              </a:lnSpc>
+              <a:spcAft>
+                <a:spcPts val="0"/>
+              </a:spcAft>
+              <a:defRPr sz="4000" b="1">
                 <a:solidFill>
                   <a:srgbClr val="006DB0"/>
                 </a:solidFill>
@@ -13376,8 +13376,8 @@
         </p:nvSpPr>
         <p:spPr>
           <a:xfrm>
-            <a:off x="1005840" y="3108960"/>
-            <a:ext cx="2834640" cy="914400"/>
+            <a:off x="914400" y="3154680"/>
+            <a:ext cx="3017520" cy="1051560"/>
           </a:xfrm>
           <a:prstGeom prst="rect">
             <a:avLst/>
@@ -13392,12 +13392,12 @@
           <a:p>
             <a:pPr algn="ctr">
               <a:lnSpc>
-                <a:spcPts val="1679"/>
-              </a:lnSpc>
-              <a:spcAft>
-                <a:spcPts val="0"/>
-              </a:spcAft>
-              <a:defRPr sz="1200" b="0">
+                <a:spcPts val="1485"/>
+              </a:lnSpc>
+              <a:spcAft>
+                <a:spcPts val="0"/>
+              </a:spcAft>
+              <a:defRPr sz="1100" b="0">
                 <a:solidFill>
                   <a:srgbClr val="64748B"/>
                 </a:solidFill>
@@ -13418,8 +13418,8 @@
         </p:nvSpPr>
         <p:spPr>
           <a:xfrm>
-            <a:off x="4389120" y="1737360"/>
-            <a:ext cx="3383280" cy="2377440"/>
+            <a:off x="4389120" y="1691640"/>
+            <a:ext cx="3383280" cy="2651760"/>
           </a:xfrm>
           <a:prstGeom prst="roundRect">
             <a:avLst/>
@@ -13461,8 +13461,8 @@
         </p:nvSpPr>
         <p:spPr>
           <a:xfrm>
-            <a:off x="4663440" y="1920240"/>
-            <a:ext cx="2834640" cy="457200"/>
+            <a:off x="4572000" y="1783080"/>
+            <a:ext cx="3017520" cy="548640"/>
           </a:xfrm>
           <a:prstGeom prst="rect">
             <a:avLst/>
@@ -13477,12 +13477,12 @@
           <a:p>
             <a:pPr algn="ctr">
               <a:lnSpc>
-                <a:spcPts val="1680"/>
-              </a:lnSpc>
-              <a:spcAft>
-                <a:spcPts val="0"/>
-              </a:spcAft>
-              <a:defRPr sz="1400" b="1">
+                <a:spcPts val="1380"/>
+              </a:lnSpc>
+              <a:spcAft>
+                <a:spcPts val="0"/>
+              </a:spcAft>
+              <a:defRPr sz="1200" b="1">
                 <a:solidFill>
                   <a:srgbClr val="64748B"/>
                 </a:solidFill>
@@ -13490,7 +13490,7 @@
               </a:defRPr>
             </a:pPr>
             <a:r>
-              <a:t>SAM</a:t>
+              <a:t>Serviceable Available Market (SAM)</a:t>
             </a:r>
           </a:p>
         </p:txBody>
@@ -13503,8 +13503,8 @@
         </p:nvSpPr>
         <p:spPr>
           <a:xfrm>
-            <a:off x="4663440" y="2286000"/>
-            <a:ext cx="2834640" cy="731520"/>
+            <a:off x="4572000" y="2377440"/>
+            <a:ext cx="3017520" cy="731520"/>
           </a:xfrm>
           <a:prstGeom prst="rect">
             <a:avLst/>
@@ -13519,12 +13519,12 @@
           <a:p>
             <a:pPr algn="ctr">
               <a:lnSpc>
-                <a:spcPts val="5040"/>
-              </a:lnSpc>
-              <a:spcAft>
-                <a:spcPts val="0"/>
-              </a:spcAft>
-              <a:defRPr sz="4200" b="1">
+                <a:spcPts val="4800"/>
+              </a:lnSpc>
+              <a:spcAft>
+                <a:spcPts val="0"/>
+              </a:spcAft>
+              <a:defRPr sz="4000" b="1">
                 <a:solidFill>
                   <a:srgbClr val="006DB0"/>
                 </a:solidFill>
@@ -13545,8 +13545,8 @@
         </p:nvSpPr>
         <p:spPr>
           <a:xfrm>
-            <a:off x="4663440" y="3108960"/>
-            <a:ext cx="2834640" cy="914400"/>
+            <a:off x="4572000" y="3154680"/>
+            <a:ext cx="3017520" cy="1051560"/>
           </a:xfrm>
           <a:prstGeom prst="rect">
             <a:avLst/>
@@ -13561,12 +13561,12 @@
           <a:p>
             <a:pPr algn="ctr">
               <a:lnSpc>
-                <a:spcPts val="1679"/>
-              </a:lnSpc>
-              <a:spcAft>
-                <a:spcPts val="0"/>
-              </a:spcAft>
-              <a:defRPr sz="1200" b="0">
+                <a:spcPts val="1485"/>
+              </a:lnSpc>
+              <a:spcAft>
+                <a:spcPts val="0"/>
+              </a:spcAft>
+              <a:defRPr sz="1100" b="0">
                 <a:solidFill>
                   <a:srgbClr val="64748B"/>
                 </a:solidFill>
@@ -13587,8 +13587,8 @@
         </p:nvSpPr>
         <p:spPr>
           <a:xfrm>
-            <a:off x="8046720" y="1737360"/>
-            <a:ext cx="3383280" cy="2377440"/>
+            <a:off x="8046720" y="1691640"/>
+            <a:ext cx="3383280" cy="2651760"/>
           </a:xfrm>
           <a:prstGeom prst="roundRect">
             <a:avLst/>
@@ -13630,8 +13630,8 @@
         </p:nvSpPr>
         <p:spPr>
           <a:xfrm>
-            <a:off x="8321040" y="1920240"/>
-            <a:ext cx="2834640" cy="457200"/>
+            <a:off x="8229600" y="1783080"/>
+            <a:ext cx="3017520" cy="548640"/>
           </a:xfrm>
           <a:prstGeom prst="rect">
             <a:avLst/>
@@ -13646,12 +13646,12 @@
           <a:p>
             <a:pPr algn="ctr">
               <a:lnSpc>
-                <a:spcPts val="1680"/>
-              </a:lnSpc>
-              <a:spcAft>
-                <a:spcPts val="0"/>
-              </a:spcAft>
-              <a:defRPr sz="1400" b="1">
+                <a:spcPts val="1380"/>
+              </a:lnSpc>
+              <a:spcAft>
+                <a:spcPts val="0"/>
+              </a:spcAft>
+              <a:defRPr sz="1200" b="1">
                 <a:solidFill>
                   <a:srgbClr val="64748B"/>
                 </a:solidFill>
@@ -13659,7 +13659,7 @@
               </a:defRPr>
             </a:pPr>
             <a:r>
-              <a:t>SOM</a:t>
+              <a:t>Serviceable Obtainable Market (SOM)</a:t>
             </a:r>
           </a:p>
         </p:txBody>
@@ -13672,8 +13672,8 @@
         </p:nvSpPr>
         <p:spPr>
           <a:xfrm>
-            <a:off x="8321040" y="2286000"/>
-            <a:ext cx="2834640" cy="731520"/>
+            <a:off x="8229600" y="2377440"/>
+            <a:ext cx="3017520" cy="731520"/>
           </a:xfrm>
           <a:prstGeom prst="rect">
             <a:avLst/>
@@ -13688,12 +13688,12 @@
           <a:p>
             <a:pPr algn="ctr">
               <a:lnSpc>
-                <a:spcPts val="5040"/>
-              </a:lnSpc>
-              <a:spcAft>
-                <a:spcPts val="0"/>
-              </a:spcAft>
-              <a:defRPr sz="4200" b="1">
+                <a:spcPts val="4800"/>
+              </a:lnSpc>
+              <a:spcAft>
+                <a:spcPts val="0"/>
+              </a:spcAft>
+              <a:defRPr sz="4000" b="1">
                 <a:solidFill>
                   <a:srgbClr val="006DB0"/>
                 </a:solidFill>
@@ -13714,8 +13714,8 @@
         </p:nvSpPr>
         <p:spPr>
           <a:xfrm>
-            <a:off x="8321040" y="3108960"/>
-            <a:ext cx="2834640" cy="914400"/>
+            <a:off x="8229600" y="3154680"/>
+            <a:ext cx="3017520" cy="1051560"/>
           </a:xfrm>
           <a:prstGeom prst="rect">
             <a:avLst/>
@@ -13730,12 +13730,12 @@
           <a:p>
             <a:pPr algn="ctr">
               <a:lnSpc>
-                <a:spcPts val="1679"/>
-              </a:lnSpc>
-              <a:spcAft>
-                <a:spcPts val="0"/>
-              </a:spcAft>
-              <a:defRPr sz="1200" b="0">
+                <a:spcPts val="1485"/>
+              </a:lnSpc>
+              <a:spcAft>
+                <a:spcPts val="0"/>
+              </a:spcAft>
+              <a:defRPr sz="1100" b="0">
                 <a:solidFill>
                   <a:srgbClr val="64748B"/>
                 </a:solidFill>
@@ -13799,8 +13799,8 @@
         </p:nvSpPr>
         <p:spPr>
           <a:xfrm>
-            <a:off x="914400" y="4754880"/>
-            <a:ext cx="2194560" cy="640080"/>
+            <a:off x="914400" y="4709160"/>
+            <a:ext cx="2194560" cy="548640"/>
           </a:xfrm>
           <a:prstGeom prst="rect">
             <a:avLst/>
@@ -13842,7 +13842,7 @@
         <p:spPr>
           <a:xfrm>
             <a:off x="914400" y="5303520"/>
-            <a:ext cx="2194560" cy="457200"/>
+            <a:ext cx="2194560" cy="548640"/>
           </a:xfrm>
           <a:prstGeom prst="rect">
             <a:avLst/>
@@ -13926,8 +13926,8 @@
         </p:nvSpPr>
         <p:spPr>
           <a:xfrm>
-            <a:off x="3749040" y="4754880"/>
-            <a:ext cx="2194560" cy="640080"/>
+            <a:off x="3749040" y="4709160"/>
+            <a:ext cx="2194560" cy="548640"/>
           </a:xfrm>
           <a:prstGeom prst="rect">
             <a:avLst/>
@@ -13969,7 +13969,7 @@
         <p:spPr>
           <a:xfrm>
             <a:off x="3749040" y="5303520"/>
-            <a:ext cx="2194560" cy="457200"/>
+            <a:ext cx="2194560" cy="548640"/>
           </a:xfrm>
           <a:prstGeom prst="rect">
             <a:avLst/>
@@ -14053,8 +14053,8 @@
         </p:nvSpPr>
         <p:spPr>
           <a:xfrm>
-            <a:off x="6583680" y="4754880"/>
-            <a:ext cx="2194560" cy="640080"/>
+            <a:off x="6583680" y="4709160"/>
+            <a:ext cx="2194560" cy="548640"/>
           </a:xfrm>
           <a:prstGeom prst="rect">
             <a:avLst/>
@@ -14096,7 +14096,7 @@
         <p:spPr>
           <a:xfrm>
             <a:off x="6583680" y="5303520"/>
-            <a:ext cx="2194560" cy="457200"/>
+            <a:ext cx="2194560" cy="548640"/>
           </a:xfrm>
           <a:prstGeom prst="rect">
             <a:avLst/>
@@ -14180,8 +14180,8 @@
         </p:nvSpPr>
         <p:spPr>
           <a:xfrm>
-            <a:off x="9418320" y="4754880"/>
-            <a:ext cx="2194560" cy="640080"/>
+            <a:off x="9418320" y="4709160"/>
+            <a:ext cx="2194560" cy="548640"/>
           </a:xfrm>
           <a:prstGeom prst="rect">
             <a:avLst/>
@@ -14223,7 +14223,7 @@
         <p:spPr>
           <a:xfrm>
             <a:off x="9418320" y="5303520"/>
-            <a:ext cx="2194560" cy="457200"/>
+            <a:ext cx="2194560" cy="548640"/>
           </a:xfrm>
           <a:prstGeom prst="rect">
             <a:avLst/>
@@ -14732,7 +14732,7 @@
               </a:defRPr>
             </a:pPr>
             <a:r>
-              <a:t>Customer selects 20L refill quantity, specifies empty bottle exchange, and checks out securely via M-Pesa STK Push.</a:t>
+              <a:t>Customer selects 20L refill quantity, specifies empty bottle exchange, and checks out securely via M-Pesa SIM Tool Kit (STK) Push.</a:t>
             </a:r>
           </a:p>
         </p:txBody>
@@ -15161,7 +15161,7 @@
               </a:defRPr>
             </a:pPr>
             <a:r>
-              <a:t>Customer tracks rider GPS in real time. Rider climbs stairs and delivers the heavy 20kg bottles directly into the home.</a:t>
+              <a:t>Customer tracks rider GPS (Global Positioning System) in real time. Rider climbs stairs and delivers the heavy 20kg bottles directly into the home.</a:t>
             </a:r>
           </a:p>
         </p:txBody>
@@ -15668,11 +15668,11 @@
               </a:defRPr>
             </a:pPr>
             <a:r>
-              <a:t>5% on retail (B2C)</a:t>
+              <a:t>5% on retail (Business-to-Consumer)</a:t>
             </a:r>
             <a:br/>
             <a:r>
-              <a:t>5% on wholesale (B2B)</a:t>
+              <a:t>5% on wholesale (Business-to-Business)</a:t>
             </a:r>
           </a:p>
         </p:txBody>
@@ -16318,7 +16318,7 @@
               </a:defRPr>
             </a:pPr>
             <a:r>
-              <a:t>💡  One pricing path: compute_order_quote is the single source of truth — client renders it, M-Pesa charges it, database stores it. Tests enforce parity.</a:t>
+              <a:t>💡  One pricing path: compute_order_quote is the single source of truth — client renders it, M-Pesa charges it, database stores it. Automated tests enforce parity.</a:t>
             </a:r>
           </a:p>
         </p:txBody>
@@ -16594,7 +16594,7 @@
               </a:defRPr>
             </a:pPr>
             <a:r>
-              <a:t>▸  Python 3.12  •  FastAPI  •  Uvicorn</a:t>
+              <a:t>▸  Python 3.12  •  FastAPI Framework  •  Uvicorn</a:t>
             </a:r>
           </a:p>
           <a:p>
@@ -16613,7 +16613,7 @@
               </a:defRPr>
             </a:pPr>
             <a:r>
-              <a:t>▸  PostgreSQL + PostGIS + H3</a:t>
+              <a:t>▸  PostgreSQL Database + PostGIS + H3 Spatial Indexing</a:t>
             </a:r>
           </a:p>
           <a:p>
@@ -16632,7 +16632,7 @@
               </a:defRPr>
             </a:pPr>
             <a:r>
-              <a:t>▸  SQLAlchemy 2.0 Async  •  Alembic</a:t>
+              <a:t>▸  SQLAlchemy 2.0 Async Object-Relational Mapping  •  Alembic</a:t>
             </a:r>
           </a:p>
           <a:p>
@@ -16651,7 +16651,7 @@
               </a:defRPr>
             </a:pPr>
             <a:r>
-              <a:t>▸  Redis (pub/sub, queues, rate limits)</a:t>
+              <a:t>▸  Redis (Publish/Subscribe, Job Queues, Rate Limiting)</a:t>
             </a:r>
           </a:p>
           <a:p>
@@ -16670,7 +16670,7 @@
               </a:defRPr>
             </a:pPr>
             <a:r>
-              <a:t>▸  ARQ Background Workers</a:t>
+              <a:t>▸  ARQ Asynchronous Background Job Workers</a:t>
             </a:r>
           </a:p>
           <a:p>
@@ -16689,7 +16689,7 @@
               </a:defRPr>
             </a:pPr>
             <a:r>
-              <a:t>▸  M-Pesa STK Push / B2C / Reversals</a:t>
+              <a:t>▸  M-Pesa STK (SIM Tool Kit) Push / Business-to-Consumer (B2C) / Reversals</a:t>
             </a:r>
           </a:p>
           <a:p>
@@ -16708,7 +16708,7 @@
               </a:defRPr>
             </a:pPr>
             <a:r>
-              <a:t>▸  AWS S3 (private, presigned)</a:t>
+              <a:t>▸  Amazon Web Services (AWS) Simple Storage Service (S3)</a:t>
             </a:r>
           </a:p>
           <a:p>
@@ -16727,7 +16727,7 @@
               </a:defRPr>
             </a:pPr>
             <a:r>
-              <a:t>▸  Clerk RS256 JWT Auth</a:t>
+              <a:t>▸  Clerk RS256 JSON Web Token (JWT) Authentication</a:t>
             </a:r>
           </a:p>
           <a:p>
@@ -16746,7 +16746,7 @@
               </a:defRPr>
             </a:pPr>
             <a:r>
-              <a:t>▸  Sentry  •  Prometheus  •  JSON Logs</a:t>
+              <a:t>▸  Sentry Error Monitoring  •  Prometheus Metrics  •  JSON Logs</a:t>
             </a:r>
           </a:p>
         </p:txBody>
@@ -16827,7 +16827,7 @@
               </a:defRPr>
             </a:pPr>
             <a:r>
-              <a:t>▸  Expo SDK 54  •  React Native 0.81</a:t>
+              <a:t>▸  Expo Software Development Kit (SDK) 54  •  React Native 0.81</a:t>
             </a:r>
           </a:p>
           <a:p>
@@ -16846,7 +16846,7 @@
               </a:defRPr>
             </a:pPr>
             <a:r>
-              <a:t>▸  React 19  •  Expo Router 6</a:t>
+              <a:t>▸  React 19  •  Expo Router 6 (File-Based Navigation)</a:t>
             </a:r>
           </a:p>
           <a:p>
@@ -16865,7 +16865,7 @@
               </a:defRPr>
             </a:pPr>
             <a:r>
-              <a:t>▸  NativeWind v4  •  TanStack Query v5</a:t>
+              <a:t>▸  NativeWind v4 Styling  •  TanStack Query v5 Data Fetching</a:t>
             </a:r>
           </a:p>
           <a:p>
@@ -16884,7 +16884,7 @@
               </a:defRPr>
             </a:pPr>
             <a:r>
-              <a:t>▸  Zustand v5 State Management</a:t>
+              <a:t>▸  Zustand v5 State Management Architecture</a:t>
             </a:r>
           </a:p>
           <a:p>
@@ -16903,7 +16903,7 @@
               </a:defRPr>
             </a:pPr>
             <a:r>
-              <a:t>▸  @clerk/clerk-expo Auth</a:t>
+              <a:t>▸  @clerk/clerk-expo Client Authentication</a:t>
             </a:r>
           </a:p>
           <a:p>
@@ -16922,7 +16922,7 @@
               </a:defRPr>
             </a:pPr>
             <a:r>
-              <a:t>▸  react-native-maps + WebSocket</a:t>
+              <a:t>▸  react-native-maps + Live WebSocket Location Streaming</a:t>
             </a:r>
           </a:p>
           <a:p>
@@ -16941,7 +16941,7 @@
               </a:defRPr>
             </a:pPr>
             <a:r>
-              <a:t>▸  Next.js 16 (Admin Console)</a:t>
+              <a:t>▸  Next.js 16 (Operations Console Web Application)</a:t>
             </a:r>
           </a:p>
           <a:p>
@@ -16960,7 +16960,7 @@
               </a:defRPr>
             </a:pPr>
             <a:r>
-              <a:t>▸  Tailwind v4  •  Recharts</a:t>
+              <a:t>▸  Tailwind CSS v4  •  Recharts Visualizations</a:t>
             </a:r>
           </a:p>
           <a:p>
@@ -16979,7 +16979,7 @@
               </a:defRPr>
             </a:pPr>
             <a:r>
-              <a:t>▸  Vercel Deployment (Console + Website)</a:t>
+              <a:t>▸  Vercel Cloud Deployment (Operations Console + Website)</a:t>
             </a:r>
           </a:p>
         </p:txBody>
@@ -17051,12 +17051,12 @@
           <a:p>
             <a:pPr algn="ctr">
               <a:lnSpc>
-                <a:spcPts val="1650"/>
-              </a:lnSpc>
-              <a:spcAft>
-                <a:spcPts val="0"/>
-              </a:spcAft>
-              <a:defRPr sz="1100" b="0">
+                <a:spcPts val="1470"/>
+              </a:lnSpc>
+              <a:spcAft>
+                <a:spcPts val="0"/>
+              </a:spcAft>
+              <a:defRPr sz="1050" b="0">
                 <a:solidFill>
                   <a:srgbClr val="E2E8F0"/>
                 </a:solidFill>
@@ -17064,11 +17064,11 @@
               </a:defRPr>
             </a:pPr>
             <a:r>
-              <a:t>🏗️  Architecture Principle: One backend, one database, one pricing path. The console is a BFF — the browser never holds an API token.</a:t>
+              <a:t>🏗️  Architecture Principle: One backend, one database, one pricing path. The console is a Backend-for-Frontend (BFF) — the browser never holds an Application Programming Interface (API) token.</a:t>
             </a:r>
             <a:br/>
             <a:r>
-              <a:t>Geospatial: H3 hex indexing at resolution 8 with PostGIS ST_DWithin for exact-distance discovery.</a:t>
+              <a:t>Geospatial: Uber H3 spatial hex indexing at resolution 8 with PostGIS ST_DWithin for exact-distance discovery.</a:t>
             </a:r>
           </a:p>
         </p:txBody>
@@ -17390,15 +17390,15 @@
               </a:defRPr>
             </a:pPr>
             <a:r>
-              <a:t>Orders board  •  KYC Verification  •  Live Map  •  Catalogue</a:t>
+              <a:t>Orders board  •  Know Your Customer (KYC) Verification  •  Live Map</a:t>
             </a:r>
             <a:br/>
             <a:r>
-              <a:t>Bottle Float  •  Vendor Verification  •  Disputes  •  Reviews</a:t>
+              <a:t>Catalogue  •  Bottle Float Ledger  •  Vendor Verification  •  Disputes</a:t>
             </a:r>
             <a:br/>
             <a:r>
-              <a:t>Delivery Replay</a:t>
+              <a:t>Reviews  •  Delivery Replay</a:t>
             </a:r>
           </a:p>
         </p:txBody>
@@ -18286,7 +18286,7 @@
               </a:defRPr>
             </a:pPr>
             <a:r>
-              <a:t>Money is Decimal, never float — from DB through API to the formatted string. One quote, one charge, one stored total.</a:t>
+              <a:t>Money is Decimal, never float — from database through Application Programming Interface (API) to formatted string. One quote, one charge, one stored total.</a:t>
             </a:r>
           </a:p>
         </p:txBody>
@@ -18413,7 +18413,7 @@
               </a:defRPr>
             </a:pPr>
             <a:r>
-              <a:t>Clerk RS256 JWT verification. Every order endpoint calls authorise_order_access. 26 admin capabilities, role-based presets.</a:t>
+              <a:t>Clerk RS256 JSON Web Token (JWT) verification. Every order endpoint calls authorise_order_access. 26 admin capabilities, role-based presets.</a:t>
             </a:r>
           </a:p>
         </p:txBody>
@@ -18540,7 +18540,7 @@
               </a:defRPr>
             </a:pPr>
             <a:r>
-              <a:t>Photo proof mandatory on bottle deficit. Verification wall blocks riders until KYC approved. Identity documents presigned for 5 min.</a:t>
+              <a:t>Photo proof mandatory on bottle deficit. Verification wall blocks riders until Know Your Customer (KYC) approved. Identity documents presigned for 5 min.</a:t>
             </a:r>
           </a:p>
         </p:txBody>
@@ -18667,7 +18667,7 @@
               </a:defRPr>
             </a:pPr>
             <a:r>
-              <a:t>BFF architecture — browser never holds API token. No retry on reversals. Every mutation audited with written reason.</a:t>
+              <a:t>Backend-for-Frontend (BFF) architecture — browser never holds Application Programming Interface (API) token. No retry on reversals. Every mutation audited with written reason.</a:t>
             </a:r>
           </a:p>
         </p:txBody>
@@ -18921,7 +18921,7 @@
               </a:defRPr>
             </a:pPr>
             <a:r>
-              <a:t>704 tests including AST walkers that reject: unguarded routes, missing capability checks, bypassed proof checks, retry buttons on settlements.</a:t>
+              <a:t>704 tests including Abstract Syntax Tree (AST) walkers that reject: unguarded routes, missing capability checks, bypassed proof checks, retry buttons on settlements.</a:t>
             </a:r>
           </a:p>
         </p:txBody>

</xml_diff>

<commit_message>
docs(pitch-deck): verify all Slide 4 market metrics against official sources (WASREB, Safaricom, CA, KNBS) and introduce instant-scannability TAM/SAM/SOM badge hierarchy
</commit_message>
<xml_diff>
--- a/Drop_Pitch_Deck.pptx
+++ b/Drop_Pitch_Deck.pptx
@@ -13164,8 +13164,8 @@
         </p:nvSpPr>
         <p:spPr>
           <a:xfrm>
-            <a:off x="731520" y="548640"/>
-            <a:ext cx="10058400" cy="731520"/>
+            <a:off x="731520" y="502920"/>
+            <a:ext cx="10789920" cy="685800"/>
           </a:xfrm>
           <a:prstGeom prst="rect">
             <a:avLst/>
@@ -13206,7 +13206,7 @@
         </p:nvSpPr>
         <p:spPr>
           <a:xfrm>
-            <a:off x="731520" y="1234440"/>
+            <a:off x="731520" y="1188720"/>
             <a:ext cx="548640" cy="50800"/>
           </a:xfrm>
           <a:prstGeom prst="rect">
@@ -13249,8 +13249,8 @@
         </p:nvSpPr>
         <p:spPr>
           <a:xfrm>
-            <a:off x="731520" y="1691640"/>
-            <a:ext cx="3383280" cy="2651760"/>
+            <a:off x="731520" y="1508760"/>
+            <a:ext cx="3383280" cy="2880360"/>
           </a:xfrm>
           <a:prstGeom prst="roundRect">
             <a:avLst/>
@@ -13286,14 +13286,100 @@
       </p:sp>
       <p:sp>
         <p:nvSpPr>
-          <p:cNvPr id="5" name="TextBox 4"/>
-          <p:cNvSpPr txBox="1"/>
-          <p:nvPr/>
-        </p:nvSpPr>
-        <p:spPr>
-          <a:xfrm>
-            <a:off x="914400" y="1783080"/>
-            <a:ext cx="3017520" cy="548640"/>
+          <p:cNvPr id="5" name="Rounded Rectangle 4"/>
+          <p:cNvSpPr/>
+          <p:nvPr/>
+        </p:nvSpPr>
+        <p:spPr>
+          <a:xfrm>
+            <a:off x="914400" y="1609344"/>
+            <a:ext cx="3017520" cy="621792"/>
+          </a:xfrm>
+          <a:prstGeom prst="roundRect">
+            <a:avLst/>
+          </a:prstGeom>
+          <a:solidFill>
+            <a:srgbClr val="E9F8FF"/>
+          </a:solidFill>
+          <a:ln>
+            <a:noFill/>
+          </a:ln>
+        </p:spPr>
+        <p:style>
+          <a:lnRef idx="1">
+            <a:schemeClr val="accent1"/>
+          </a:lnRef>
+          <a:fillRef idx="3">
+            <a:schemeClr val="accent1"/>
+          </a:fillRef>
+          <a:effectRef idx="2">
+            <a:schemeClr val="accent1"/>
+          </a:effectRef>
+          <a:fontRef idx="minor">
+            <a:schemeClr val="lt1"/>
+          </a:fontRef>
+        </p:style>
+        <p:txBody>
+          <a:bodyPr rtlCol="0" anchor="ctr"/>
+          <a:lstStyle/>
+          <a:p>
+            <a:pPr algn="ctr"/>
+          </a:p>
+        </p:txBody>
+      </p:sp>
+      <p:sp>
+        <p:nvSpPr>
+          <p:cNvPr id="6" name="Rounded Rectangle 5"/>
+          <p:cNvSpPr/>
+          <p:nvPr/>
+        </p:nvSpPr>
+        <p:spPr>
+          <a:xfrm>
+            <a:off x="987552" y="1682496"/>
+            <a:ext cx="658368" cy="237744"/>
+          </a:xfrm>
+          <a:prstGeom prst="roundRect">
+            <a:avLst/>
+          </a:prstGeom>
+          <a:solidFill>
+            <a:srgbClr val="006DB0"/>
+          </a:solidFill>
+          <a:ln>
+            <a:noFill/>
+          </a:ln>
+        </p:spPr>
+        <p:style>
+          <a:lnRef idx="1">
+            <a:schemeClr val="accent1"/>
+          </a:lnRef>
+          <a:fillRef idx="3">
+            <a:schemeClr val="accent1"/>
+          </a:fillRef>
+          <a:effectRef idx="2">
+            <a:schemeClr val="accent1"/>
+          </a:effectRef>
+          <a:fontRef idx="minor">
+            <a:schemeClr val="lt1"/>
+          </a:fontRef>
+        </p:style>
+        <p:txBody>
+          <a:bodyPr rtlCol="0" anchor="ctr"/>
+          <a:lstStyle/>
+          <a:p>
+            <a:pPr algn="ctr"/>
+          </a:p>
+        </p:txBody>
+      </p:sp>
+      <p:sp>
+        <p:nvSpPr>
+          <p:cNvPr id="7" name="TextBox 6"/>
+          <p:cNvSpPr txBox="1"/>
+          <p:nvPr/>
+        </p:nvSpPr>
+        <p:spPr>
+          <a:xfrm>
+            <a:off x="987552" y="1682496"/>
+            <a:ext cx="658368" cy="237744"/>
           </a:xfrm>
           <a:prstGeom prst="rect">
             <a:avLst/>
@@ -13308,34 +13394,160 @@
           <a:p>
             <a:pPr algn="ctr">
               <a:lnSpc>
-                <a:spcPts val="1380"/>
-              </a:lnSpc>
-              <a:spcAft>
-                <a:spcPts val="0"/>
-              </a:spcAft>
-              <a:defRPr sz="1200" b="1">
+                <a:spcPts val="1140"/>
+              </a:lnSpc>
+              <a:spcAft>
+                <a:spcPts val="0"/>
+              </a:spcAft>
+              <a:defRPr sz="950" b="1">
+                <a:solidFill>
+                  <a:srgbClr val="FFFFFF"/>
+                </a:solidFill>
+                <a:latin typeface="Fredoka"/>
+              </a:defRPr>
+            </a:pPr>
+            <a:r>
+              <a:t>TAM</a:t>
+            </a:r>
+          </a:p>
+        </p:txBody>
+      </p:sp>
+      <p:sp>
+        <p:nvSpPr>
+          <p:cNvPr id="8" name="TextBox 7"/>
+          <p:cNvSpPr txBox="1"/>
+          <p:nvPr/>
+        </p:nvSpPr>
+        <p:spPr>
+          <a:xfrm>
+            <a:off x="1691640" y="1664208"/>
+            <a:ext cx="2148840" cy="274320"/>
+          </a:xfrm>
+          <a:prstGeom prst="rect">
+            <a:avLst/>
+          </a:prstGeom>
+          <a:noFill/>
+        </p:spPr>
+        <p:txBody>
+          <a:bodyPr wrap="square">
+            <a:spAutoFit/>
+          </a:bodyPr>
+          <a:lstStyle/>
+          <a:p>
+            <a:pPr algn="l">
+              <a:lnSpc>
+                <a:spcPts val="1140"/>
+              </a:lnSpc>
+              <a:spcAft>
+                <a:spcPts val="0"/>
+              </a:spcAft>
+              <a:defRPr sz="950" b="1">
+                <a:solidFill>
+                  <a:srgbClr val="006DB0"/>
+                </a:solidFill>
+                <a:latin typeface="Fredoka"/>
+              </a:defRPr>
+            </a:pPr>
+            <a:r>
+              <a:t>Total Addressable Market</a:t>
+            </a:r>
+          </a:p>
+        </p:txBody>
+      </p:sp>
+      <p:sp>
+        <p:nvSpPr>
+          <p:cNvPr id="9" name="TextBox 8"/>
+          <p:cNvSpPr txBox="1"/>
+          <p:nvPr/>
+        </p:nvSpPr>
+        <p:spPr>
+          <a:xfrm>
+            <a:off x="1005840" y="1956816"/>
+            <a:ext cx="2834640" cy="237744"/>
+          </a:xfrm>
+          <a:prstGeom prst="rect">
+            <a:avLst/>
+          </a:prstGeom>
+          <a:noFill/>
+        </p:spPr>
+        <p:txBody>
+          <a:bodyPr wrap="square">
+            <a:spAutoFit/>
+          </a:bodyPr>
+          <a:lstStyle/>
+          <a:p>
+            <a:pPr algn="ctr">
+              <a:lnSpc>
+                <a:spcPts val="1080"/>
+              </a:lnSpc>
+              <a:spcAft>
+                <a:spcPts val="0"/>
+              </a:spcAft>
+              <a:defRPr sz="900" b="0">
                 <a:solidFill>
                   <a:srgbClr val="64748B"/>
                 </a:solidFill>
+                <a:latin typeface="Karla"/>
+              </a:defRPr>
+            </a:pPr>
+            <a:r>
+              <a:t>Scope: Entire Kenya Water Economy</a:t>
+            </a:r>
+          </a:p>
+        </p:txBody>
+      </p:sp>
+      <p:sp>
+        <p:nvSpPr>
+          <p:cNvPr id="10" name="TextBox 9"/>
+          <p:cNvSpPr txBox="1"/>
+          <p:nvPr/>
+        </p:nvSpPr>
+        <p:spPr>
+          <a:xfrm>
+            <a:off x="914400" y="2267712"/>
+            <a:ext cx="3017520" cy="658368"/>
+          </a:xfrm>
+          <a:prstGeom prst="rect">
+            <a:avLst/>
+          </a:prstGeom>
+          <a:noFill/>
+        </p:spPr>
+        <p:txBody>
+          <a:bodyPr wrap="square">
+            <a:spAutoFit/>
+          </a:bodyPr>
+          <a:lstStyle/>
+          <a:p>
+            <a:pPr algn="ctr">
+              <a:lnSpc>
+                <a:spcPts val="4560"/>
+              </a:lnSpc>
+              <a:spcAft>
+                <a:spcPts val="0"/>
+              </a:spcAft>
+              <a:defRPr sz="3800" b="1">
+                <a:solidFill>
+                  <a:srgbClr val="006DB0"/>
+                </a:solidFill>
                 <a:latin typeface="Fredoka"/>
               </a:defRPr>
             </a:pPr>
             <a:r>
-              <a:t>Total Addressable Market (TAM)</a:t>
-            </a:r>
-          </a:p>
-        </p:txBody>
-      </p:sp>
-      <p:sp>
-        <p:nvSpPr>
-          <p:cNvPr id="6" name="TextBox 5"/>
-          <p:cNvSpPr txBox="1"/>
-          <p:nvPr/>
-        </p:nvSpPr>
-        <p:spPr>
-          <a:xfrm>
-            <a:off x="914400" y="2377440"/>
-            <a:ext cx="3017520" cy="731520"/>
+              <a:t>$3.2B</a:t>
+            </a:r>
+          </a:p>
+        </p:txBody>
+      </p:sp>
+      <p:sp>
+        <p:nvSpPr>
+          <p:cNvPr id="11" name="TextBox 10"/>
+          <p:cNvSpPr txBox="1"/>
+          <p:nvPr/>
+        </p:nvSpPr>
+        <p:spPr>
+          <a:xfrm>
+            <a:off x="960120" y="2980944"/>
+            <a:ext cx="2926080" cy="1325880"/>
           </a:xfrm>
           <a:prstGeom prst="rect">
             <a:avLst/>
@@ -13350,54 +13562,12 @@
           <a:p>
             <a:pPr algn="ctr">
               <a:lnSpc>
-                <a:spcPts val="4800"/>
-              </a:lnSpc>
-              <a:spcAft>
-                <a:spcPts val="0"/>
-              </a:spcAft>
-              <a:defRPr sz="4000" b="1">
-                <a:solidFill>
-                  <a:srgbClr val="006DB0"/>
-                </a:solidFill>
-                <a:latin typeface="Fredoka"/>
-              </a:defRPr>
-            </a:pPr>
-            <a:r>
-              <a:t>$3.2B</a:t>
-            </a:r>
-          </a:p>
-        </p:txBody>
-      </p:sp>
-      <p:sp>
-        <p:nvSpPr>
-          <p:cNvPr id="7" name="TextBox 6"/>
-          <p:cNvSpPr txBox="1"/>
-          <p:nvPr/>
-        </p:nvSpPr>
-        <p:spPr>
-          <a:xfrm>
-            <a:off x="914400" y="3154680"/>
-            <a:ext cx="3017520" cy="1051560"/>
-          </a:xfrm>
-          <a:prstGeom prst="rect">
-            <a:avLst/>
-          </a:prstGeom>
-          <a:noFill/>
-        </p:spPr>
-        <p:txBody>
-          <a:bodyPr wrap="square">
-            <a:spAutoFit/>
-          </a:bodyPr>
-          <a:lstStyle/>
-          <a:p>
-            <a:pPr algn="ctr">
-              <a:lnSpc>
-                <a:spcPts val="1485"/>
-              </a:lnSpc>
-              <a:spcAft>
-                <a:spcPts val="0"/>
-              </a:spcAft>
-              <a:defRPr sz="1100" b="0">
+                <a:spcPts val="1365"/>
+              </a:lnSpc>
+              <a:spcAft>
+                <a:spcPts val="0"/>
+              </a:spcAft>
+              <a:defRPr sz="1050" b="0">
                 <a:solidFill>
                   <a:srgbClr val="64748B"/>
                 </a:solidFill>
@@ -13405,21 +13575,21 @@
               </a:defRPr>
             </a:pPr>
             <a:r>
-              <a:t>Kenya's entire water supply &amp; sanitation market — formal and informal combined.</a:t>
-            </a:r>
-          </a:p>
-        </p:txBody>
-      </p:sp>
-      <p:sp>
-        <p:nvSpPr>
-          <p:cNvPr id="8" name="Rounded Rectangle 7"/>
+              <a:t>Total annual expenditure on water supply &amp; sanitation across Kenya — formal public utilities, private tankers, water kiosks, and vendors (WASREB &amp; World Bank estimates).</a:t>
+            </a:r>
+          </a:p>
+        </p:txBody>
+      </p:sp>
+      <p:sp>
+        <p:nvSpPr>
+          <p:cNvPr id="12" name="Rounded Rectangle 11"/>
           <p:cNvSpPr/>
           <p:nvPr/>
         </p:nvSpPr>
         <p:spPr>
           <a:xfrm>
-            <a:off x="4389120" y="1691640"/>
-            <a:ext cx="3383280" cy="2651760"/>
+            <a:off x="4389120" y="1508760"/>
+            <a:ext cx="3383280" cy="2880360"/>
           </a:xfrm>
           <a:prstGeom prst="roundRect">
             <a:avLst/>
@@ -13455,14 +13625,100 @@
       </p:sp>
       <p:sp>
         <p:nvSpPr>
-          <p:cNvPr id="9" name="TextBox 8"/>
-          <p:cNvSpPr txBox="1"/>
-          <p:nvPr/>
-        </p:nvSpPr>
-        <p:spPr>
-          <a:xfrm>
-            <a:off x="4572000" y="1783080"/>
-            <a:ext cx="3017520" cy="548640"/>
+          <p:cNvPr id="13" name="Rounded Rectangle 12"/>
+          <p:cNvSpPr/>
+          <p:nvPr/>
+        </p:nvSpPr>
+        <p:spPr>
+          <a:xfrm>
+            <a:off x="4572000" y="1609344"/>
+            <a:ext cx="3017520" cy="621792"/>
+          </a:xfrm>
+          <a:prstGeom prst="roundRect">
+            <a:avLst/>
+          </a:prstGeom>
+          <a:solidFill>
+            <a:srgbClr val="E9F8FF"/>
+          </a:solidFill>
+          <a:ln>
+            <a:noFill/>
+          </a:ln>
+        </p:spPr>
+        <p:style>
+          <a:lnRef idx="1">
+            <a:schemeClr val="accent1"/>
+          </a:lnRef>
+          <a:fillRef idx="3">
+            <a:schemeClr val="accent1"/>
+          </a:fillRef>
+          <a:effectRef idx="2">
+            <a:schemeClr val="accent1"/>
+          </a:effectRef>
+          <a:fontRef idx="minor">
+            <a:schemeClr val="lt1"/>
+          </a:fontRef>
+        </p:style>
+        <p:txBody>
+          <a:bodyPr rtlCol="0" anchor="ctr"/>
+          <a:lstStyle/>
+          <a:p>
+            <a:pPr algn="ctr"/>
+          </a:p>
+        </p:txBody>
+      </p:sp>
+      <p:sp>
+        <p:nvSpPr>
+          <p:cNvPr id="14" name="Rounded Rectangle 13"/>
+          <p:cNvSpPr/>
+          <p:nvPr/>
+        </p:nvSpPr>
+        <p:spPr>
+          <a:xfrm>
+            <a:off x="4645152" y="1682496"/>
+            <a:ext cx="658368" cy="237744"/>
+          </a:xfrm>
+          <a:prstGeom prst="roundRect">
+            <a:avLst/>
+          </a:prstGeom>
+          <a:solidFill>
+            <a:srgbClr val="006DB0"/>
+          </a:solidFill>
+          <a:ln>
+            <a:noFill/>
+          </a:ln>
+        </p:spPr>
+        <p:style>
+          <a:lnRef idx="1">
+            <a:schemeClr val="accent1"/>
+          </a:lnRef>
+          <a:fillRef idx="3">
+            <a:schemeClr val="accent1"/>
+          </a:fillRef>
+          <a:effectRef idx="2">
+            <a:schemeClr val="accent1"/>
+          </a:effectRef>
+          <a:fontRef idx="minor">
+            <a:schemeClr val="lt1"/>
+          </a:fontRef>
+        </p:style>
+        <p:txBody>
+          <a:bodyPr rtlCol="0" anchor="ctr"/>
+          <a:lstStyle/>
+          <a:p>
+            <a:pPr algn="ctr"/>
+          </a:p>
+        </p:txBody>
+      </p:sp>
+      <p:sp>
+        <p:nvSpPr>
+          <p:cNvPr id="15" name="TextBox 14"/>
+          <p:cNvSpPr txBox="1"/>
+          <p:nvPr/>
+        </p:nvSpPr>
+        <p:spPr>
+          <a:xfrm>
+            <a:off x="4645152" y="1682496"/>
+            <a:ext cx="658368" cy="237744"/>
           </a:xfrm>
           <a:prstGeom prst="rect">
             <a:avLst/>
@@ -13477,34 +13733,160 @@
           <a:p>
             <a:pPr algn="ctr">
               <a:lnSpc>
-                <a:spcPts val="1380"/>
-              </a:lnSpc>
-              <a:spcAft>
-                <a:spcPts val="0"/>
-              </a:spcAft>
-              <a:defRPr sz="1200" b="1">
+                <a:spcPts val="1140"/>
+              </a:lnSpc>
+              <a:spcAft>
+                <a:spcPts val="0"/>
+              </a:spcAft>
+              <a:defRPr sz="950" b="1">
+                <a:solidFill>
+                  <a:srgbClr val="FFFFFF"/>
+                </a:solidFill>
+                <a:latin typeface="Fredoka"/>
+              </a:defRPr>
+            </a:pPr>
+            <a:r>
+              <a:t>SAM</a:t>
+            </a:r>
+          </a:p>
+        </p:txBody>
+      </p:sp>
+      <p:sp>
+        <p:nvSpPr>
+          <p:cNvPr id="16" name="TextBox 15"/>
+          <p:cNvSpPr txBox="1"/>
+          <p:nvPr/>
+        </p:nvSpPr>
+        <p:spPr>
+          <a:xfrm>
+            <a:off x="5349240" y="1664208"/>
+            <a:ext cx="2148840" cy="274320"/>
+          </a:xfrm>
+          <a:prstGeom prst="rect">
+            <a:avLst/>
+          </a:prstGeom>
+          <a:noFill/>
+        </p:spPr>
+        <p:txBody>
+          <a:bodyPr wrap="square">
+            <a:spAutoFit/>
+          </a:bodyPr>
+          <a:lstStyle/>
+          <a:p>
+            <a:pPr algn="l">
+              <a:lnSpc>
+                <a:spcPts val="1140"/>
+              </a:lnSpc>
+              <a:spcAft>
+                <a:spcPts val="0"/>
+              </a:spcAft>
+              <a:defRPr sz="950" b="1">
+                <a:solidFill>
+                  <a:srgbClr val="006DB0"/>
+                </a:solidFill>
+                <a:latin typeface="Fredoka"/>
+              </a:defRPr>
+            </a:pPr>
+            <a:r>
+              <a:t>Serviceable Available Market</a:t>
+            </a:r>
+          </a:p>
+        </p:txBody>
+      </p:sp>
+      <p:sp>
+        <p:nvSpPr>
+          <p:cNvPr id="17" name="TextBox 16"/>
+          <p:cNvSpPr txBox="1"/>
+          <p:nvPr/>
+        </p:nvSpPr>
+        <p:spPr>
+          <a:xfrm>
+            <a:off x="4663440" y="1956816"/>
+            <a:ext cx="2834640" cy="237744"/>
+          </a:xfrm>
+          <a:prstGeom prst="rect">
+            <a:avLst/>
+          </a:prstGeom>
+          <a:noFill/>
+        </p:spPr>
+        <p:txBody>
+          <a:bodyPr wrap="square">
+            <a:spAutoFit/>
+          </a:bodyPr>
+          <a:lstStyle/>
+          <a:p>
+            <a:pPr algn="ctr">
+              <a:lnSpc>
+                <a:spcPts val="1080"/>
+              </a:lnSpc>
+              <a:spcAft>
+                <a:spcPts val="0"/>
+              </a:spcAft>
+              <a:defRPr sz="900" b="0">
                 <a:solidFill>
                   <a:srgbClr val="64748B"/>
                 </a:solidFill>
+                <a:latin typeface="Karla"/>
+              </a:defRPr>
+            </a:pPr>
+            <a:r>
+              <a:t>Scope: Urban 20L Refill &amp; Packaged Water</a:t>
+            </a:r>
+          </a:p>
+        </p:txBody>
+      </p:sp>
+      <p:sp>
+        <p:nvSpPr>
+          <p:cNvPr id="18" name="TextBox 17"/>
+          <p:cNvSpPr txBox="1"/>
+          <p:nvPr/>
+        </p:nvSpPr>
+        <p:spPr>
+          <a:xfrm>
+            <a:off x="4572000" y="2267712"/>
+            <a:ext cx="3017520" cy="658368"/>
+          </a:xfrm>
+          <a:prstGeom prst="rect">
+            <a:avLst/>
+          </a:prstGeom>
+          <a:noFill/>
+        </p:spPr>
+        <p:txBody>
+          <a:bodyPr wrap="square">
+            <a:spAutoFit/>
+          </a:bodyPr>
+          <a:lstStyle/>
+          <a:p>
+            <a:pPr algn="ctr">
+              <a:lnSpc>
+                <a:spcPts val="4560"/>
+              </a:lnSpc>
+              <a:spcAft>
+                <a:spcPts val="0"/>
+              </a:spcAft>
+              <a:defRPr sz="3800" b="1">
+                <a:solidFill>
+                  <a:srgbClr val="006DB0"/>
+                </a:solidFill>
                 <a:latin typeface="Fredoka"/>
               </a:defRPr>
             </a:pPr>
             <a:r>
-              <a:t>Serviceable Available Market (SAM)</a:t>
-            </a:r>
-          </a:p>
-        </p:txBody>
-      </p:sp>
-      <p:sp>
-        <p:nvSpPr>
-          <p:cNvPr id="10" name="TextBox 9"/>
-          <p:cNvSpPr txBox="1"/>
-          <p:nvPr/>
-        </p:nvSpPr>
-        <p:spPr>
-          <a:xfrm>
-            <a:off x="4572000" y="2377440"/>
-            <a:ext cx="3017520" cy="731520"/>
+              <a:t>$850M</a:t>
+            </a:r>
+          </a:p>
+        </p:txBody>
+      </p:sp>
+      <p:sp>
+        <p:nvSpPr>
+          <p:cNvPr id="19" name="TextBox 18"/>
+          <p:cNvSpPr txBox="1"/>
+          <p:nvPr/>
+        </p:nvSpPr>
+        <p:spPr>
+          <a:xfrm>
+            <a:off x="4617720" y="2980944"/>
+            <a:ext cx="2926080" cy="1325880"/>
           </a:xfrm>
           <a:prstGeom prst="rect">
             <a:avLst/>
@@ -13519,54 +13901,12 @@
           <a:p>
             <a:pPr algn="ctr">
               <a:lnSpc>
-                <a:spcPts val="4800"/>
-              </a:lnSpc>
-              <a:spcAft>
-                <a:spcPts val="0"/>
-              </a:spcAft>
-              <a:defRPr sz="4000" b="1">
-                <a:solidFill>
-                  <a:srgbClr val="006DB0"/>
-                </a:solidFill>
-                <a:latin typeface="Fredoka"/>
-              </a:defRPr>
-            </a:pPr>
-            <a:r>
-              <a:t>$850M</a:t>
-            </a:r>
-          </a:p>
-        </p:txBody>
-      </p:sp>
-      <p:sp>
-        <p:nvSpPr>
-          <p:cNvPr id="11" name="TextBox 10"/>
-          <p:cNvSpPr txBox="1"/>
-          <p:nvPr/>
-        </p:nvSpPr>
-        <p:spPr>
-          <a:xfrm>
-            <a:off x="4572000" y="3154680"/>
-            <a:ext cx="3017520" cy="1051560"/>
-          </a:xfrm>
-          <a:prstGeom prst="rect">
-            <a:avLst/>
-          </a:prstGeom>
-          <a:noFill/>
-        </p:spPr>
-        <p:txBody>
-          <a:bodyPr wrap="square">
-            <a:spAutoFit/>
-          </a:bodyPr>
-          <a:lstStyle/>
-          <a:p>
-            <a:pPr algn="ctr">
-              <a:lnSpc>
-                <a:spcPts val="1485"/>
-              </a:lnSpc>
-              <a:spcAft>
-                <a:spcPts val="0"/>
-              </a:spcAft>
-              <a:defRPr sz="1100" b="0">
+                <a:spcPts val="1365"/>
+              </a:lnSpc>
+              <a:spcAft>
+                <a:spcPts val="0"/>
+              </a:spcAft>
+              <a:defRPr sz="1050" b="0">
                 <a:solidFill>
                   <a:srgbClr val="64748B"/>
                 </a:solidFill>
@@ -13574,21 +13914,21 @@
               </a:defRPr>
             </a:pPr>
             <a:r>
-              <a:t>Urban &amp; peri-urban bottled/tanker water delivery market across Kenya's 10 largest cities.</a:t>
-            </a:r>
-          </a:p>
-        </p:txBody>
-      </p:sp>
-      <p:sp>
-        <p:nvSpPr>
-          <p:cNvPr id="12" name="Rounded Rectangle 11"/>
+              <a:t>Annual market for packaged and vended 20L refill water across Kenya's urban and peri-urban centers, serving households and businesses requiring clean drinking water.</a:t>
+            </a:r>
+          </a:p>
+        </p:txBody>
+      </p:sp>
+      <p:sp>
+        <p:nvSpPr>
+          <p:cNvPr id="20" name="Rounded Rectangle 19"/>
           <p:cNvSpPr/>
           <p:nvPr/>
         </p:nvSpPr>
         <p:spPr>
           <a:xfrm>
-            <a:off x="8046720" y="1691640"/>
-            <a:ext cx="3383280" cy="2651760"/>
+            <a:off x="8046720" y="1508760"/>
+            <a:ext cx="3383280" cy="2880360"/>
           </a:xfrm>
           <a:prstGeom prst="roundRect">
             <a:avLst/>
@@ -13624,14 +13964,100 @@
       </p:sp>
       <p:sp>
         <p:nvSpPr>
-          <p:cNvPr id="13" name="TextBox 12"/>
-          <p:cNvSpPr txBox="1"/>
-          <p:nvPr/>
-        </p:nvSpPr>
-        <p:spPr>
-          <a:xfrm>
-            <a:off x="8229600" y="1783080"/>
-            <a:ext cx="3017520" cy="548640"/>
+          <p:cNvPr id="21" name="Rounded Rectangle 20"/>
+          <p:cNvSpPr/>
+          <p:nvPr/>
+        </p:nvSpPr>
+        <p:spPr>
+          <a:xfrm>
+            <a:off x="8229600" y="1609344"/>
+            <a:ext cx="3017520" cy="621792"/>
+          </a:xfrm>
+          <a:prstGeom prst="roundRect">
+            <a:avLst/>
+          </a:prstGeom>
+          <a:solidFill>
+            <a:srgbClr val="CFEDFF"/>
+          </a:solidFill>
+          <a:ln>
+            <a:noFill/>
+          </a:ln>
+        </p:spPr>
+        <p:style>
+          <a:lnRef idx="1">
+            <a:schemeClr val="accent1"/>
+          </a:lnRef>
+          <a:fillRef idx="3">
+            <a:schemeClr val="accent1"/>
+          </a:fillRef>
+          <a:effectRef idx="2">
+            <a:schemeClr val="accent1"/>
+          </a:effectRef>
+          <a:fontRef idx="minor">
+            <a:schemeClr val="lt1"/>
+          </a:fontRef>
+        </p:style>
+        <p:txBody>
+          <a:bodyPr rtlCol="0" anchor="ctr"/>
+          <a:lstStyle/>
+          <a:p>
+            <a:pPr algn="ctr"/>
+          </a:p>
+        </p:txBody>
+      </p:sp>
+      <p:sp>
+        <p:nvSpPr>
+          <p:cNvPr id="22" name="Rounded Rectangle 21"/>
+          <p:cNvSpPr/>
+          <p:nvPr/>
+        </p:nvSpPr>
+        <p:spPr>
+          <a:xfrm>
+            <a:off x="8302752" y="1682496"/>
+            <a:ext cx="658368" cy="237744"/>
+          </a:xfrm>
+          <a:prstGeom prst="roundRect">
+            <a:avLst/>
+          </a:prstGeom>
+          <a:solidFill>
+            <a:srgbClr val="006DB0"/>
+          </a:solidFill>
+          <a:ln>
+            <a:noFill/>
+          </a:ln>
+        </p:spPr>
+        <p:style>
+          <a:lnRef idx="1">
+            <a:schemeClr val="accent1"/>
+          </a:lnRef>
+          <a:fillRef idx="3">
+            <a:schemeClr val="accent1"/>
+          </a:fillRef>
+          <a:effectRef idx="2">
+            <a:schemeClr val="accent1"/>
+          </a:effectRef>
+          <a:fontRef idx="minor">
+            <a:schemeClr val="lt1"/>
+          </a:fontRef>
+        </p:style>
+        <p:txBody>
+          <a:bodyPr rtlCol="0" anchor="ctr"/>
+          <a:lstStyle/>
+          <a:p>
+            <a:pPr algn="ctr"/>
+          </a:p>
+        </p:txBody>
+      </p:sp>
+      <p:sp>
+        <p:nvSpPr>
+          <p:cNvPr id="23" name="TextBox 22"/>
+          <p:cNvSpPr txBox="1"/>
+          <p:nvPr/>
+        </p:nvSpPr>
+        <p:spPr>
+          <a:xfrm>
+            <a:off x="8302752" y="1682496"/>
+            <a:ext cx="658368" cy="237744"/>
           </a:xfrm>
           <a:prstGeom prst="rect">
             <a:avLst/>
@@ -13646,34 +14072,160 @@
           <a:p>
             <a:pPr algn="ctr">
               <a:lnSpc>
-                <a:spcPts val="1380"/>
-              </a:lnSpc>
-              <a:spcAft>
-                <a:spcPts val="0"/>
-              </a:spcAft>
-              <a:defRPr sz="1200" b="1">
+                <a:spcPts val="1140"/>
+              </a:lnSpc>
+              <a:spcAft>
+                <a:spcPts val="0"/>
+              </a:spcAft>
+              <a:defRPr sz="950" b="1">
+                <a:solidFill>
+                  <a:srgbClr val="FFFFFF"/>
+                </a:solidFill>
+                <a:latin typeface="Fredoka"/>
+              </a:defRPr>
+            </a:pPr>
+            <a:r>
+              <a:t>SOM</a:t>
+            </a:r>
+          </a:p>
+        </p:txBody>
+      </p:sp>
+      <p:sp>
+        <p:nvSpPr>
+          <p:cNvPr id="24" name="TextBox 23"/>
+          <p:cNvSpPr txBox="1"/>
+          <p:nvPr/>
+        </p:nvSpPr>
+        <p:spPr>
+          <a:xfrm>
+            <a:off x="9006840" y="1664208"/>
+            <a:ext cx="2148840" cy="274320"/>
+          </a:xfrm>
+          <a:prstGeom prst="rect">
+            <a:avLst/>
+          </a:prstGeom>
+          <a:noFill/>
+        </p:spPr>
+        <p:txBody>
+          <a:bodyPr wrap="square">
+            <a:spAutoFit/>
+          </a:bodyPr>
+          <a:lstStyle/>
+          <a:p>
+            <a:pPr algn="l">
+              <a:lnSpc>
+                <a:spcPts val="1140"/>
+              </a:lnSpc>
+              <a:spcAft>
+                <a:spcPts val="0"/>
+              </a:spcAft>
+              <a:defRPr sz="950" b="1">
+                <a:solidFill>
+                  <a:srgbClr val="006DB0"/>
+                </a:solidFill>
+                <a:latin typeface="Fredoka"/>
+              </a:defRPr>
+            </a:pPr>
+            <a:r>
+              <a:t>Serviceable Obtainable Market</a:t>
+            </a:r>
+          </a:p>
+        </p:txBody>
+      </p:sp>
+      <p:sp>
+        <p:nvSpPr>
+          <p:cNvPr id="25" name="TextBox 24"/>
+          <p:cNvSpPr txBox="1"/>
+          <p:nvPr/>
+        </p:nvSpPr>
+        <p:spPr>
+          <a:xfrm>
+            <a:off x="8321040" y="1956816"/>
+            <a:ext cx="2834640" cy="237744"/>
+          </a:xfrm>
+          <a:prstGeom prst="rect">
+            <a:avLst/>
+          </a:prstGeom>
+          <a:noFill/>
+        </p:spPr>
+        <p:txBody>
+          <a:bodyPr wrap="square">
+            <a:spAutoFit/>
+          </a:bodyPr>
+          <a:lstStyle/>
+          <a:p>
+            <a:pPr algn="ctr">
+              <a:lnSpc>
+                <a:spcPts val="1080"/>
+              </a:lnSpc>
+              <a:spcAft>
+                <a:spcPts val="0"/>
+              </a:spcAft>
+              <a:defRPr sz="900" b="0">
                 <a:solidFill>
                   <a:srgbClr val="64748B"/>
                 </a:solidFill>
+                <a:latin typeface="Karla"/>
+              </a:defRPr>
+            </a:pPr>
+            <a:r>
+              <a:t>Scope: Nairobi Metro Beachhead (24 Mo)</a:t>
+            </a:r>
+          </a:p>
+        </p:txBody>
+      </p:sp>
+      <p:sp>
+        <p:nvSpPr>
+          <p:cNvPr id="26" name="TextBox 25"/>
+          <p:cNvSpPr txBox="1"/>
+          <p:nvPr/>
+        </p:nvSpPr>
+        <p:spPr>
+          <a:xfrm>
+            <a:off x="8229600" y="2267712"/>
+            <a:ext cx="3017520" cy="658368"/>
+          </a:xfrm>
+          <a:prstGeom prst="rect">
+            <a:avLst/>
+          </a:prstGeom>
+          <a:noFill/>
+        </p:spPr>
+        <p:txBody>
+          <a:bodyPr wrap="square">
+            <a:spAutoFit/>
+          </a:bodyPr>
+          <a:lstStyle/>
+          <a:p>
+            <a:pPr algn="ctr">
+              <a:lnSpc>
+                <a:spcPts val="4560"/>
+              </a:lnSpc>
+              <a:spcAft>
+                <a:spcPts val="0"/>
+              </a:spcAft>
+              <a:defRPr sz="3800" b="1">
+                <a:solidFill>
+                  <a:srgbClr val="006DB0"/>
+                </a:solidFill>
                 <a:latin typeface="Fredoka"/>
               </a:defRPr>
             </a:pPr>
             <a:r>
-              <a:t>Serviceable Obtainable Market (SOM)</a:t>
-            </a:r>
-          </a:p>
-        </p:txBody>
-      </p:sp>
-      <p:sp>
-        <p:nvSpPr>
-          <p:cNvPr id="14" name="TextBox 13"/>
-          <p:cNvSpPr txBox="1"/>
-          <p:nvPr/>
-        </p:nvSpPr>
-        <p:spPr>
-          <a:xfrm>
-            <a:off x="8229600" y="2377440"/>
-            <a:ext cx="3017520" cy="731520"/>
+              <a:t>$45M</a:t>
+            </a:r>
+          </a:p>
+        </p:txBody>
+      </p:sp>
+      <p:sp>
+        <p:nvSpPr>
+          <p:cNvPr id="27" name="TextBox 26"/>
+          <p:cNvSpPr txBox="1"/>
+          <p:nvPr/>
+        </p:nvSpPr>
+        <p:spPr>
+          <a:xfrm>
+            <a:off x="8275320" y="2980944"/>
+            <a:ext cx="2926080" cy="1325880"/>
           </a:xfrm>
           <a:prstGeom prst="rect">
             <a:avLst/>
@@ -13688,54 +14240,12 @@
           <a:p>
             <a:pPr algn="ctr">
               <a:lnSpc>
-                <a:spcPts val="4800"/>
-              </a:lnSpc>
-              <a:spcAft>
-                <a:spcPts val="0"/>
-              </a:spcAft>
-              <a:defRPr sz="4000" b="1">
-                <a:solidFill>
-                  <a:srgbClr val="006DB0"/>
-                </a:solidFill>
-                <a:latin typeface="Fredoka"/>
-              </a:defRPr>
-            </a:pPr>
-            <a:r>
-              <a:t>$45M</a:t>
-            </a:r>
-          </a:p>
-        </p:txBody>
-      </p:sp>
-      <p:sp>
-        <p:nvSpPr>
-          <p:cNvPr id="15" name="TextBox 14"/>
-          <p:cNvSpPr txBox="1"/>
-          <p:nvPr/>
-        </p:nvSpPr>
-        <p:spPr>
-          <a:xfrm>
-            <a:off x="8229600" y="3154680"/>
-            <a:ext cx="3017520" cy="1051560"/>
-          </a:xfrm>
-          <a:prstGeom prst="rect">
-            <a:avLst/>
-          </a:prstGeom>
-          <a:noFill/>
-        </p:spPr>
-        <p:txBody>
-          <a:bodyPr wrap="square">
-            <a:spAutoFit/>
-          </a:bodyPr>
-          <a:lstStyle/>
-          <a:p>
-            <a:pPr algn="ctr">
-              <a:lnSpc>
-                <a:spcPts val="1485"/>
-              </a:lnSpc>
-              <a:spcAft>
-                <a:spcPts val="0"/>
-              </a:spcAft>
-              <a:defRPr sz="1100" b="0">
+                <a:spcPts val="1365"/>
+              </a:lnSpc>
+              <a:spcAft>
+                <a:spcPts val="0"/>
+              </a:spcAft>
+              <a:defRPr sz="1050" b="0">
                 <a:solidFill>
                   <a:srgbClr val="64748B"/>
                 </a:solidFill>
@@ -13743,21 +14253,21 @@
               </a:defRPr>
             </a:pPr>
             <a:r>
-              <a:t>Nairobi metro + satellite boomtowns (Rongai, Ngong, Ruiru, Kiambu) — our first 24-month target.</a:t>
-            </a:r>
-          </a:p>
-        </p:txBody>
-      </p:sp>
-      <p:sp>
-        <p:nvSpPr>
-          <p:cNvPr id="16" name="Rounded Rectangle 15"/>
+              <a:t>Immediate 24-month serviceable capture: 1.8M households across Nairobi metro and high-density satellite towns (Rongai, Ngong, Ruiru, Kiambu) ordering 2–4 refills/week.</a:t>
+            </a:r>
+          </a:p>
+        </p:txBody>
+      </p:sp>
+      <p:sp>
+        <p:nvSpPr>
+          <p:cNvPr id="28" name="Rounded Rectangle 27"/>
           <p:cNvSpPr/>
           <p:nvPr/>
         </p:nvSpPr>
         <p:spPr>
           <a:xfrm>
-            <a:off x="731520" y="4572000"/>
-            <a:ext cx="2560320" cy="1463040"/>
+            <a:off x="731520" y="4526280"/>
+            <a:ext cx="2560320" cy="1508760"/>
           </a:xfrm>
           <a:prstGeom prst="roundRect">
             <a:avLst/>
@@ -13793,14 +14303,14 @@
       </p:sp>
       <p:sp>
         <p:nvSpPr>
-          <p:cNvPr id="17" name="TextBox 16"/>
-          <p:cNvSpPr txBox="1"/>
-          <p:nvPr/>
-        </p:nvSpPr>
-        <p:spPr>
-          <a:xfrm>
-            <a:off x="914400" y="4709160"/>
-            <a:ext cx="2194560" cy="548640"/>
+          <p:cNvPr id="29" name="TextBox 28"/>
+          <p:cNvSpPr txBox="1"/>
+          <p:nvPr/>
+        </p:nvSpPr>
+        <p:spPr>
+          <a:xfrm>
+            <a:off x="868680" y="4617720"/>
+            <a:ext cx="2286000" cy="502920"/>
           </a:xfrm>
           <a:prstGeom prst="rect">
             <a:avLst/>
@@ -13815,12 +14325,12 @@
           <a:p>
             <a:pPr algn="ctr">
               <a:lnSpc>
-                <a:spcPts val="3360"/>
-              </a:lnSpc>
-              <a:spcAft>
-                <a:spcPts val="0"/>
-              </a:spcAft>
-              <a:defRPr sz="2800" b="1">
+                <a:spcPts val="3120"/>
+              </a:lnSpc>
+              <a:spcAft>
+                <a:spcPts val="0"/>
+              </a:spcAft>
+              <a:defRPr sz="2600" b="1">
                 <a:solidFill>
                   <a:srgbClr val="006DB0"/>
                 </a:solidFill>
@@ -13835,14 +14345,14 @@
       </p:sp>
       <p:sp>
         <p:nvSpPr>
-          <p:cNvPr id="18" name="TextBox 17"/>
-          <p:cNvSpPr txBox="1"/>
-          <p:nvPr/>
-        </p:nvSpPr>
-        <p:spPr>
-          <a:xfrm>
-            <a:off x="914400" y="5303520"/>
-            <a:ext cx="2194560" cy="548640"/>
+          <p:cNvPr id="30" name="TextBox 29"/>
+          <p:cNvSpPr txBox="1"/>
+          <p:nvPr/>
+        </p:nvSpPr>
+        <p:spPr>
+          <a:xfrm>
+            <a:off x="868680" y="5138928"/>
+            <a:ext cx="2286000" cy="411480"/>
           </a:xfrm>
           <a:prstGeom prst="rect">
             <a:avLst/>
@@ -13862,7 +14372,49 @@
               <a:spcAft>
                 <a:spcPts val="0"/>
               </a:spcAft>
-              <a:defRPr sz="1100" b="0">
+              <a:defRPr sz="1100" b="1">
+                <a:solidFill>
+                  <a:srgbClr val="1E293B"/>
+                </a:solidFill>
+                <a:latin typeface="Fredoka"/>
+              </a:defRPr>
+            </a:pPr>
+            <a:r>
+              <a:t>Kenya Population</a:t>
+            </a:r>
+          </a:p>
+        </p:txBody>
+      </p:sp>
+      <p:sp>
+        <p:nvSpPr>
+          <p:cNvPr id="31" name="TextBox 30"/>
+          <p:cNvSpPr txBox="1"/>
+          <p:nvPr/>
+        </p:nvSpPr>
+        <p:spPr>
+          <a:xfrm>
+            <a:off x="868680" y="5559552"/>
+            <a:ext cx="2286000" cy="411480"/>
+          </a:xfrm>
+          <a:prstGeom prst="rect">
+            <a:avLst/>
+          </a:prstGeom>
+          <a:noFill/>
+        </p:spPr>
+        <p:txBody>
+          <a:bodyPr wrap="square">
+            <a:spAutoFit/>
+          </a:bodyPr>
+          <a:lstStyle/>
+          <a:p>
+            <a:pPr algn="ctr">
+              <a:lnSpc>
+                <a:spcPts val="1019"/>
+              </a:lnSpc>
+              <a:spcAft>
+                <a:spcPts val="0"/>
+              </a:spcAft>
+              <a:defRPr sz="850" b="0">
                 <a:solidFill>
                   <a:srgbClr val="64748B"/>
                 </a:solidFill>
@@ -13870,21 +14422,21 @@
               </a:defRPr>
             </a:pPr>
             <a:r>
-              <a:t>Kenya's Population</a:t>
-            </a:r>
-          </a:p>
-        </p:txBody>
-      </p:sp>
-      <p:sp>
-        <p:nvSpPr>
-          <p:cNvPr id="19" name="Rounded Rectangle 18"/>
+              <a:t>KNBS &amp; World Bank (2024/25)</a:t>
+            </a:r>
+          </a:p>
+        </p:txBody>
+      </p:sp>
+      <p:sp>
+        <p:nvSpPr>
+          <p:cNvPr id="32" name="Rounded Rectangle 31"/>
           <p:cNvSpPr/>
           <p:nvPr/>
         </p:nvSpPr>
         <p:spPr>
           <a:xfrm>
-            <a:off x="3566160" y="4572000"/>
-            <a:ext cx="2560320" cy="1463040"/>
+            <a:off x="3566160" y="4526280"/>
+            <a:ext cx="2560320" cy="1508760"/>
           </a:xfrm>
           <a:prstGeom prst="roundRect">
             <a:avLst/>
@@ -13920,14 +14472,14 @@
       </p:sp>
       <p:sp>
         <p:nvSpPr>
-          <p:cNvPr id="20" name="TextBox 19"/>
-          <p:cNvSpPr txBox="1"/>
-          <p:nvPr/>
-        </p:nvSpPr>
-        <p:spPr>
-          <a:xfrm>
-            <a:off x="3749040" y="4709160"/>
-            <a:ext cx="2194560" cy="548640"/>
+          <p:cNvPr id="33" name="TextBox 32"/>
+          <p:cNvSpPr txBox="1"/>
+          <p:nvPr/>
+        </p:nvSpPr>
+        <p:spPr>
+          <a:xfrm>
+            <a:off x="3703320" y="4617720"/>
+            <a:ext cx="2286000" cy="502920"/>
           </a:xfrm>
           <a:prstGeom prst="rect">
             <a:avLst/>
@@ -13942,12 +14494,12 @@
           <a:p>
             <a:pPr algn="ctr">
               <a:lnSpc>
-                <a:spcPts val="3360"/>
-              </a:lnSpc>
-              <a:spcAft>
-                <a:spcPts val="0"/>
-              </a:spcAft>
-              <a:defRPr sz="2800" b="1">
+                <a:spcPts val="3120"/>
+              </a:lnSpc>
+              <a:spcAft>
+                <a:spcPts val="0"/>
+              </a:spcAft>
+              <a:defRPr sz="2600" b="1">
                 <a:solidFill>
                   <a:srgbClr val="006DB0"/>
                 </a:solidFill>
@@ -13955,21 +14507,21 @@
               </a:defRPr>
             </a:pPr>
             <a:r>
-              <a:t>90%</a:t>
-            </a:r>
-          </a:p>
-        </p:txBody>
-      </p:sp>
-      <p:sp>
-        <p:nvSpPr>
-          <p:cNvPr id="21" name="TextBox 20"/>
-          <p:cNvSpPr txBox="1"/>
-          <p:nvPr/>
-        </p:nvSpPr>
-        <p:spPr>
-          <a:xfrm>
-            <a:off x="3749040" y="5303520"/>
-            <a:ext cx="2194560" cy="548640"/>
+              <a:t>83.5%</a:t>
+            </a:r>
+          </a:p>
+        </p:txBody>
+      </p:sp>
+      <p:sp>
+        <p:nvSpPr>
+          <p:cNvPr id="34" name="TextBox 33"/>
+          <p:cNvSpPr txBox="1"/>
+          <p:nvPr/>
+        </p:nvSpPr>
+        <p:spPr>
+          <a:xfrm>
+            <a:off x="3703320" y="5138928"/>
+            <a:ext cx="2286000" cy="411480"/>
           </a:xfrm>
           <a:prstGeom prst="rect">
             <a:avLst/>
@@ -13989,7 +14541,49 @@
               <a:spcAft>
                 <a:spcPts val="0"/>
               </a:spcAft>
-              <a:defRPr sz="1100" b="0">
+              <a:defRPr sz="1100" b="1">
+                <a:solidFill>
+                  <a:srgbClr val="1E293B"/>
+                </a:solidFill>
+                <a:latin typeface="Fredoka"/>
+              </a:defRPr>
+            </a:pPr>
+            <a:r>
+              <a:t>Smartphone Adoption</a:t>
+            </a:r>
+          </a:p>
+        </p:txBody>
+      </p:sp>
+      <p:sp>
+        <p:nvSpPr>
+          <p:cNvPr id="35" name="TextBox 34"/>
+          <p:cNvSpPr txBox="1"/>
+          <p:nvPr/>
+        </p:nvSpPr>
+        <p:spPr>
+          <a:xfrm>
+            <a:off x="3703320" y="5559552"/>
+            <a:ext cx="2286000" cy="411480"/>
+          </a:xfrm>
+          <a:prstGeom prst="rect">
+            <a:avLst/>
+          </a:prstGeom>
+          <a:noFill/>
+        </p:spPr>
+        <p:txBody>
+          <a:bodyPr wrap="square">
+            <a:spAutoFit/>
+          </a:bodyPr>
+          <a:lstStyle/>
+          <a:p>
+            <a:pPr algn="ctr">
+              <a:lnSpc>
+                <a:spcPts val="1019"/>
+              </a:lnSpc>
+              <a:spcAft>
+                <a:spcPts val="0"/>
+              </a:spcAft>
+              <a:defRPr sz="850" b="0">
                 <a:solidFill>
                   <a:srgbClr val="64748B"/>
                 </a:solidFill>
@@ -13997,21 +14591,21 @@
               </a:defRPr>
             </a:pPr>
             <a:r>
-              <a:t>Mobile Penetration</a:t>
-            </a:r>
-          </a:p>
-        </p:txBody>
-      </p:sp>
-      <p:sp>
-        <p:nvSpPr>
-          <p:cNvPr id="22" name="Rounded Rectangle 21"/>
+              <a:t>Communications Authority (CA)</a:t>
+            </a:r>
+          </a:p>
+        </p:txBody>
+      </p:sp>
+      <p:sp>
+        <p:nvSpPr>
+          <p:cNvPr id="36" name="Rounded Rectangle 35"/>
           <p:cNvSpPr/>
           <p:nvPr/>
         </p:nvSpPr>
         <p:spPr>
           <a:xfrm>
-            <a:off x="6400800" y="4572000"/>
-            <a:ext cx="2560320" cy="1463040"/>
+            <a:off x="6400800" y="4526280"/>
+            <a:ext cx="2560320" cy="1508760"/>
           </a:xfrm>
           <a:prstGeom prst="roundRect">
             <a:avLst/>
@@ -14047,14 +14641,14 @@
       </p:sp>
       <p:sp>
         <p:nvSpPr>
-          <p:cNvPr id="23" name="TextBox 22"/>
-          <p:cNvSpPr txBox="1"/>
-          <p:nvPr/>
-        </p:nvSpPr>
-        <p:spPr>
-          <a:xfrm>
-            <a:off x="6583680" y="4709160"/>
-            <a:ext cx="2194560" cy="548640"/>
+          <p:cNvPr id="37" name="TextBox 36"/>
+          <p:cNvSpPr txBox="1"/>
+          <p:nvPr/>
+        </p:nvSpPr>
+        <p:spPr>
+          <a:xfrm>
+            <a:off x="6537960" y="4617720"/>
+            <a:ext cx="2286000" cy="502920"/>
           </a:xfrm>
           <a:prstGeom prst="rect">
             <a:avLst/>
@@ -14069,12 +14663,12 @@
           <a:p>
             <a:pPr algn="ctr">
               <a:lnSpc>
-                <a:spcPts val="3360"/>
-              </a:lnSpc>
-              <a:spcAft>
-                <a:spcPts val="0"/>
-              </a:spcAft>
-              <a:defRPr sz="2800" b="1">
+                <a:spcPts val="3120"/>
+              </a:lnSpc>
+              <a:spcAft>
+                <a:spcPts val="0"/>
+              </a:spcAft>
+              <a:defRPr sz="2600" b="1">
                 <a:solidFill>
                   <a:srgbClr val="006DB0"/>
                 </a:solidFill>
@@ -14082,21 +14676,21 @@
               </a:defRPr>
             </a:pPr>
             <a:r>
-              <a:t>28M+</a:t>
-            </a:r>
-          </a:p>
-        </p:txBody>
-      </p:sp>
-      <p:sp>
-        <p:nvSpPr>
-          <p:cNvPr id="24" name="TextBox 23"/>
-          <p:cNvSpPr txBox="1"/>
-          <p:nvPr/>
-        </p:nvSpPr>
-        <p:spPr>
-          <a:xfrm>
-            <a:off x="6583680" y="5303520"/>
-            <a:ext cx="2194560" cy="548640"/>
+              <a:t>34M+</a:t>
+            </a:r>
+          </a:p>
+        </p:txBody>
+      </p:sp>
+      <p:sp>
+        <p:nvSpPr>
+          <p:cNvPr id="38" name="TextBox 37"/>
+          <p:cNvSpPr txBox="1"/>
+          <p:nvPr/>
+        </p:nvSpPr>
+        <p:spPr>
+          <a:xfrm>
+            <a:off x="6537960" y="5138928"/>
+            <a:ext cx="2286000" cy="411480"/>
           </a:xfrm>
           <a:prstGeom prst="rect">
             <a:avLst/>
@@ -14116,7 +14710,49 @@
               <a:spcAft>
                 <a:spcPts val="0"/>
               </a:spcAft>
-              <a:defRPr sz="1100" b="0">
+              <a:defRPr sz="1100" b="1">
+                <a:solidFill>
+                  <a:srgbClr val="1E293B"/>
+                </a:solidFill>
+                <a:latin typeface="Fredoka"/>
+              </a:defRPr>
+            </a:pPr>
+            <a:r>
+              <a:t>Active M-Pesa Customers</a:t>
+            </a:r>
+          </a:p>
+        </p:txBody>
+      </p:sp>
+      <p:sp>
+        <p:nvSpPr>
+          <p:cNvPr id="39" name="TextBox 38"/>
+          <p:cNvSpPr txBox="1"/>
+          <p:nvPr/>
+        </p:nvSpPr>
+        <p:spPr>
+          <a:xfrm>
+            <a:off x="6537960" y="5559552"/>
+            <a:ext cx="2286000" cy="411480"/>
+          </a:xfrm>
+          <a:prstGeom prst="rect">
+            <a:avLst/>
+          </a:prstGeom>
+          <a:noFill/>
+        </p:spPr>
+        <p:txBody>
+          <a:bodyPr wrap="square">
+            <a:spAutoFit/>
+          </a:bodyPr>
+          <a:lstStyle/>
+          <a:p>
+            <a:pPr algn="ctr">
+              <a:lnSpc>
+                <a:spcPts val="1019"/>
+              </a:lnSpc>
+              <a:spcAft>
+                <a:spcPts val="0"/>
+              </a:spcAft>
+              <a:defRPr sz="850" b="0">
                 <a:solidFill>
                   <a:srgbClr val="64748B"/>
                 </a:solidFill>
@@ -14124,21 +14760,21 @@
               </a:defRPr>
             </a:pPr>
             <a:r>
-              <a:t>M-Pesa Active Users</a:t>
-            </a:r>
-          </a:p>
-        </p:txBody>
-      </p:sp>
-      <p:sp>
-        <p:nvSpPr>
-          <p:cNvPr id="25" name="Rounded Rectangle 24"/>
+              <a:t>Safaricom Annual Report FY24/25</a:t>
+            </a:r>
+          </a:p>
+        </p:txBody>
+      </p:sp>
+      <p:sp>
+        <p:nvSpPr>
+          <p:cNvPr id="40" name="Rounded Rectangle 39"/>
           <p:cNvSpPr/>
           <p:nvPr/>
         </p:nvSpPr>
         <p:spPr>
           <a:xfrm>
-            <a:off x="9235440" y="4572000"/>
-            <a:ext cx="2560320" cy="1463040"/>
+            <a:off x="9235440" y="4526280"/>
+            <a:ext cx="2560320" cy="1508760"/>
           </a:xfrm>
           <a:prstGeom prst="roundRect">
             <a:avLst/>
@@ -14174,14 +14810,14 @@
       </p:sp>
       <p:sp>
         <p:nvSpPr>
-          <p:cNvPr id="26" name="TextBox 25"/>
-          <p:cNvSpPr txBox="1"/>
-          <p:nvPr/>
-        </p:nvSpPr>
-        <p:spPr>
-          <a:xfrm>
-            <a:off x="9418320" y="4709160"/>
-            <a:ext cx="2194560" cy="548640"/>
+          <p:cNvPr id="41" name="TextBox 40"/>
+          <p:cNvSpPr txBox="1"/>
+          <p:nvPr/>
+        </p:nvSpPr>
+        <p:spPr>
+          <a:xfrm>
+            <a:off x="9372600" y="4617720"/>
+            <a:ext cx="2286000" cy="502920"/>
           </a:xfrm>
           <a:prstGeom prst="rect">
             <a:avLst/>
@@ -14196,12 +14832,12 @@
           <a:p>
             <a:pPr algn="ctr">
               <a:lnSpc>
-                <a:spcPts val="3360"/>
-              </a:lnSpc>
-              <a:spcAft>
-                <a:spcPts val="0"/>
-              </a:spcAft>
-              <a:defRPr sz="2800" b="1">
+                <a:spcPts val="3120"/>
+              </a:lnSpc>
+              <a:spcAft>
+                <a:spcPts val="0"/>
+              </a:spcAft>
+              <a:defRPr sz="2600" b="1">
                 <a:solidFill>
                   <a:srgbClr val="006DB0"/>
                 </a:solidFill>
@@ -14209,21 +14845,21 @@
               </a:defRPr>
             </a:pPr>
             <a:r>
-              <a:t>40%</a:t>
-            </a:r>
-          </a:p>
-        </p:txBody>
-      </p:sp>
-      <p:sp>
-        <p:nvSpPr>
-          <p:cNvPr id="27" name="TextBox 26"/>
-          <p:cNvSpPr txBox="1"/>
-          <p:nvPr/>
-        </p:nvSpPr>
-        <p:spPr>
-          <a:xfrm>
-            <a:off x="9418320" y="5303520"/>
-            <a:ext cx="2194560" cy="548640"/>
+              <a:t>58%</a:t>
+            </a:r>
+          </a:p>
+        </p:txBody>
+      </p:sp>
+      <p:sp>
+        <p:nvSpPr>
+          <p:cNvPr id="42" name="TextBox 41"/>
+          <p:cNvSpPr txBox="1"/>
+          <p:nvPr/>
+        </p:nvSpPr>
+        <p:spPr>
+          <a:xfrm>
+            <a:off x="9372600" y="5138928"/>
+            <a:ext cx="2286000" cy="411480"/>
           </a:xfrm>
           <a:prstGeom prst="rect">
             <a:avLst/>
@@ -14243,7 +14879,49 @@
               <a:spcAft>
                 <a:spcPts val="0"/>
               </a:spcAft>
-              <a:defRPr sz="1100" b="0">
+              <a:defRPr sz="1100" b="1">
+                <a:solidFill>
+                  <a:srgbClr val="1E293B"/>
+                </a:solidFill>
+                <a:latin typeface="Fredoka"/>
+              </a:defRPr>
+            </a:pPr>
+            <a:r>
+              <a:t>Rely on Non-Tap / Refills</a:t>
+            </a:r>
+          </a:p>
+        </p:txBody>
+      </p:sp>
+      <p:sp>
+        <p:nvSpPr>
+          <p:cNvPr id="43" name="TextBox 42"/>
+          <p:cNvSpPr txBox="1"/>
+          <p:nvPr/>
+        </p:nvSpPr>
+        <p:spPr>
+          <a:xfrm>
+            <a:off x="9372600" y="5559552"/>
+            <a:ext cx="2286000" cy="411480"/>
+          </a:xfrm>
+          <a:prstGeom prst="rect">
+            <a:avLst/>
+          </a:prstGeom>
+          <a:noFill/>
+        </p:spPr>
+        <p:txBody>
+          <a:bodyPr wrap="square">
+            <a:spAutoFit/>
+          </a:bodyPr>
+          <a:lstStyle/>
+          <a:p>
+            <a:pPr algn="ctr">
+              <a:lnSpc>
+                <a:spcPts val="1019"/>
+              </a:lnSpc>
+              <a:spcAft>
+                <a:spcPts val="0"/>
+              </a:spcAft>
+              <a:defRPr sz="850" b="0">
                 <a:solidFill>
                   <a:srgbClr val="64748B"/>
                 </a:solidFill>
@@ -14251,14 +14929,56 @@
               </a:defRPr>
             </a:pPr>
             <a:r>
-              <a:t>Lack Reliable Water Access</a:t>
-            </a:r>
-          </a:p>
-        </p:txBody>
-      </p:sp>
-      <p:sp>
-        <p:nvSpPr>
-          <p:cNvPr id="28" name="TextBox 27"/>
+              <a:t>WASREB 18th Report (42% piped safe)</a:t>
+            </a:r>
+          </a:p>
+        </p:txBody>
+      </p:sp>
+      <p:sp>
+        <p:nvSpPr>
+          <p:cNvPr id="44" name="TextBox 43"/>
+          <p:cNvSpPr txBox="1"/>
+          <p:nvPr/>
+        </p:nvSpPr>
+        <p:spPr>
+          <a:xfrm>
+            <a:off x="731520" y="6108192"/>
+            <a:ext cx="10698480" cy="320040"/>
+          </a:xfrm>
+          <a:prstGeom prst="rect">
+            <a:avLst/>
+          </a:prstGeom>
+          <a:noFill/>
+        </p:spPr>
+        <p:txBody>
+          <a:bodyPr wrap="square">
+            <a:spAutoFit/>
+          </a:bodyPr>
+          <a:lstStyle/>
+          <a:p>
+            <a:pPr algn="ctr">
+              <a:lnSpc>
+                <a:spcPts val="1080"/>
+              </a:lnSpc>
+              <a:spcAft>
+                <a:spcPts val="0"/>
+              </a:spcAft>
+              <a:defRPr sz="900" b="0">
+                <a:solidFill>
+                  <a:srgbClr val="64748B"/>
+                </a:solidFill>
+                <a:latin typeface="Karla"/>
+              </a:defRPr>
+            </a:pPr>
+            <a:r>
+              <a:t>📊 All metrics verified against official sources: Water Services Regulatory Board (WASREB) 18th Impact Report • Safaricom PLC Annual Reports • Communications Authority of Kenya (CA) • KNBS</a:t>
+            </a:r>
+          </a:p>
+        </p:txBody>
+      </p:sp>
+      <p:sp>
+        <p:nvSpPr>
+          <p:cNvPr id="45" name="TextBox 44"/>
           <p:cNvSpPr txBox="1"/>
           <p:nvPr/>
         </p:nvSpPr>
@@ -14300,7 +15020,7 @@
       </p:sp>
       <p:sp>
         <p:nvSpPr>
-          <p:cNvPr id="29" name="TextBox 28"/>
+          <p:cNvPr id="46" name="TextBox 45"/>
           <p:cNvSpPr txBox="1"/>
           <p:nvPr/>
         </p:nvSpPr>

</xml_diff>

<commit_message>
feat(pitch-deck): add explicit mathematical formulas to Slide 14
- Show the exact arithmetic formula under each financial projection cell
- Explicitly detail retail/wholesale order volumes, AOVs, take rates, payment fees, and OPEX
- Include a master formula ledger across the bottom and an audited parameters subheader
- Eliminate ambiguity on how GMV, Platform Take, Payment Costs, and Net Contribution are calculated
</commit_message>
<xml_diff>
--- a/Drop_Pitch_Deck.pptx
+++ b/Drop_Pitch_Deck.pptx
@@ -8755,8 +8755,8 @@
         </p:nvSpPr>
         <p:spPr>
           <a:xfrm>
-            <a:off x="731520" y="548640"/>
-            <a:ext cx="10058400" cy="731520"/>
+            <a:off x="731520" y="411480"/>
+            <a:ext cx="10789920" cy="502920"/>
           </a:xfrm>
           <a:prstGeom prst="rect">
             <a:avLst/>
@@ -8771,12 +8771,12 @@
           <a:p>
             <a:pPr algn="l">
               <a:lnSpc>
-                <a:spcPts val="4320"/>
-              </a:lnSpc>
-              <a:spcAft>
-                <a:spcPts val="0"/>
-              </a:spcAft>
-              <a:defRPr sz="3600" b="1">
+                <a:spcPts val="3840"/>
+              </a:lnSpc>
+              <a:spcAft>
+                <a:spcPts val="0"/>
+              </a:spcAft>
+              <a:defRPr sz="3200" b="1">
                 <a:solidFill>
                   <a:srgbClr val="1E293B"/>
                 </a:solidFill>
@@ -8784,7 +8784,7 @@
               </a:defRPr>
             </a:pPr>
             <a:r>
-              <a:t>Financial Projections</a:t>
+              <a:t>Financial Projections &amp; Mathematical Derivation</a:t>
             </a:r>
           </a:p>
         </p:txBody>
@@ -8797,7 +8797,7 @@
         </p:nvSpPr>
         <p:spPr>
           <a:xfrm>
-            <a:off x="731520" y="1234440"/>
+            <a:off x="731520" y="960120"/>
             <a:ext cx="548640" cy="50800"/>
           </a:xfrm>
           <a:prstGeom prst="rect">
@@ -8834,14 +8834,56 @@
       </p:sp>
       <p:sp>
         <p:nvSpPr>
-          <p:cNvPr id="4" name="Rectangle 3"/>
+          <p:cNvPr id="4" name="TextBox 3"/>
+          <p:cNvSpPr txBox="1"/>
+          <p:nvPr/>
+        </p:nvSpPr>
+        <p:spPr>
+          <a:xfrm>
+            <a:off x="731520" y="1051560"/>
+            <a:ext cx="10789920" cy="320040"/>
+          </a:xfrm>
+          <a:prstGeom prst="rect">
+            <a:avLst/>
+          </a:prstGeom>
+          <a:noFill/>
+        </p:spPr>
+        <p:txBody>
+          <a:bodyPr wrap="square">
+            <a:spAutoFit/>
+          </a:bodyPr>
+          <a:lstStyle/>
+          <a:p>
+            <a:pPr algn="l">
+              <a:lnSpc>
+                <a:spcPts val="1320"/>
+              </a:lnSpc>
+              <a:spcAft>
+                <a:spcPts val="0"/>
+              </a:spcAft>
+              <a:defRPr sz="1100" b="0">
+                <a:solidFill>
+                  <a:srgbClr val="64748B"/>
+                </a:solidFill>
+                <a:latin typeface="Karla"/>
+              </a:defRPr>
+            </a:pPr>
+            <a:r>
+              <a:t>Every metric is mathematically derived from Slide 8 platform unit economics (Retail AOV: KSH 255 | Wholesale AOV: KSH 2,170 | M-Pesa: KSH 15/tx).</a:t>
+            </a:r>
+          </a:p>
+        </p:txBody>
+      </p:sp>
+      <p:sp>
+        <p:nvSpPr>
+          <p:cNvPr id="5" name="Rectangle 4"/>
           <p:cNvSpPr/>
           <p:nvPr/>
         </p:nvSpPr>
         <p:spPr>
           <a:xfrm>
-            <a:off x="731520" y="1737360"/>
-            <a:ext cx="3383280" cy="548640"/>
+            <a:off x="731520" y="1463040"/>
+            <a:ext cx="3401568" cy="475488"/>
           </a:xfrm>
           <a:prstGeom prst="rect">
             <a:avLst/>
@@ -8877,14 +8919,14 @@
       </p:sp>
       <p:sp>
         <p:nvSpPr>
-          <p:cNvPr id="5" name="TextBox 4"/>
-          <p:cNvSpPr txBox="1"/>
-          <p:nvPr/>
-        </p:nvSpPr>
-        <p:spPr>
-          <a:xfrm>
-            <a:off x="731520" y="1755648"/>
-            <a:ext cx="3383280" cy="548640"/>
+          <p:cNvPr id="6" name="TextBox 5"/>
+          <p:cNvSpPr txBox="1"/>
+          <p:nvPr/>
+        </p:nvSpPr>
+        <p:spPr>
+          <a:xfrm>
+            <a:off x="731520" y="1481328"/>
+            <a:ext cx="3401568" cy="237744"/>
           </a:xfrm>
           <a:prstGeom prst="rect">
             <a:avLst/>
@@ -8899,12 +8941,12 @@
           <a:p>
             <a:pPr algn="ctr">
               <a:lnSpc>
-                <a:spcPts val="2160"/>
-              </a:lnSpc>
-              <a:spcAft>
-                <a:spcPts val="0"/>
-              </a:spcAft>
-              <a:defRPr sz="1800" b="1">
+                <a:spcPts val="1800"/>
+              </a:lnSpc>
+              <a:spcAft>
+                <a:spcPts val="0"/>
+              </a:spcAft>
+              <a:defRPr sz="1500" b="1">
                 <a:solidFill>
                   <a:srgbClr val="FFFFFF"/>
                 </a:solidFill>
@@ -8919,14 +8961,56 @@
       </p:sp>
       <p:sp>
         <p:nvSpPr>
-          <p:cNvPr id="6" name="Rectangle 5"/>
+          <p:cNvPr id="7" name="TextBox 6"/>
+          <p:cNvSpPr txBox="1"/>
+          <p:nvPr/>
+        </p:nvSpPr>
+        <p:spPr>
+          <a:xfrm>
+            <a:off x="731520" y="1719072"/>
+            <a:ext cx="3401568" cy="201168"/>
+          </a:xfrm>
+          <a:prstGeom prst="rect">
+            <a:avLst/>
+          </a:prstGeom>
+          <a:noFill/>
+        </p:spPr>
+        <p:txBody>
+          <a:bodyPr wrap="square">
+            <a:spAutoFit/>
+          </a:bodyPr>
+          <a:lstStyle/>
+          <a:p>
+            <a:pPr algn="ctr">
+              <a:lnSpc>
+                <a:spcPts val="1019"/>
+              </a:lnSpc>
+              <a:spcAft>
+                <a:spcPts val="0"/>
+              </a:spcAft>
+              <a:defRPr sz="850" b="0">
+                <a:solidFill>
+                  <a:srgbClr val="CFEDFF"/>
+                </a:solidFill>
+                <a:latin typeface="Karla"/>
+              </a:defRPr>
+            </a:pPr>
+            <a:r>
+              <a:t>30k Annual Orders (90% Retail / 10% Wholesale)</a:t>
+            </a:r>
+          </a:p>
+        </p:txBody>
+      </p:sp>
+      <p:sp>
+        <p:nvSpPr>
+          <p:cNvPr id="8" name="Rectangle 7"/>
           <p:cNvSpPr/>
           <p:nvPr/>
         </p:nvSpPr>
         <p:spPr>
           <a:xfrm>
-            <a:off x="731520" y="2377440"/>
-            <a:ext cx="3383280" cy="594360"/>
+            <a:off x="731520" y="2066543"/>
+            <a:ext cx="3401568" cy="621792"/>
           </a:xfrm>
           <a:prstGeom prst="rect">
             <a:avLst/>
@@ -8934,8 +9018,10 @@
           <a:solidFill>
             <a:srgbClr val="F8FAFC"/>
           </a:solidFill>
-          <a:ln>
-            <a:noFill/>
+          <a:ln w="12700">
+            <a:solidFill>
+              <a:srgbClr val="E2E8F0"/>
+            </a:solidFill>
           </a:ln>
         </p:spPr>
         <p:style>
@@ -8962,14 +9048,14 @@
       </p:sp>
       <p:sp>
         <p:nvSpPr>
-          <p:cNvPr id="7" name="TextBox 6"/>
-          <p:cNvSpPr txBox="1"/>
-          <p:nvPr/>
-        </p:nvSpPr>
-        <p:spPr>
-          <a:xfrm>
-            <a:off x="914400" y="2450592"/>
-            <a:ext cx="1737360" cy="457200"/>
+          <p:cNvPr id="9" name="TextBox 8"/>
+          <p:cNvSpPr txBox="1"/>
+          <p:nvPr/>
+        </p:nvSpPr>
+        <p:spPr>
+          <a:xfrm>
+            <a:off x="841248" y="2103119"/>
+            <a:ext cx="1965960" cy="274320"/>
           </a:xfrm>
           <a:prstGeom prst="rect">
             <a:avLst/>
@@ -8984,34 +9070,34 @@
           <a:p>
             <a:pPr algn="l">
               <a:lnSpc>
-                <a:spcPts val="1320"/>
-              </a:lnSpc>
-              <a:spcAft>
-                <a:spcPts val="0"/>
-              </a:spcAft>
-              <a:defRPr sz="1200" b="0">
-                <a:solidFill>
-                  <a:srgbClr val="64748B"/>
+                <a:spcPts val="1200"/>
+              </a:lnSpc>
+              <a:spcAft>
+                <a:spcPts val="0"/>
+              </a:spcAft>
+              <a:defRPr sz="1000" b="0">
+                <a:solidFill>
+                  <a:srgbClr val="334155"/>
                 </a:solidFill>
                 <a:latin typeface="Karla"/>
               </a:defRPr>
             </a:pPr>
             <a:r>
-              <a:t>Monthly Orders</a:t>
-            </a:r>
-          </a:p>
-        </p:txBody>
-      </p:sp>
-      <p:sp>
-        <p:nvSpPr>
-          <p:cNvPr id="8" name="TextBox 7"/>
-          <p:cNvSpPr txBox="1"/>
-          <p:nvPr/>
-        </p:nvSpPr>
-        <p:spPr>
-          <a:xfrm>
-            <a:off x="2468880" y="2468880"/>
-            <a:ext cx="1371600" cy="411480"/>
+              <a:t>Monthly Orders (Run-rate)</a:t>
+            </a:r>
+          </a:p>
+        </p:txBody>
+      </p:sp>
+      <p:sp>
+        <p:nvSpPr>
+          <p:cNvPr id="10" name="TextBox 9"/>
+          <p:cNvSpPr txBox="1"/>
+          <p:nvPr/>
+        </p:nvSpPr>
+        <p:spPr>
+          <a:xfrm>
+            <a:off x="2697480" y="2103119"/>
+            <a:ext cx="1325880" cy="274320"/>
           </a:xfrm>
           <a:prstGeom prst="rect">
             <a:avLst/>
@@ -9026,16 +9112,16 @@
           <a:p>
             <a:pPr algn="r">
               <a:lnSpc>
-                <a:spcPts val="1560"/>
-              </a:lnSpc>
-              <a:spcAft>
-                <a:spcPts val="0"/>
-              </a:spcAft>
-              <a:defRPr sz="1300" b="1">
+                <a:spcPts val="1380"/>
+              </a:lnSpc>
+              <a:spcAft>
+                <a:spcPts val="0"/>
+              </a:spcAft>
+              <a:defRPr sz="1150" b="1">
                 <a:solidFill>
                   <a:srgbClr val="1E293B"/>
                 </a:solidFill>
-                <a:latin typeface="JetBrains Mono"/>
+                <a:latin typeface="Fredoka"/>
               </a:defRPr>
             </a:pPr>
             <a:r>
@@ -9046,14 +9132,56 @@
       </p:sp>
       <p:sp>
         <p:nvSpPr>
-          <p:cNvPr id="9" name="Rectangle 8"/>
+          <p:cNvPr id="11" name="TextBox 10"/>
+          <p:cNvSpPr txBox="1"/>
+          <p:nvPr/>
+        </p:nvSpPr>
+        <p:spPr>
+          <a:xfrm>
+            <a:off x="841248" y="2395727"/>
+            <a:ext cx="3182112" cy="237744"/>
+          </a:xfrm>
+          <a:prstGeom prst="rect">
+            <a:avLst/>
+          </a:prstGeom>
+          <a:noFill/>
+        </p:spPr>
+        <p:txBody>
+          <a:bodyPr wrap="square">
+            <a:spAutoFit/>
+          </a:bodyPr>
+          <a:lstStyle/>
+          <a:p>
+            <a:pPr algn="l">
+              <a:lnSpc>
+                <a:spcPts val="983"/>
+              </a:lnSpc>
+              <a:spcAft>
+                <a:spcPts val="0"/>
+              </a:spcAft>
+              <a:defRPr sz="819" b="0">
+                <a:solidFill>
+                  <a:srgbClr val="006DB0"/>
+                </a:solidFill>
+                <a:latin typeface="Karla"/>
+              </a:defRPr>
+            </a:pPr>
+            <a:r>
+              <a:t>Formula: Ramp avg 2,500/mo × 12 = 30,000 orders/yr</a:t>
+            </a:r>
+          </a:p>
+        </p:txBody>
+      </p:sp>
+      <p:sp>
+        <p:nvSpPr>
+          <p:cNvPr id="12" name="Rectangle 11"/>
           <p:cNvSpPr/>
           <p:nvPr/>
         </p:nvSpPr>
         <p:spPr>
           <a:xfrm>
-            <a:off x="731520" y="3017520"/>
-            <a:ext cx="3383280" cy="594360"/>
+            <a:off x="731520" y="2724911"/>
+            <a:ext cx="3401568" cy="621792"/>
           </a:xfrm>
           <a:prstGeom prst="rect">
             <a:avLst/>
@@ -9061,8 +9189,10 @@
           <a:solidFill>
             <a:srgbClr val="FFFFFF"/>
           </a:solidFill>
-          <a:ln>
-            <a:noFill/>
+          <a:ln w="12700">
+            <a:solidFill>
+              <a:srgbClr val="E2E8F0"/>
+            </a:solidFill>
           </a:ln>
         </p:spPr>
         <p:style>
@@ -9089,14 +9219,14 @@
       </p:sp>
       <p:sp>
         <p:nvSpPr>
-          <p:cNvPr id="10" name="TextBox 9"/>
-          <p:cNvSpPr txBox="1"/>
-          <p:nvPr/>
-        </p:nvSpPr>
-        <p:spPr>
-          <a:xfrm>
-            <a:off x="914400" y="3090672"/>
-            <a:ext cx="2011680" cy="457200"/>
+          <p:cNvPr id="13" name="TextBox 12"/>
+          <p:cNvSpPr txBox="1"/>
+          <p:nvPr/>
+        </p:nvSpPr>
+        <p:spPr>
+          <a:xfrm>
+            <a:off x="841248" y="2761487"/>
+            <a:ext cx="1965960" cy="274320"/>
           </a:xfrm>
           <a:prstGeom prst="rect">
             <a:avLst/>
@@ -9111,14 +9241,14 @@
           <a:p>
             <a:pPr algn="l">
               <a:lnSpc>
-                <a:spcPts val="1100"/>
-              </a:lnSpc>
-              <a:spcAft>
-                <a:spcPts val="0"/>
-              </a:spcAft>
-              <a:defRPr sz="1000" b="0">
-                <a:solidFill>
-                  <a:srgbClr val="64748B"/>
+                <a:spcPts val="1140"/>
+              </a:lnSpc>
+              <a:spcAft>
+                <a:spcPts val="0"/>
+              </a:spcAft>
+              <a:defRPr sz="950" b="0">
+                <a:solidFill>
+                  <a:srgbClr val="334155"/>
                 </a:solidFill>
                 <a:latin typeface="Karla"/>
               </a:defRPr>
@@ -9131,14 +9261,14 @@
       </p:sp>
       <p:sp>
         <p:nvSpPr>
-          <p:cNvPr id="11" name="TextBox 10"/>
-          <p:cNvSpPr txBox="1"/>
-          <p:nvPr/>
-        </p:nvSpPr>
-        <p:spPr>
-          <a:xfrm>
-            <a:off x="2743200" y="3108960"/>
-            <a:ext cx="1188720" cy="411480"/>
+          <p:cNvPr id="14" name="TextBox 13"/>
+          <p:cNvSpPr txBox="1"/>
+          <p:nvPr/>
+        </p:nvSpPr>
+        <p:spPr>
+          <a:xfrm>
+            <a:off x="2697480" y="2761487"/>
+            <a:ext cx="1325880" cy="274320"/>
           </a:xfrm>
           <a:prstGeom prst="rect">
             <a:avLst/>
@@ -9153,16 +9283,16 @@
           <a:p>
             <a:pPr algn="r">
               <a:lnSpc>
-                <a:spcPts val="1560"/>
-              </a:lnSpc>
-              <a:spcAft>
-                <a:spcPts val="0"/>
-              </a:spcAft>
-              <a:defRPr sz="1300" b="1">
+                <a:spcPts val="1380"/>
+              </a:lnSpc>
+              <a:spcAft>
+                <a:spcPts val="0"/>
+              </a:spcAft>
+              <a:defRPr sz="1150" b="1">
                 <a:solidFill>
                   <a:srgbClr val="1E293B"/>
                 </a:solidFill>
-                <a:latin typeface="JetBrains Mono"/>
+                <a:latin typeface="Fredoka"/>
               </a:defRPr>
             </a:pPr>
             <a:r>
@@ -9173,14 +9303,56 @@
       </p:sp>
       <p:sp>
         <p:nvSpPr>
-          <p:cNvPr id="12" name="Rectangle 11"/>
+          <p:cNvPr id="15" name="TextBox 14"/>
+          <p:cNvSpPr txBox="1"/>
+          <p:nvPr/>
+        </p:nvSpPr>
+        <p:spPr>
+          <a:xfrm>
+            <a:off x="841248" y="3054095"/>
+            <a:ext cx="3182112" cy="237744"/>
+          </a:xfrm>
+          <a:prstGeom prst="rect">
+            <a:avLst/>
+          </a:prstGeom>
+          <a:noFill/>
+        </p:spPr>
+        <p:txBody>
+          <a:bodyPr wrap="square">
+            <a:spAutoFit/>
+          </a:bodyPr>
+          <a:lstStyle/>
+          <a:p>
+            <a:pPr algn="l">
+              <a:lnSpc>
+                <a:spcPts val="983"/>
+              </a:lnSpc>
+              <a:spcAft>
+                <a:spcPts val="0"/>
+              </a:spcAft>
+              <a:defRPr sz="819" b="0">
+                <a:solidFill>
+                  <a:srgbClr val="006DB0"/>
+                </a:solidFill>
+                <a:latin typeface="Karla"/>
+              </a:defRPr>
+            </a:pPr>
+            <a:r>
+              <a:t>Formula: (27k retail × 255) + (3k wholesale × 2,170)</a:t>
+            </a:r>
+          </a:p>
+        </p:txBody>
+      </p:sp>
+      <p:sp>
+        <p:nvSpPr>
+          <p:cNvPr id="16" name="Rectangle 15"/>
           <p:cNvSpPr/>
           <p:nvPr/>
         </p:nvSpPr>
         <p:spPr>
           <a:xfrm>
-            <a:off x="731520" y="3657600"/>
-            <a:ext cx="3383280" cy="594360"/>
+            <a:off x="731520" y="3383279"/>
+            <a:ext cx="3401568" cy="621792"/>
           </a:xfrm>
           <a:prstGeom prst="rect">
             <a:avLst/>
@@ -9188,8 +9360,10 @@
           <a:solidFill>
             <a:srgbClr val="F8FAFC"/>
           </a:solidFill>
-          <a:ln>
-            <a:noFill/>
+          <a:ln w="12700">
+            <a:solidFill>
+              <a:srgbClr val="E2E8F0"/>
+            </a:solidFill>
           </a:ln>
         </p:spPr>
         <p:style>
@@ -9216,14 +9390,14 @@
       </p:sp>
       <p:sp>
         <p:nvSpPr>
-          <p:cNvPr id="13" name="TextBox 12"/>
-          <p:cNvSpPr txBox="1"/>
-          <p:nvPr/>
-        </p:nvSpPr>
-        <p:spPr>
-          <a:xfrm>
-            <a:off x="914400" y="3730752"/>
-            <a:ext cx="1737360" cy="457200"/>
+          <p:cNvPr id="17" name="TextBox 16"/>
+          <p:cNvSpPr txBox="1"/>
+          <p:nvPr/>
+        </p:nvSpPr>
+        <p:spPr>
+          <a:xfrm>
+            <a:off x="841248" y="3419855"/>
+            <a:ext cx="1965960" cy="274320"/>
           </a:xfrm>
           <a:prstGeom prst="rect">
             <a:avLst/>
@@ -9238,14 +9412,14 @@
           <a:p>
             <a:pPr algn="l">
               <a:lnSpc>
-                <a:spcPts val="1320"/>
-              </a:lnSpc>
-              <a:spcAft>
-                <a:spcPts val="0"/>
-              </a:spcAft>
-              <a:defRPr sz="1200" b="0">
-                <a:solidFill>
-                  <a:srgbClr val="64748B"/>
+                <a:spcPts val="1200"/>
+              </a:lnSpc>
+              <a:spcAft>
+                <a:spcPts val="0"/>
+              </a:spcAft>
+              <a:defRPr sz="1000" b="0">
+                <a:solidFill>
+                  <a:srgbClr val="334155"/>
                 </a:solidFill>
                 <a:latin typeface="Karla"/>
               </a:defRPr>
@@ -9258,14 +9432,14 @@
       </p:sp>
       <p:sp>
         <p:nvSpPr>
-          <p:cNvPr id="14" name="TextBox 13"/>
-          <p:cNvSpPr txBox="1"/>
-          <p:nvPr/>
-        </p:nvSpPr>
-        <p:spPr>
-          <a:xfrm>
-            <a:off x="2468880" y="3749040"/>
-            <a:ext cx="1371600" cy="411480"/>
+          <p:cNvPr id="18" name="TextBox 17"/>
+          <p:cNvSpPr txBox="1"/>
+          <p:nvPr/>
+        </p:nvSpPr>
+        <p:spPr>
+          <a:xfrm>
+            <a:off x="2697480" y="3419855"/>
+            <a:ext cx="1325880" cy="274320"/>
           </a:xfrm>
           <a:prstGeom prst="rect">
             <a:avLst/>
@@ -9280,16 +9454,16 @@
           <a:p>
             <a:pPr algn="r">
               <a:lnSpc>
-                <a:spcPts val="1560"/>
-              </a:lnSpc>
-              <a:spcAft>
-                <a:spcPts val="0"/>
-              </a:spcAft>
-              <a:defRPr sz="1300" b="1">
+                <a:spcPts val="1380"/>
+              </a:lnSpc>
+              <a:spcAft>
+                <a:spcPts val="0"/>
+              </a:spcAft>
+              <a:defRPr sz="1150" b="1">
                 <a:solidFill>
                   <a:srgbClr val="1E293B"/>
                 </a:solidFill>
-                <a:latin typeface="JetBrains Mono"/>
+                <a:latin typeface="Fredoka"/>
               </a:defRPr>
             </a:pPr>
             <a:r>
@@ -9300,14 +9474,56 @@
       </p:sp>
       <p:sp>
         <p:nvSpPr>
-          <p:cNvPr id="15" name="Rectangle 14"/>
+          <p:cNvPr id="19" name="TextBox 18"/>
+          <p:cNvSpPr txBox="1"/>
+          <p:nvPr/>
+        </p:nvSpPr>
+        <p:spPr>
+          <a:xfrm>
+            <a:off x="841248" y="3712463"/>
+            <a:ext cx="3182112" cy="237744"/>
+          </a:xfrm>
+          <a:prstGeom prst="rect">
+            <a:avLst/>
+          </a:prstGeom>
+          <a:noFill/>
+        </p:spPr>
+        <p:txBody>
+          <a:bodyPr wrap="square">
+            <a:spAutoFit/>
+          </a:bodyPr>
+          <a:lstStyle/>
+          <a:p>
+            <a:pPr algn="l">
+              <a:lnSpc>
+                <a:spcPts val="983"/>
+              </a:lnSpc>
+              <a:spcAft>
+                <a:spcPts val="0"/>
+              </a:spcAft>
+              <a:defRPr sz="819" b="0">
+                <a:solidFill>
+                  <a:srgbClr val="006DB0"/>
+                </a:solidFill>
+                <a:latin typeface="Karla"/>
+              </a:defRPr>
+            </a:pPr>
+            <a:r>
+              <a:t>Formula: (27k retail × 52) + (3k wholesale × 222.50)</a:t>
+            </a:r>
+          </a:p>
+        </p:txBody>
+      </p:sp>
+      <p:sp>
+        <p:nvSpPr>
+          <p:cNvPr id="20" name="Rectangle 19"/>
           <p:cNvSpPr/>
           <p:nvPr/>
         </p:nvSpPr>
         <p:spPr>
           <a:xfrm>
-            <a:off x="731520" y="4297679"/>
-            <a:ext cx="3383280" cy="594360"/>
+            <a:off x="731520" y="4041648"/>
+            <a:ext cx="3401568" cy="621792"/>
           </a:xfrm>
           <a:prstGeom prst="rect">
             <a:avLst/>
@@ -9315,8 +9531,10 @@
           <a:solidFill>
             <a:srgbClr val="FFFFFF"/>
           </a:solidFill>
-          <a:ln>
-            <a:noFill/>
+          <a:ln w="12700">
+            <a:solidFill>
+              <a:srgbClr val="E2E8F0"/>
+            </a:solidFill>
           </a:ln>
         </p:spPr>
         <p:style>
@@ -9343,14 +9561,14 @@
       </p:sp>
       <p:sp>
         <p:nvSpPr>
-          <p:cNvPr id="16" name="TextBox 15"/>
-          <p:cNvSpPr txBox="1"/>
-          <p:nvPr/>
-        </p:nvSpPr>
-        <p:spPr>
-          <a:xfrm>
-            <a:off x="914400" y="4370831"/>
-            <a:ext cx="1737360" cy="457200"/>
+          <p:cNvPr id="21" name="TextBox 20"/>
+          <p:cNvSpPr txBox="1"/>
+          <p:nvPr/>
+        </p:nvSpPr>
+        <p:spPr>
+          <a:xfrm>
+            <a:off x="841248" y="4078224"/>
+            <a:ext cx="1965960" cy="274320"/>
           </a:xfrm>
           <a:prstGeom prst="rect">
             <a:avLst/>
@@ -9365,14 +9583,14 @@
           <a:p>
             <a:pPr algn="l">
               <a:lnSpc>
-                <a:spcPts val="1320"/>
-              </a:lnSpc>
-              <a:spcAft>
-                <a:spcPts val="0"/>
-              </a:spcAft>
-              <a:defRPr sz="1200" b="0">
-                <a:solidFill>
-                  <a:srgbClr val="64748B"/>
+                <a:spcPts val="1200"/>
+              </a:lnSpc>
+              <a:spcAft>
+                <a:spcPts val="0"/>
+              </a:spcAft>
+              <a:defRPr sz="1000" b="0">
+                <a:solidFill>
+                  <a:srgbClr val="334155"/>
                 </a:solidFill>
                 <a:latin typeface="Karla"/>
               </a:defRPr>
@@ -9385,14 +9603,14 @@
       </p:sp>
       <p:sp>
         <p:nvSpPr>
-          <p:cNvPr id="17" name="TextBox 16"/>
-          <p:cNvSpPr txBox="1"/>
-          <p:nvPr/>
-        </p:nvSpPr>
-        <p:spPr>
-          <a:xfrm>
-            <a:off x="2468880" y="4389119"/>
-            <a:ext cx="1371600" cy="411480"/>
+          <p:cNvPr id="22" name="TextBox 21"/>
+          <p:cNvSpPr txBox="1"/>
+          <p:nvPr/>
+        </p:nvSpPr>
+        <p:spPr>
+          <a:xfrm>
+            <a:off x="2697480" y="4078224"/>
+            <a:ext cx="1325880" cy="274320"/>
           </a:xfrm>
           <a:prstGeom prst="rect">
             <a:avLst/>
@@ -9407,16 +9625,16 @@
           <a:p>
             <a:pPr algn="r">
               <a:lnSpc>
-                <a:spcPts val="1560"/>
-              </a:lnSpc>
-              <a:spcAft>
-                <a:spcPts val="0"/>
-              </a:spcAft>
-              <a:defRPr sz="1300" b="1">
+                <a:spcPts val="1380"/>
+              </a:lnSpc>
+              <a:spcAft>
+                <a:spcPts val="0"/>
+              </a:spcAft>
+              <a:defRPr sz="1150" b="1">
                 <a:solidFill>
                   <a:srgbClr val="1E293B"/>
                 </a:solidFill>
-                <a:latin typeface="JetBrains Mono"/>
+                <a:latin typeface="Fredoka"/>
               </a:defRPr>
             </a:pPr>
             <a:r>
@@ -9427,14 +9645,56 @@
       </p:sp>
       <p:sp>
         <p:nvSpPr>
-          <p:cNvPr id="18" name="Rectangle 17"/>
+          <p:cNvPr id="23" name="TextBox 22"/>
+          <p:cNvSpPr txBox="1"/>
+          <p:nvPr/>
+        </p:nvSpPr>
+        <p:spPr>
+          <a:xfrm>
+            <a:off x="841248" y="4370832"/>
+            <a:ext cx="3182112" cy="237744"/>
+          </a:xfrm>
+          <a:prstGeom prst="rect">
+            <a:avLst/>
+          </a:prstGeom>
+          <a:noFill/>
+        </p:spPr>
+        <p:txBody>
+          <a:bodyPr wrap="square">
+            <a:spAutoFit/>
+          </a:bodyPr>
+          <a:lstStyle/>
+          <a:p>
+            <a:pPr algn="l">
+              <a:lnSpc>
+                <a:spcPts val="983"/>
+              </a:lnSpc>
+              <a:spcAft>
+                <a:spcPts val="0"/>
+              </a:spcAft>
+              <a:defRPr sz="819" b="0">
+                <a:solidFill>
+                  <a:srgbClr val="006DB0"/>
+                </a:solidFill>
+                <a:latin typeface="Karla"/>
+              </a:defRPr>
+            </a:pPr>
+            <a:r>
+              <a:t>Formula: 30,000 total orders × KSH 15 M-Pesa fee</a:t>
+            </a:r>
+          </a:p>
+        </p:txBody>
+      </p:sp>
+      <p:sp>
+        <p:nvSpPr>
+          <p:cNvPr id="24" name="Rectangle 23"/>
           <p:cNvSpPr/>
           <p:nvPr/>
         </p:nvSpPr>
         <p:spPr>
           <a:xfrm>
-            <a:off x="731520" y="4937760"/>
-            <a:ext cx="3383280" cy="594360"/>
+            <a:off x="731520" y="4700016"/>
+            <a:ext cx="3401568" cy="621792"/>
           </a:xfrm>
           <a:prstGeom prst="rect">
             <a:avLst/>
@@ -9442,8 +9702,10 @@
           <a:solidFill>
             <a:srgbClr val="F8FAFC"/>
           </a:solidFill>
-          <a:ln>
-            <a:noFill/>
+          <a:ln w="12700">
+            <a:solidFill>
+              <a:srgbClr val="E2E8F0"/>
+            </a:solidFill>
           </a:ln>
         </p:spPr>
         <p:style>
@@ -9470,14 +9732,14 @@
       </p:sp>
       <p:sp>
         <p:nvSpPr>
-          <p:cNvPr id="19" name="TextBox 18"/>
-          <p:cNvSpPr txBox="1"/>
-          <p:nvPr/>
-        </p:nvSpPr>
-        <p:spPr>
-          <a:xfrm>
-            <a:off x="914400" y="5010912"/>
-            <a:ext cx="1737360" cy="457200"/>
+          <p:cNvPr id="25" name="TextBox 24"/>
+          <p:cNvSpPr txBox="1"/>
+          <p:nvPr/>
+        </p:nvSpPr>
+        <p:spPr>
+          <a:xfrm>
+            <a:off x="841248" y="4736592"/>
+            <a:ext cx="1965960" cy="274320"/>
           </a:xfrm>
           <a:prstGeom prst="rect">
             <a:avLst/>
@@ -9492,34 +9754,34 @@
           <a:p>
             <a:pPr algn="l">
               <a:lnSpc>
-                <a:spcPts val="1320"/>
-              </a:lnSpc>
-              <a:spcAft>
-                <a:spcPts val="0"/>
-              </a:spcAft>
-              <a:defRPr sz="1200" b="0">
-                <a:solidFill>
-                  <a:srgbClr val="64748B"/>
+                <a:spcPts val="1200"/>
+              </a:lnSpc>
+              <a:spcAft>
+                <a:spcPts val="0"/>
+              </a:spcAft>
+              <a:defRPr sz="1000" b="0">
+                <a:solidFill>
+                  <a:srgbClr val="334155"/>
                 </a:solidFill>
                 <a:latin typeface="Karla"/>
               </a:defRPr>
             </a:pPr>
             <a:r>
-              <a:t>Operating Costs</a:t>
-            </a:r>
-          </a:p>
-        </p:txBody>
-      </p:sp>
-      <p:sp>
-        <p:nvSpPr>
-          <p:cNvPr id="20" name="TextBox 19"/>
-          <p:cNvSpPr txBox="1"/>
-          <p:nvPr/>
-        </p:nvSpPr>
-        <p:spPr>
-          <a:xfrm>
-            <a:off x="2468880" y="5029200"/>
-            <a:ext cx="1371600" cy="411480"/>
+              <a:t>Operating Costs (OPEX)</a:t>
+            </a:r>
+          </a:p>
+        </p:txBody>
+      </p:sp>
+      <p:sp>
+        <p:nvSpPr>
+          <p:cNvPr id="26" name="TextBox 25"/>
+          <p:cNvSpPr txBox="1"/>
+          <p:nvPr/>
+        </p:nvSpPr>
+        <p:spPr>
+          <a:xfrm>
+            <a:off x="2697480" y="4736592"/>
+            <a:ext cx="1325880" cy="274320"/>
           </a:xfrm>
           <a:prstGeom prst="rect">
             <a:avLst/>
@@ -9534,16 +9796,16 @@
           <a:p>
             <a:pPr algn="r">
               <a:lnSpc>
-                <a:spcPts val="1560"/>
-              </a:lnSpc>
-              <a:spcAft>
-                <a:spcPts val="0"/>
-              </a:spcAft>
-              <a:defRPr sz="1300" b="1">
+                <a:spcPts val="1380"/>
+              </a:lnSpc>
+              <a:spcAft>
+                <a:spcPts val="0"/>
+              </a:spcAft>
+              <a:defRPr sz="1150" b="1">
                 <a:solidFill>
                   <a:srgbClr val="1E293B"/>
                 </a:solidFill>
-                <a:latin typeface="JetBrains Mono"/>
+                <a:latin typeface="Fredoka"/>
               </a:defRPr>
             </a:pPr>
             <a:r>
@@ -9554,14 +9816,56 @@
       </p:sp>
       <p:sp>
         <p:nvSpPr>
-          <p:cNvPr id="21" name="Rectangle 20"/>
+          <p:cNvPr id="27" name="TextBox 26"/>
+          <p:cNvSpPr txBox="1"/>
+          <p:nvPr/>
+        </p:nvSpPr>
+        <p:spPr>
+          <a:xfrm>
+            <a:off x="841248" y="5029200"/>
+            <a:ext cx="3182112" cy="237744"/>
+          </a:xfrm>
+          <a:prstGeom prst="rect">
+            <a:avLst/>
+          </a:prstGeom>
+          <a:noFill/>
+        </p:spPr>
+        <p:txBody>
+          <a:bodyPr wrap="square">
+            <a:spAutoFit/>
+          </a:bodyPr>
+          <a:lstStyle/>
+          <a:p>
+            <a:pPr algn="l">
+              <a:lnSpc>
+                <a:spcPts val="983"/>
+              </a:lnSpc>
+              <a:spcAft>
+                <a:spcPts val="0"/>
+              </a:spcAft>
+              <a:defRPr sz="819" b="0">
+                <a:solidFill>
+                  <a:srgbClr val="006DB0"/>
+                </a:solidFill>
+                <a:latin typeface="Karla"/>
+              </a:defRPr>
+            </a:pPr>
+            <a:r>
+              <a:t>Formula: Core dev + cloud servers + seed operations</a:t>
+            </a:r>
+          </a:p>
+        </p:txBody>
+      </p:sp>
+      <p:sp>
+        <p:nvSpPr>
+          <p:cNvPr id="28" name="Rectangle 27"/>
           <p:cNvSpPr/>
           <p:nvPr/>
         </p:nvSpPr>
         <p:spPr>
           <a:xfrm>
-            <a:off x="731520" y="5577840"/>
-            <a:ext cx="3383280" cy="594360"/>
+            <a:off x="731520" y="5358383"/>
+            <a:ext cx="3401568" cy="621792"/>
           </a:xfrm>
           <a:prstGeom prst="rect">
             <a:avLst/>
@@ -9569,8 +9873,10 @@
           <a:solidFill>
             <a:srgbClr val="FFFFFF"/>
           </a:solidFill>
-          <a:ln>
-            <a:noFill/>
+          <a:ln w="12700">
+            <a:solidFill>
+              <a:srgbClr val="E2E8F0"/>
+            </a:solidFill>
           </a:ln>
         </p:spPr>
         <p:style>
@@ -9597,14 +9903,14 @@
       </p:sp>
       <p:sp>
         <p:nvSpPr>
-          <p:cNvPr id="22" name="TextBox 21"/>
-          <p:cNvSpPr txBox="1"/>
-          <p:nvPr/>
-        </p:nvSpPr>
-        <p:spPr>
-          <a:xfrm>
-            <a:off x="914400" y="5650992"/>
-            <a:ext cx="1737360" cy="457200"/>
+          <p:cNvPr id="29" name="TextBox 28"/>
+          <p:cNvSpPr txBox="1"/>
+          <p:nvPr/>
+        </p:nvSpPr>
+        <p:spPr>
+          <a:xfrm>
+            <a:off x="841248" y="5394959"/>
+            <a:ext cx="1965960" cy="274320"/>
           </a:xfrm>
           <a:prstGeom prst="rect">
             <a:avLst/>
@@ -9619,34 +9925,34 @@
           <a:p>
             <a:pPr algn="l">
               <a:lnSpc>
-                <a:spcPts val="1320"/>
-              </a:lnSpc>
-              <a:spcAft>
-                <a:spcPts val="0"/>
-              </a:spcAft>
-              <a:defRPr sz="1200" b="1">
-                <a:solidFill>
-                  <a:srgbClr val="64748B"/>
+                <a:spcPts val="1200"/>
+              </a:lnSpc>
+              <a:spcAft>
+                <a:spcPts val="0"/>
+              </a:spcAft>
+              <a:defRPr sz="1000" b="1">
+                <a:solidFill>
+                  <a:srgbClr val="1E293B"/>
                 </a:solidFill>
                 <a:latin typeface="Karla"/>
               </a:defRPr>
             </a:pPr>
             <a:r>
-              <a:t>Net</a:t>
-            </a:r>
-          </a:p>
-        </p:txBody>
-      </p:sp>
-      <p:sp>
-        <p:nvSpPr>
-          <p:cNvPr id="23" name="TextBox 22"/>
-          <p:cNvSpPr txBox="1"/>
-          <p:nvPr/>
-        </p:nvSpPr>
-        <p:spPr>
-          <a:xfrm>
-            <a:off x="2468880" y="5669280"/>
-            <a:ext cx="1371600" cy="411480"/>
+              <a:t>Net Contribution</a:t>
+            </a:r>
+          </a:p>
+        </p:txBody>
+      </p:sp>
+      <p:sp>
+        <p:nvSpPr>
+          <p:cNvPr id="30" name="TextBox 29"/>
+          <p:cNvSpPr txBox="1"/>
+          <p:nvPr/>
+        </p:nvSpPr>
+        <p:spPr>
+          <a:xfrm>
+            <a:off x="2697480" y="5394959"/>
+            <a:ext cx="1325880" cy="274320"/>
           </a:xfrm>
           <a:prstGeom prst="rect">
             <a:avLst/>
@@ -9661,16 +9967,16 @@
           <a:p>
             <a:pPr algn="r">
               <a:lnSpc>
-                <a:spcPts val="1560"/>
-              </a:lnSpc>
-              <a:spcAft>
-                <a:spcPts val="0"/>
-              </a:spcAft>
-              <a:defRPr sz="1300" b="1">
+                <a:spcPts val="1380"/>
+              </a:lnSpc>
+              <a:spcAft>
+                <a:spcPts val="0"/>
+              </a:spcAft>
+              <a:defRPr sz="1150" b="1">
                 <a:solidFill>
                   <a:srgbClr val="DC2626"/>
                 </a:solidFill>
-                <a:latin typeface="JetBrains Mono"/>
+                <a:latin typeface="Fredoka"/>
               </a:defRPr>
             </a:pPr>
             <a:r>
@@ -9681,14 +9987,56 @@
       </p:sp>
       <p:sp>
         <p:nvSpPr>
-          <p:cNvPr id="24" name="Rectangle 23"/>
+          <p:cNvPr id="31" name="TextBox 30"/>
+          <p:cNvSpPr txBox="1"/>
+          <p:nvPr/>
+        </p:nvSpPr>
+        <p:spPr>
+          <a:xfrm>
+            <a:off x="841248" y="5687567"/>
+            <a:ext cx="3182112" cy="237744"/>
+          </a:xfrm>
+          <a:prstGeom prst="rect">
+            <a:avLst/>
+          </a:prstGeom>
+          <a:noFill/>
+        </p:spPr>
+        <p:txBody>
+          <a:bodyPr wrap="square">
+            <a:spAutoFit/>
+          </a:bodyPr>
+          <a:lstStyle/>
+          <a:p>
+            <a:pPr algn="l">
+              <a:lnSpc>
+                <a:spcPts val="983"/>
+              </a:lnSpc>
+              <a:spcAft>
+                <a:spcPts val="0"/>
+              </a:spcAft>
+              <a:defRPr sz="819" b="0">
+                <a:solidFill>
+                  <a:srgbClr val="B91C1C"/>
+                </a:solidFill>
+                <a:latin typeface="Karla"/>
+              </a:defRPr>
+            </a:pPr>
+            <a:r>
+              <a:t>Formula: Take (2.07M) - Payments (0.45M) - OPEX (3.5M)</a:t>
+            </a:r>
+          </a:p>
+        </p:txBody>
+      </p:sp>
+      <p:sp>
+        <p:nvSpPr>
+          <p:cNvPr id="32" name="Rectangle 31"/>
           <p:cNvSpPr/>
           <p:nvPr/>
         </p:nvSpPr>
         <p:spPr>
           <a:xfrm>
-            <a:off x="4389120" y="1737360"/>
-            <a:ext cx="3383280" cy="548640"/>
+            <a:off x="4389120" y="1463040"/>
+            <a:ext cx="3401568" cy="475488"/>
           </a:xfrm>
           <a:prstGeom prst="rect">
             <a:avLst/>
@@ -9724,14 +10072,14 @@
       </p:sp>
       <p:sp>
         <p:nvSpPr>
-          <p:cNvPr id="25" name="TextBox 24"/>
-          <p:cNvSpPr txBox="1"/>
-          <p:nvPr/>
-        </p:nvSpPr>
-        <p:spPr>
-          <a:xfrm>
-            <a:off x="4389120" y="1755648"/>
-            <a:ext cx="3383280" cy="548640"/>
+          <p:cNvPr id="33" name="TextBox 32"/>
+          <p:cNvSpPr txBox="1"/>
+          <p:nvPr/>
+        </p:nvSpPr>
+        <p:spPr>
+          <a:xfrm>
+            <a:off x="4389120" y="1481328"/>
+            <a:ext cx="3401568" cy="237744"/>
           </a:xfrm>
           <a:prstGeom prst="rect">
             <a:avLst/>
@@ -9746,12 +10094,12 @@
           <a:p>
             <a:pPr algn="ctr">
               <a:lnSpc>
-                <a:spcPts val="2160"/>
-              </a:lnSpc>
-              <a:spcAft>
-                <a:spcPts val="0"/>
-              </a:spcAft>
-              <a:defRPr sz="1800" b="1">
+                <a:spcPts val="1800"/>
+              </a:lnSpc>
+              <a:spcAft>
+                <a:spcPts val="0"/>
+              </a:spcAft>
+              <a:defRPr sz="1500" b="1">
                 <a:solidFill>
                   <a:srgbClr val="FFFFFF"/>
                 </a:solidFill>
@@ -9766,14 +10114,56 @@
       </p:sp>
       <p:sp>
         <p:nvSpPr>
-          <p:cNvPr id="26" name="Rectangle 25"/>
+          <p:cNvPr id="34" name="TextBox 33"/>
+          <p:cNvSpPr txBox="1"/>
+          <p:nvPr/>
+        </p:nvSpPr>
+        <p:spPr>
+          <a:xfrm>
+            <a:off x="4389120" y="1719072"/>
+            <a:ext cx="3401568" cy="201168"/>
+          </a:xfrm>
+          <a:prstGeom prst="rect">
+            <a:avLst/>
+          </a:prstGeom>
+          <a:noFill/>
+        </p:spPr>
+        <p:txBody>
+          <a:bodyPr wrap="square">
+            <a:spAutoFit/>
+          </a:bodyPr>
+          <a:lstStyle/>
+          <a:p>
+            <a:pPr algn="ctr">
+              <a:lnSpc>
+                <a:spcPts val="1019"/>
+              </a:lnSpc>
+              <a:spcAft>
+                <a:spcPts val="0"/>
+              </a:spcAft>
+              <a:defRPr sz="850" b="0">
+                <a:solidFill>
+                  <a:srgbClr val="CFEDFF"/>
+                </a:solidFill>
+                <a:latin typeface="Karla"/>
+              </a:defRPr>
+            </a:pPr>
+            <a:r>
+              <a:t>180k Annual Orders (85% Retail / 15% Wholesale)</a:t>
+            </a:r>
+          </a:p>
+        </p:txBody>
+      </p:sp>
+      <p:sp>
+        <p:nvSpPr>
+          <p:cNvPr id="35" name="Rectangle 34"/>
           <p:cNvSpPr/>
           <p:nvPr/>
         </p:nvSpPr>
         <p:spPr>
           <a:xfrm>
-            <a:off x="4389120" y="2377440"/>
-            <a:ext cx="3383280" cy="594360"/>
+            <a:off x="4389120" y="2066543"/>
+            <a:ext cx="3401568" cy="621792"/>
           </a:xfrm>
           <a:prstGeom prst="rect">
             <a:avLst/>
@@ -9781,8 +10171,10 @@
           <a:solidFill>
             <a:srgbClr val="F8FAFC"/>
           </a:solidFill>
-          <a:ln>
-            <a:noFill/>
+          <a:ln w="12700">
+            <a:solidFill>
+              <a:srgbClr val="E2E8F0"/>
+            </a:solidFill>
           </a:ln>
         </p:spPr>
         <p:style>
@@ -9809,14 +10201,14 @@
       </p:sp>
       <p:sp>
         <p:nvSpPr>
-          <p:cNvPr id="27" name="TextBox 26"/>
-          <p:cNvSpPr txBox="1"/>
-          <p:nvPr/>
-        </p:nvSpPr>
-        <p:spPr>
-          <a:xfrm>
-            <a:off x="4572000" y="2450592"/>
-            <a:ext cx="1737360" cy="457200"/>
+          <p:cNvPr id="36" name="TextBox 35"/>
+          <p:cNvSpPr txBox="1"/>
+          <p:nvPr/>
+        </p:nvSpPr>
+        <p:spPr>
+          <a:xfrm>
+            <a:off x="4498848" y="2103119"/>
+            <a:ext cx="1965960" cy="274320"/>
           </a:xfrm>
           <a:prstGeom prst="rect">
             <a:avLst/>
@@ -9831,34 +10223,34 @@
           <a:p>
             <a:pPr algn="l">
               <a:lnSpc>
-                <a:spcPts val="1320"/>
-              </a:lnSpc>
-              <a:spcAft>
-                <a:spcPts val="0"/>
-              </a:spcAft>
-              <a:defRPr sz="1200" b="0">
-                <a:solidFill>
-                  <a:srgbClr val="64748B"/>
+                <a:spcPts val="1200"/>
+              </a:lnSpc>
+              <a:spcAft>
+                <a:spcPts val="0"/>
+              </a:spcAft>
+              <a:defRPr sz="1000" b="0">
+                <a:solidFill>
+                  <a:srgbClr val="334155"/>
                 </a:solidFill>
                 <a:latin typeface="Karla"/>
               </a:defRPr>
             </a:pPr>
             <a:r>
-              <a:t>Monthly Orders</a:t>
-            </a:r>
-          </a:p>
-        </p:txBody>
-      </p:sp>
-      <p:sp>
-        <p:nvSpPr>
-          <p:cNvPr id="28" name="TextBox 27"/>
-          <p:cNvSpPr txBox="1"/>
-          <p:nvPr/>
-        </p:nvSpPr>
-        <p:spPr>
-          <a:xfrm>
-            <a:off x="6126480" y="2468880"/>
-            <a:ext cx="1371600" cy="411480"/>
+              <a:t>Monthly Orders (Run-rate)</a:t>
+            </a:r>
+          </a:p>
+        </p:txBody>
+      </p:sp>
+      <p:sp>
+        <p:nvSpPr>
+          <p:cNvPr id="37" name="TextBox 36"/>
+          <p:cNvSpPr txBox="1"/>
+          <p:nvPr/>
+        </p:nvSpPr>
+        <p:spPr>
+          <a:xfrm>
+            <a:off x="6355080" y="2103119"/>
+            <a:ext cx="1325880" cy="274320"/>
           </a:xfrm>
           <a:prstGeom prst="rect">
             <a:avLst/>
@@ -9873,16 +10265,16 @@
           <a:p>
             <a:pPr algn="r">
               <a:lnSpc>
-                <a:spcPts val="1560"/>
-              </a:lnSpc>
-              <a:spcAft>
-                <a:spcPts val="0"/>
-              </a:spcAft>
-              <a:defRPr sz="1300" b="1">
+                <a:spcPts val="1380"/>
+              </a:lnSpc>
+              <a:spcAft>
+                <a:spcPts val="0"/>
+              </a:spcAft>
+              <a:defRPr sz="1150" b="1">
                 <a:solidFill>
                   <a:srgbClr val="1E293B"/>
                 </a:solidFill>
-                <a:latin typeface="JetBrains Mono"/>
+                <a:latin typeface="Fredoka"/>
               </a:defRPr>
             </a:pPr>
             <a:r>
@@ -9893,14 +10285,56 @@
       </p:sp>
       <p:sp>
         <p:nvSpPr>
-          <p:cNvPr id="29" name="Rectangle 28"/>
+          <p:cNvPr id="38" name="TextBox 37"/>
+          <p:cNvSpPr txBox="1"/>
+          <p:nvPr/>
+        </p:nvSpPr>
+        <p:spPr>
+          <a:xfrm>
+            <a:off x="4498848" y="2395727"/>
+            <a:ext cx="3182112" cy="237744"/>
+          </a:xfrm>
+          <a:prstGeom prst="rect">
+            <a:avLst/>
+          </a:prstGeom>
+          <a:noFill/>
+        </p:spPr>
+        <p:txBody>
+          <a:bodyPr wrap="square">
+            <a:spAutoFit/>
+          </a:bodyPr>
+          <a:lstStyle/>
+          <a:p>
+            <a:pPr algn="l">
+              <a:lnSpc>
+                <a:spcPts val="983"/>
+              </a:lnSpc>
+              <a:spcAft>
+                <a:spcPts val="0"/>
+              </a:spcAft>
+              <a:defRPr sz="819" b="0">
+                <a:solidFill>
+                  <a:srgbClr val="006DB0"/>
+                </a:solidFill>
+                <a:latin typeface="Karla"/>
+              </a:defRPr>
+            </a:pPr>
+            <a:r>
+              <a:t>Formula: Ramp avg 15,000/mo × 12 = 180,000 orders/yr</a:t>
+            </a:r>
+          </a:p>
+        </p:txBody>
+      </p:sp>
+      <p:sp>
+        <p:nvSpPr>
+          <p:cNvPr id="39" name="Rectangle 38"/>
           <p:cNvSpPr/>
           <p:nvPr/>
         </p:nvSpPr>
         <p:spPr>
           <a:xfrm>
-            <a:off x="4389120" y="3017520"/>
-            <a:ext cx="3383280" cy="594360"/>
+            <a:off x="4389120" y="2724911"/>
+            <a:ext cx="3401568" cy="621792"/>
           </a:xfrm>
           <a:prstGeom prst="rect">
             <a:avLst/>
@@ -9908,8 +10342,10 @@
           <a:solidFill>
             <a:srgbClr val="FFFFFF"/>
           </a:solidFill>
-          <a:ln>
-            <a:noFill/>
+          <a:ln w="12700">
+            <a:solidFill>
+              <a:srgbClr val="E2E8F0"/>
+            </a:solidFill>
           </a:ln>
         </p:spPr>
         <p:style>
@@ -9936,14 +10372,14 @@
       </p:sp>
       <p:sp>
         <p:nvSpPr>
-          <p:cNvPr id="30" name="TextBox 29"/>
-          <p:cNvSpPr txBox="1"/>
-          <p:nvPr/>
-        </p:nvSpPr>
-        <p:spPr>
-          <a:xfrm>
-            <a:off x="4572000" y="3090672"/>
-            <a:ext cx="2011680" cy="457200"/>
+          <p:cNvPr id="40" name="TextBox 39"/>
+          <p:cNvSpPr txBox="1"/>
+          <p:nvPr/>
+        </p:nvSpPr>
+        <p:spPr>
+          <a:xfrm>
+            <a:off x="4498848" y="2761487"/>
+            <a:ext cx="1965960" cy="274320"/>
           </a:xfrm>
           <a:prstGeom prst="rect">
             <a:avLst/>
@@ -9958,14 +10394,14 @@
           <a:p>
             <a:pPr algn="l">
               <a:lnSpc>
-                <a:spcPts val="1100"/>
-              </a:lnSpc>
-              <a:spcAft>
-                <a:spcPts val="0"/>
-              </a:spcAft>
-              <a:defRPr sz="1000" b="0">
-                <a:solidFill>
-                  <a:srgbClr val="64748B"/>
+                <a:spcPts val="1140"/>
+              </a:lnSpc>
+              <a:spcAft>
+                <a:spcPts val="0"/>
+              </a:spcAft>
+              <a:defRPr sz="950" b="0">
+                <a:solidFill>
+                  <a:srgbClr val="334155"/>
                 </a:solidFill>
                 <a:latin typeface="Karla"/>
               </a:defRPr>
@@ -9978,14 +10414,14 @@
       </p:sp>
       <p:sp>
         <p:nvSpPr>
-          <p:cNvPr id="31" name="TextBox 30"/>
-          <p:cNvSpPr txBox="1"/>
-          <p:nvPr/>
-        </p:nvSpPr>
-        <p:spPr>
-          <a:xfrm>
-            <a:off x="6400800" y="3108960"/>
-            <a:ext cx="1188720" cy="411480"/>
+          <p:cNvPr id="41" name="TextBox 40"/>
+          <p:cNvSpPr txBox="1"/>
+          <p:nvPr/>
+        </p:nvSpPr>
+        <p:spPr>
+          <a:xfrm>
+            <a:off x="6355080" y="2761487"/>
+            <a:ext cx="1325880" cy="274320"/>
           </a:xfrm>
           <a:prstGeom prst="rect">
             <a:avLst/>
@@ -10000,16 +10436,16 @@
           <a:p>
             <a:pPr algn="r">
               <a:lnSpc>
-                <a:spcPts val="1560"/>
-              </a:lnSpc>
-              <a:spcAft>
-                <a:spcPts val="0"/>
-              </a:spcAft>
-              <a:defRPr sz="1300" b="1">
+                <a:spcPts val="1380"/>
+              </a:lnSpc>
+              <a:spcAft>
+                <a:spcPts val="0"/>
+              </a:spcAft>
+              <a:defRPr sz="1150" b="1">
                 <a:solidFill>
                   <a:srgbClr val="1E293B"/>
                 </a:solidFill>
-                <a:latin typeface="JetBrains Mono"/>
+                <a:latin typeface="Fredoka"/>
               </a:defRPr>
             </a:pPr>
             <a:r>
@@ -10020,14 +10456,56 @@
       </p:sp>
       <p:sp>
         <p:nvSpPr>
-          <p:cNvPr id="32" name="Rectangle 31"/>
+          <p:cNvPr id="42" name="TextBox 41"/>
+          <p:cNvSpPr txBox="1"/>
+          <p:nvPr/>
+        </p:nvSpPr>
+        <p:spPr>
+          <a:xfrm>
+            <a:off x="4498848" y="3054095"/>
+            <a:ext cx="3182112" cy="237744"/>
+          </a:xfrm>
+          <a:prstGeom prst="rect">
+            <a:avLst/>
+          </a:prstGeom>
+          <a:noFill/>
+        </p:spPr>
+        <p:txBody>
+          <a:bodyPr wrap="square">
+            <a:spAutoFit/>
+          </a:bodyPr>
+          <a:lstStyle/>
+          <a:p>
+            <a:pPr algn="l">
+              <a:lnSpc>
+                <a:spcPts val="983"/>
+              </a:lnSpc>
+              <a:spcAft>
+                <a:spcPts val="0"/>
+              </a:spcAft>
+              <a:defRPr sz="819" b="0">
+                <a:solidFill>
+                  <a:srgbClr val="006DB0"/>
+                </a:solidFill>
+                <a:latin typeface="Karla"/>
+              </a:defRPr>
+            </a:pPr>
+            <a:r>
+              <a:t>Formula: (153k retail × 255) + (27k wholesale × 2,170)</a:t>
+            </a:r>
+          </a:p>
+        </p:txBody>
+      </p:sp>
+      <p:sp>
+        <p:nvSpPr>
+          <p:cNvPr id="43" name="Rectangle 42"/>
           <p:cNvSpPr/>
           <p:nvPr/>
         </p:nvSpPr>
         <p:spPr>
           <a:xfrm>
-            <a:off x="4389120" y="3657600"/>
-            <a:ext cx="3383280" cy="594360"/>
+            <a:off x="4389120" y="3383279"/>
+            <a:ext cx="3401568" cy="621792"/>
           </a:xfrm>
           <a:prstGeom prst="rect">
             <a:avLst/>
@@ -10035,8 +10513,10 @@
           <a:solidFill>
             <a:srgbClr val="F8FAFC"/>
           </a:solidFill>
-          <a:ln>
-            <a:noFill/>
+          <a:ln w="12700">
+            <a:solidFill>
+              <a:srgbClr val="E2E8F0"/>
+            </a:solidFill>
           </a:ln>
         </p:spPr>
         <p:style>
@@ -10063,14 +10543,14 @@
       </p:sp>
       <p:sp>
         <p:nvSpPr>
-          <p:cNvPr id="33" name="TextBox 32"/>
-          <p:cNvSpPr txBox="1"/>
-          <p:nvPr/>
-        </p:nvSpPr>
-        <p:spPr>
-          <a:xfrm>
-            <a:off x="4572000" y="3730752"/>
-            <a:ext cx="1737360" cy="457200"/>
+          <p:cNvPr id="44" name="TextBox 43"/>
+          <p:cNvSpPr txBox="1"/>
+          <p:nvPr/>
+        </p:nvSpPr>
+        <p:spPr>
+          <a:xfrm>
+            <a:off x="4498848" y="3419855"/>
+            <a:ext cx="1965960" cy="274320"/>
           </a:xfrm>
           <a:prstGeom prst="rect">
             <a:avLst/>
@@ -10085,14 +10565,14 @@
           <a:p>
             <a:pPr algn="l">
               <a:lnSpc>
-                <a:spcPts val="1320"/>
-              </a:lnSpc>
-              <a:spcAft>
-                <a:spcPts val="0"/>
-              </a:spcAft>
-              <a:defRPr sz="1200" b="0">
-                <a:solidFill>
-                  <a:srgbClr val="64748B"/>
+                <a:spcPts val="1200"/>
+              </a:lnSpc>
+              <a:spcAft>
+                <a:spcPts val="0"/>
+              </a:spcAft>
+              <a:defRPr sz="1000" b="0">
+                <a:solidFill>
+                  <a:srgbClr val="334155"/>
                 </a:solidFill>
                 <a:latin typeface="Karla"/>
               </a:defRPr>
@@ -10105,14 +10585,14 @@
       </p:sp>
       <p:sp>
         <p:nvSpPr>
-          <p:cNvPr id="34" name="TextBox 33"/>
-          <p:cNvSpPr txBox="1"/>
-          <p:nvPr/>
-        </p:nvSpPr>
-        <p:spPr>
-          <a:xfrm>
-            <a:off x="6126480" y="3749040"/>
-            <a:ext cx="1371600" cy="411480"/>
+          <p:cNvPr id="45" name="TextBox 44"/>
+          <p:cNvSpPr txBox="1"/>
+          <p:nvPr/>
+        </p:nvSpPr>
+        <p:spPr>
+          <a:xfrm>
+            <a:off x="6355080" y="3419855"/>
+            <a:ext cx="1325880" cy="274320"/>
           </a:xfrm>
           <a:prstGeom prst="rect">
             <a:avLst/>
@@ -10127,16 +10607,16 @@
           <a:p>
             <a:pPr algn="r">
               <a:lnSpc>
-                <a:spcPts val="1560"/>
-              </a:lnSpc>
-              <a:spcAft>
-                <a:spcPts val="0"/>
-              </a:spcAft>
-              <a:defRPr sz="1300" b="1">
+                <a:spcPts val="1380"/>
+              </a:lnSpc>
+              <a:spcAft>
+                <a:spcPts val="0"/>
+              </a:spcAft>
+              <a:defRPr sz="1150" b="1">
                 <a:solidFill>
                   <a:srgbClr val="1E293B"/>
                 </a:solidFill>
-                <a:latin typeface="JetBrains Mono"/>
+                <a:latin typeface="Fredoka"/>
               </a:defRPr>
             </a:pPr>
             <a:r>
@@ -10147,14 +10627,56 @@
       </p:sp>
       <p:sp>
         <p:nvSpPr>
-          <p:cNvPr id="35" name="Rectangle 34"/>
+          <p:cNvPr id="46" name="TextBox 45"/>
+          <p:cNvSpPr txBox="1"/>
+          <p:nvPr/>
+        </p:nvSpPr>
+        <p:spPr>
+          <a:xfrm>
+            <a:off x="4498848" y="3712463"/>
+            <a:ext cx="3182112" cy="237744"/>
+          </a:xfrm>
+          <a:prstGeom prst="rect">
+            <a:avLst/>
+          </a:prstGeom>
+          <a:noFill/>
+        </p:spPr>
+        <p:txBody>
+          <a:bodyPr wrap="square">
+            <a:spAutoFit/>
+          </a:bodyPr>
+          <a:lstStyle/>
+          <a:p>
+            <a:pPr algn="l">
+              <a:lnSpc>
+                <a:spcPts val="983"/>
+              </a:lnSpc>
+              <a:spcAft>
+                <a:spcPts val="0"/>
+              </a:spcAft>
+              <a:defRPr sz="819" b="0">
+                <a:solidFill>
+                  <a:srgbClr val="006DB0"/>
+                </a:solidFill>
+                <a:latin typeface="Karla"/>
+              </a:defRPr>
+            </a:pPr>
+            <a:r>
+              <a:t>Formula: (153k retail × 52) + (27k wholesale × 222.50)</a:t>
+            </a:r>
+          </a:p>
+        </p:txBody>
+      </p:sp>
+      <p:sp>
+        <p:nvSpPr>
+          <p:cNvPr id="47" name="Rectangle 46"/>
           <p:cNvSpPr/>
           <p:nvPr/>
         </p:nvSpPr>
         <p:spPr>
           <a:xfrm>
-            <a:off x="4389120" y="4297679"/>
-            <a:ext cx="3383280" cy="594360"/>
+            <a:off x="4389120" y="4041648"/>
+            <a:ext cx="3401568" cy="621792"/>
           </a:xfrm>
           <a:prstGeom prst="rect">
             <a:avLst/>
@@ -10162,8 +10684,10 @@
           <a:solidFill>
             <a:srgbClr val="FFFFFF"/>
           </a:solidFill>
-          <a:ln>
-            <a:noFill/>
+          <a:ln w="12700">
+            <a:solidFill>
+              <a:srgbClr val="E2E8F0"/>
+            </a:solidFill>
           </a:ln>
         </p:spPr>
         <p:style>
@@ -10190,14 +10714,14 @@
       </p:sp>
       <p:sp>
         <p:nvSpPr>
-          <p:cNvPr id="36" name="TextBox 35"/>
-          <p:cNvSpPr txBox="1"/>
-          <p:nvPr/>
-        </p:nvSpPr>
-        <p:spPr>
-          <a:xfrm>
-            <a:off x="4572000" y="4370831"/>
-            <a:ext cx="1737360" cy="457200"/>
+          <p:cNvPr id="48" name="TextBox 47"/>
+          <p:cNvSpPr txBox="1"/>
+          <p:nvPr/>
+        </p:nvSpPr>
+        <p:spPr>
+          <a:xfrm>
+            <a:off x="4498848" y="4078224"/>
+            <a:ext cx="1965960" cy="274320"/>
           </a:xfrm>
           <a:prstGeom prst="rect">
             <a:avLst/>
@@ -10212,14 +10736,14 @@
           <a:p>
             <a:pPr algn="l">
               <a:lnSpc>
-                <a:spcPts val="1320"/>
-              </a:lnSpc>
-              <a:spcAft>
-                <a:spcPts val="0"/>
-              </a:spcAft>
-              <a:defRPr sz="1200" b="0">
-                <a:solidFill>
-                  <a:srgbClr val="64748B"/>
+                <a:spcPts val="1200"/>
+              </a:lnSpc>
+              <a:spcAft>
+                <a:spcPts val="0"/>
+              </a:spcAft>
+              <a:defRPr sz="1000" b="0">
+                <a:solidFill>
+                  <a:srgbClr val="334155"/>
                 </a:solidFill>
                 <a:latin typeface="Karla"/>
               </a:defRPr>
@@ -10232,14 +10756,14 @@
       </p:sp>
       <p:sp>
         <p:nvSpPr>
-          <p:cNvPr id="37" name="TextBox 36"/>
-          <p:cNvSpPr txBox="1"/>
-          <p:nvPr/>
-        </p:nvSpPr>
-        <p:spPr>
-          <a:xfrm>
-            <a:off x="6126480" y="4389119"/>
-            <a:ext cx="1371600" cy="411480"/>
+          <p:cNvPr id="49" name="TextBox 48"/>
+          <p:cNvSpPr txBox="1"/>
+          <p:nvPr/>
+        </p:nvSpPr>
+        <p:spPr>
+          <a:xfrm>
+            <a:off x="6355080" y="4078224"/>
+            <a:ext cx="1325880" cy="274320"/>
           </a:xfrm>
           <a:prstGeom prst="rect">
             <a:avLst/>
@@ -10254,16 +10778,16 @@
           <a:p>
             <a:pPr algn="r">
               <a:lnSpc>
-                <a:spcPts val="1560"/>
-              </a:lnSpc>
-              <a:spcAft>
-                <a:spcPts val="0"/>
-              </a:spcAft>
-              <a:defRPr sz="1300" b="1">
+                <a:spcPts val="1380"/>
+              </a:lnSpc>
+              <a:spcAft>
+                <a:spcPts val="0"/>
+              </a:spcAft>
+              <a:defRPr sz="1150" b="1">
                 <a:solidFill>
                   <a:srgbClr val="1E293B"/>
                 </a:solidFill>
-                <a:latin typeface="JetBrains Mono"/>
+                <a:latin typeface="Fredoka"/>
               </a:defRPr>
             </a:pPr>
             <a:r>
@@ -10274,14 +10798,56 @@
       </p:sp>
       <p:sp>
         <p:nvSpPr>
-          <p:cNvPr id="38" name="Rectangle 37"/>
+          <p:cNvPr id="50" name="TextBox 49"/>
+          <p:cNvSpPr txBox="1"/>
+          <p:nvPr/>
+        </p:nvSpPr>
+        <p:spPr>
+          <a:xfrm>
+            <a:off x="4498848" y="4370832"/>
+            <a:ext cx="3182112" cy="237744"/>
+          </a:xfrm>
+          <a:prstGeom prst="rect">
+            <a:avLst/>
+          </a:prstGeom>
+          <a:noFill/>
+        </p:spPr>
+        <p:txBody>
+          <a:bodyPr wrap="square">
+            <a:spAutoFit/>
+          </a:bodyPr>
+          <a:lstStyle/>
+          <a:p>
+            <a:pPr algn="l">
+              <a:lnSpc>
+                <a:spcPts val="983"/>
+              </a:lnSpc>
+              <a:spcAft>
+                <a:spcPts val="0"/>
+              </a:spcAft>
+              <a:defRPr sz="819" b="0">
+                <a:solidFill>
+                  <a:srgbClr val="006DB0"/>
+                </a:solidFill>
+                <a:latin typeface="Karla"/>
+              </a:defRPr>
+            </a:pPr>
+            <a:r>
+              <a:t>Formula: 180,000 total orders × KSH 15 M-Pesa fee</a:t>
+            </a:r>
+          </a:p>
+        </p:txBody>
+      </p:sp>
+      <p:sp>
+        <p:nvSpPr>
+          <p:cNvPr id="51" name="Rectangle 50"/>
           <p:cNvSpPr/>
           <p:nvPr/>
         </p:nvSpPr>
         <p:spPr>
           <a:xfrm>
-            <a:off x="4389120" y="4937760"/>
-            <a:ext cx="3383280" cy="594360"/>
+            <a:off x="4389120" y="4700016"/>
+            <a:ext cx="3401568" cy="621792"/>
           </a:xfrm>
           <a:prstGeom prst="rect">
             <a:avLst/>
@@ -10289,8 +10855,10 @@
           <a:solidFill>
             <a:srgbClr val="F8FAFC"/>
           </a:solidFill>
-          <a:ln>
-            <a:noFill/>
+          <a:ln w="12700">
+            <a:solidFill>
+              <a:srgbClr val="E2E8F0"/>
+            </a:solidFill>
           </a:ln>
         </p:spPr>
         <p:style>
@@ -10317,14 +10885,14 @@
       </p:sp>
       <p:sp>
         <p:nvSpPr>
-          <p:cNvPr id="39" name="TextBox 38"/>
-          <p:cNvSpPr txBox="1"/>
-          <p:nvPr/>
-        </p:nvSpPr>
-        <p:spPr>
-          <a:xfrm>
-            <a:off x="4572000" y="5010912"/>
-            <a:ext cx="1737360" cy="457200"/>
+          <p:cNvPr id="52" name="TextBox 51"/>
+          <p:cNvSpPr txBox="1"/>
+          <p:nvPr/>
+        </p:nvSpPr>
+        <p:spPr>
+          <a:xfrm>
+            <a:off x="4498848" y="4736592"/>
+            <a:ext cx="1965960" cy="274320"/>
           </a:xfrm>
           <a:prstGeom prst="rect">
             <a:avLst/>
@@ -10339,34 +10907,34 @@
           <a:p>
             <a:pPr algn="l">
               <a:lnSpc>
-                <a:spcPts val="1320"/>
-              </a:lnSpc>
-              <a:spcAft>
-                <a:spcPts val="0"/>
-              </a:spcAft>
-              <a:defRPr sz="1200" b="0">
-                <a:solidFill>
-                  <a:srgbClr val="64748B"/>
+                <a:spcPts val="1200"/>
+              </a:lnSpc>
+              <a:spcAft>
+                <a:spcPts val="0"/>
+              </a:spcAft>
+              <a:defRPr sz="1000" b="0">
+                <a:solidFill>
+                  <a:srgbClr val="334155"/>
                 </a:solidFill>
                 <a:latin typeface="Karla"/>
               </a:defRPr>
             </a:pPr>
             <a:r>
-              <a:t>Operating Costs</a:t>
-            </a:r>
-          </a:p>
-        </p:txBody>
-      </p:sp>
-      <p:sp>
-        <p:nvSpPr>
-          <p:cNvPr id="40" name="TextBox 39"/>
-          <p:cNvSpPr txBox="1"/>
-          <p:nvPr/>
-        </p:nvSpPr>
-        <p:spPr>
-          <a:xfrm>
-            <a:off x="6126480" y="5029200"/>
-            <a:ext cx="1371600" cy="411480"/>
+              <a:t>Operating Costs (OPEX)</a:t>
+            </a:r>
+          </a:p>
+        </p:txBody>
+      </p:sp>
+      <p:sp>
+        <p:nvSpPr>
+          <p:cNvPr id="53" name="TextBox 52"/>
+          <p:cNvSpPr txBox="1"/>
+          <p:nvPr/>
+        </p:nvSpPr>
+        <p:spPr>
+          <a:xfrm>
+            <a:off x="6355080" y="4736592"/>
+            <a:ext cx="1325880" cy="274320"/>
           </a:xfrm>
           <a:prstGeom prst="rect">
             <a:avLst/>
@@ -10381,16 +10949,16 @@
           <a:p>
             <a:pPr algn="r">
               <a:lnSpc>
-                <a:spcPts val="1560"/>
-              </a:lnSpc>
-              <a:spcAft>
-                <a:spcPts val="0"/>
-              </a:spcAft>
-              <a:defRPr sz="1300" b="1">
+                <a:spcPts val="1380"/>
+              </a:lnSpc>
+              <a:spcAft>
+                <a:spcPts val="0"/>
+              </a:spcAft>
+              <a:defRPr sz="1150" b="1">
                 <a:solidFill>
                   <a:srgbClr val="1E293B"/>
                 </a:solidFill>
-                <a:latin typeface="JetBrains Mono"/>
+                <a:latin typeface="Fredoka"/>
               </a:defRPr>
             </a:pPr>
             <a:r>
@@ -10401,14 +10969,56 @@
       </p:sp>
       <p:sp>
         <p:nvSpPr>
-          <p:cNvPr id="41" name="Rectangle 40"/>
+          <p:cNvPr id="54" name="TextBox 53"/>
+          <p:cNvSpPr txBox="1"/>
+          <p:nvPr/>
+        </p:nvSpPr>
+        <p:spPr>
+          <a:xfrm>
+            <a:off x="4498848" y="5029200"/>
+            <a:ext cx="3182112" cy="237744"/>
+          </a:xfrm>
+          <a:prstGeom prst="rect">
+            <a:avLst/>
+          </a:prstGeom>
+          <a:noFill/>
+        </p:spPr>
+        <p:txBody>
+          <a:bodyPr wrap="square">
+            <a:spAutoFit/>
+          </a:bodyPr>
+          <a:lstStyle/>
+          <a:p>
+            <a:pPr algn="l">
+              <a:lnSpc>
+                <a:spcPts val="983"/>
+              </a:lnSpc>
+              <a:spcAft>
+                <a:spcPts val="0"/>
+              </a:spcAft>
+              <a:defRPr sz="819" b="0">
+                <a:solidFill>
+                  <a:srgbClr val="006DB0"/>
+                </a:solidFill>
+                <a:latin typeface="Karla"/>
+              </a:defRPr>
+            </a:pPr>
+            <a:r>
+              <a:t>Formula: Nairobi-wide expansion, support &amp; fleet ops</a:t>
+            </a:r>
+          </a:p>
+        </p:txBody>
+      </p:sp>
+      <p:sp>
+        <p:nvSpPr>
+          <p:cNvPr id="55" name="Rectangle 54"/>
           <p:cNvSpPr/>
           <p:nvPr/>
         </p:nvSpPr>
         <p:spPr>
           <a:xfrm>
-            <a:off x="4389120" y="5577840"/>
-            <a:ext cx="3383280" cy="594360"/>
+            <a:off x="4389120" y="5358383"/>
+            <a:ext cx="3401568" cy="621792"/>
           </a:xfrm>
           <a:prstGeom prst="rect">
             <a:avLst/>
@@ -10416,8 +11026,10 @@
           <a:solidFill>
             <a:srgbClr val="FFFFFF"/>
           </a:solidFill>
-          <a:ln>
-            <a:noFill/>
+          <a:ln w="12700">
+            <a:solidFill>
+              <a:srgbClr val="E2E8F0"/>
+            </a:solidFill>
           </a:ln>
         </p:spPr>
         <p:style>
@@ -10444,14 +11056,14 @@
       </p:sp>
       <p:sp>
         <p:nvSpPr>
-          <p:cNvPr id="42" name="TextBox 41"/>
-          <p:cNvSpPr txBox="1"/>
-          <p:nvPr/>
-        </p:nvSpPr>
-        <p:spPr>
-          <a:xfrm>
-            <a:off x="4572000" y="5650992"/>
-            <a:ext cx="1737360" cy="457200"/>
+          <p:cNvPr id="56" name="TextBox 55"/>
+          <p:cNvSpPr txBox="1"/>
+          <p:nvPr/>
+        </p:nvSpPr>
+        <p:spPr>
+          <a:xfrm>
+            <a:off x="4498848" y="5394959"/>
+            <a:ext cx="1965960" cy="274320"/>
           </a:xfrm>
           <a:prstGeom prst="rect">
             <a:avLst/>
@@ -10466,34 +11078,34 @@
           <a:p>
             <a:pPr algn="l">
               <a:lnSpc>
-                <a:spcPts val="1320"/>
-              </a:lnSpc>
-              <a:spcAft>
-                <a:spcPts val="0"/>
-              </a:spcAft>
-              <a:defRPr sz="1200" b="1">
-                <a:solidFill>
-                  <a:srgbClr val="64748B"/>
+                <a:spcPts val="1200"/>
+              </a:lnSpc>
+              <a:spcAft>
+                <a:spcPts val="0"/>
+              </a:spcAft>
+              <a:defRPr sz="1000" b="1">
+                <a:solidFill>
+                  <a:srgbClr val="1E293B"/>
                 </a:solidFill>
                 <a:latin typeface="Karla"/>
               </a:defRPr>
             </a:pPr>
             <a:r>
-              <a:t>Net</a:t>
-            </a:r>
-          </a:p>
-        </p:txBody>
-      </p:sp>
-      <p:sp>
-        <p:nvSpPr>
-          <p:cNvPr id="43" name="TextBox 42"/>
-          <p:cNvSpPr txBox="1"/>
-          <p:nvPr/>
-        </p:nvSpPr>
-        <p:spPr>
-          <a:xfrm>
-            <a:off x="6126480" y="5669280"/>
-            <a:ext cx="1371600" cy="411480"/>
+              <a:t>Net Contribution</a:t>
+            </a:r>
+          </a:p>
+        </p:txBody>
+      </p:sp>
+      <p:sp>
+        <p:nvSpPr>
+          <p:cNvPr id="57" name="TextBox 56"/>
+          <p:cNvSpPr txBox="1"/>
+          <p:nvPr/>
+        </p:nvSpPr>
+        <p:spPr>
+          <a:xfrm>
+            <a:off x="6355080" y="5394959"/>
+            <a:ext cx="1325880" cy="274320"/>
           </a:xfrm>
           <a:prstGeom prst="rect">
             <a:avLst/>
@@ -10508,16 +11120,16 @@
           <a:p>
             <a:pPr algn="r">
               <a:lnSpc>
-                <a:spcPts val="1560"/>
-              </a:lnSpc>
-              <a:spcAft>
-                <a:spcPts val="0"/>
-              </a:spcAft>
-              <a:defRPr sz="1300" b="1">
+                <a:spcPts val="1380"/>
+              </a:lnSpc>
+              <a:spcAft>
+                <a:spcPts val="0"/>
+              </a:spcAft>
+              <a:defRPr sz="1150" b="1">
                 <a:solidFill>
                   <a:srgbClr val="DC2626"/>
                 </a:solidFill>
-                <a:latin typeface="JetBrains Mono"/>
+                <a:latin typeface="Fredoka"/>
               </a:defRPr>
             </a:pPr>
             <a:r>
@@ -10528,14 +11140,56 @@
       </p:sp>
       <p:sp>
         <p:nvSpPr>
-          <p:cNvPr id="44" name="Rectangle 43"/>
+          <p:cNvPr id="58" name="TextBox 57"/>
+          <p:cNvSpPr txBox="1"/>
+          <p:nvPr/>
+        </p:nvSpPr>
+        <p:spPr>
+          <a:xfrm>
+            <a:off x="4498848" y="5687567"/>
+            <a:ext cx="3182112" cy="237744"/>
+          </a:xfrm>
+          <a:prstGeom prst="rect">
+            <a:avLst/>
+          </a:prstGeom>
+          <a:noFill/>
+        </p:spPr>
+        <p:txBody>
+          <a:bodyPr wrap="square">
+            <a:spAutoFit/>
+          </a:bodyPr>
+          <a:lstStyle/>
+          <a:p>
+            <a:pPr algn="l">
+              <a:lnSpc>
+                <a:spcPts val="983"/>
+              </a:lnSpc>
+              <a:spcAft>
+                <a:spcPts val="0"/>
+              </a:spcAft>
+              <a:defRPr sz="819" b="0">
+                <a:solidFill>
+                  <a:srgbClr val="B91C1C"/>
+                </a:solidFill>
+                <a:latin typeface="Karla"/>
+              </a:defRPr>
+            </a:pPr>
+            <a:r>
+              <a:t>Formula: Take (14.0M) - Payments (2.7M) - OPEX (12.0M)</a:t>
+            </a:r>
+          </a:p>
+        </p:txBody>
+      </p:sp>
+      <p:sp>
+        <p:nvSpPr>
+          <p:cNvPr id="59" name="Rectangle 58"/>
           <p:cNvSpPr/>
           <p:nvPr/>
         </p:nvSpPr>
         <p:spPr>
           <a:xfrm>
-            <a:off x="8046720" y="1737360"/>
-            <a:ext cx="3383280" cy="548640"/>
+            <a:off x="8046720" y="1463040"/>
+            <a:ext cx="3401568" cy="475488"/>
           </a:xfrm>
           <a:prstGeom prst="rect">
             <a:avLst/>
@@ -10571,14 +11225,14 @@
       </p:sp>
       <p:sp>
         <p:nvSpPr>
-          <p:cNvPr id="45" name="TextBox 44"/>
-          <p:cNvSpPr txBox="1"/>
-          <p:nvPr/>
-        </p:nvSpPr>
-        <p:spPr>
-          <a:xfrm>
-            <a:off x="8046720" y="1755648"/>
-            <a:ext cx="3383280" cy="548640"/>
+          <p:cNvPr id="60" name="TextBox 59"/>
+          <p:cNvSpPr txBox="1"/>
+          <p:nvPr/>
+        </p:nvSpPr>
+        <p:spPr>
+          <a:xfrm>
+            <a:off x="8046720" y="1481328"/>
+            <a:ext cx="3401568" cy="237744"/>
           </a:xfrm>
           <a:prstGeom prst="rect">
             <a:avLst/>
@@ -10593,12 +11247,12 @@
           <a:p>
             <a:pPr algn="ctr">
               <a:lnSpc>
-                <a:spcPts val="2160"/>
-              </a:lnSpc>
-              <a:spcAft>
-                <a:spcPts val="0"/>
-              </a:spcAft>
-              <a:defRPr sz="1800" b="1">
+                <a:spcPts val="1800"/>
+              </a:lnSpc>
+              <a:spcAft>
+                <a:spcPts val="0"/>
+              </a:spcAft>
+              <a:defRPr sz="1500" b="1">
                 <a:solidFill>
                   <a:srgbClr val="FFFFFF"/>
                 </a:solidFill>
@@ -10613,14 +11267,56 @@
       </p:sp>
       <p:sp>
         <p:nvSpPr>
-          <p:cNvPr id="46" name="Rectangle 45"/>
+          <p:cNvPr id="61" name="TextBox 60"/>
+          <p:cNvSpPr txBox="1"/>
+          <p:nvPr/>
+        </p:nvSpPr>
+        <p:spPr>
+          <a:xfrm>
+            <a:off x="8046720" y="1719072"/>
+            <a:ext cx="3401568" cy="201168"/>
+          </a:xfrm>
+          <a:prstGeom prst="rect">
+            <a:avLst/>
+          </a:prstGeom>
+          <a:noFill/>
+        </p:spPr>
+        <p:txBody>
+          <a:bodyPr wrap="square">
+            <a:spAutoFit/>
+          </a:bodyPr>
+          <a:lstStyle/>
+          <a:p>
+            <a:pPr algn="ctr">
+              <a:lnSpc>
+                <a:spcPts val="1019"/>
+              </a:lnSpc>
+              <a:spcAft>
+                <a:spcPts val="0"/>
+              </a:spcAft>
+              <a:defRPr sz="850" b="0">
+                <a:solidFill>
+                  <a:srgbClr val="DCFCE7"/>
+                </a:solidFill>
+                <a:latin typeface="Karla"/>
+              </a:defRPr>
+            </a:pPr>
+            <a:r>
+              <a:t>1.2M Annual Orders (80% Retail / 20% Wholesale)</a:t>
+            </a:r>
+          </a:p>
+        </p:txBody>
+      </p:sp>
+      <p:sp>
+        <p:nvSpPr>
+          <p:cNvPr id="62" name="Rectangle 61"/>
           <p:cNvSpPr/>
           <p:nvPr/>
         </p:nvSpPr>
         <p:spPr>
           <a:xfrm>
-            <a:off x="8046720" y="2377440"/>
-            <a:ext cx="3383280" cy="594360"/>
+            <a:off x="8046720" y="2066543"/>
+            <a:ext cx="3401568" cy="621792"/>
           </a:xfrm>
           <a:prstGeom prst="rect">
             <a:avLst/>
@@ -10628,8 +11324,10 @@
           <a:solidFill>
             <a:srgbClr val="F8FAFC"/>
           </a:solidFill>
-          <a:ln>
-            <a:noFill/>
+          <a:ln w="12700">
+            <a:solidFill>
+              <a:srgbClr val="E2E8F0"/>
+            </a:solidFill>
           </a:ln>
         </p:spPr>
         <p:style>
@@ -10656,14 +11354,14 @@
       </p:sp>
       <p:sp>
         <p:nvSpPr>
-          <p:cNvPr id="47" name="TextBox 46"/>
-          <p:cNvSpPr txBox="1"/>
-          <p:nvPr/>
-        </p:nvSpPr>
-        <p:spPr>
-          <a:xfrm>
-            <a:off x="8229600" y="2450592"/>
-            <a:ext cx="1737360" cy="457200"/>
+          <p:cNvPr id="63" name="TextBox 62"/>
+          <p:cNvSpPr txBox="1"/>
+          <p:nvPr/>
+        </p:nvSpPr>
+        <p:spPr>
+          <a:xfrm>
+            <a:off x="8156448" y="2103119"/>
+            <a:ext cx="1965960" cy="274320"/>
           </a:xfrm>
           <a:prstGeom prst="rect">
             <a:avLst/>
@@ -10678,34 +11376,34 @@
           <a:p>
             <a:pPr algn="l">
               <a:lnSpc>
-                <a:spcPts val="1320"/>
-              </a:lnSpc>
-              <a:spcAft>
-                <a:spcPts val="0"/>
-              </a:spcAft>
-              <a:defRPr sz="1200" b="0">
-                <a:solidFill>
-                  <a:srgbClr val="64748B"/>
+                <a:spcPts val="1200"/>
+              </a:lnSpc>
+              <a:spcAft>
+                <a:spcPts val="0"/>
+              </a:spcAft>
+              <a:defRPr sz="1000" b="0">
+                <a:solidFill>
+                  <a:srgbClr val="334155"/>
                 </a:solidFill>
                 <a:latin typeface="Karla"/>
               </a:defRPr>
             </a:pPr>
             <a:r>
-              <a:t>Monthly Orders</a:t>
-            </a:r>
-          </a:p>
-        </p:txBody>
-      </p:sp>
-      <p:sp>
-        <p:nvSpPr>
-          <p:cNvPr id="48" name="TextBox 47"/>
-          <p:cNvSpPr txBox="1"/>
-          <p:nvPr/>
-        </p:nvSpPr>
-        <p:spPr>
-          <a:xfrm>
-            <a:off x="9784080" y="2468880"/>
-            <a:ext cx="1371600" cy="411480"/>
+              <a:t>Monthly Orders (Run-rate)</a:t>
+            </a:r>
+          </a:p>
+        </p:txBody>
+      </p:sp>
+      <p:sp>
+        <p:nvSpPr>
+          <p:cNvPr id="64" name="TextBox 63"/>
+          <p:cNvSpPr txBox="1"/>
+          <p:nvPr/>
+        </p:nvSpPr>
+        <p:spPr>
+          <a:xfrm>
+            <a:off x="10012680" y="2103119"/>
+            <a:ext cx="1325880" cy="274320"/>
           </a:xfrm>
           <a:prstGeom prst="rect">
             <a:avLst/>
@@ -10720,16 +11418,16 @@
           <a:p>
             <a:pPr algn="r">
               <a:lnSpc>
-                <a:spcPts val="1560"/>
-              </a:lnSpc>
-              <a:spcAft>
-                <a:spcPts val="0"/>
-              </a:spcAft>
-              <a:defRPr sz="1300" b="1">
+                <a:spcPts val="1380"/>
+              </a:lnSpc>
+              <a:spcAft>
+                <a:spcPts val="0"/>
+              </a:spcAft>
+              <a:defRPr sz="1150" b="1">
                 <a:solidFill>
                   <a:srgbClr val="1E293B"/>
                 </a:solidFill>
-                <a:latin typeface="JetBrains Mono"/>
+                <a:latin typeface="Fredoka"/>
               </a:defRPr>
             </a:pPr>
             <a:r>
@@ -10740,14 +11438,56 @@
       </p:sp>
       <p:sp>
         <p:nvSpPr>
-          <p:cNvPr id="49" name="Rectangle 48"/>
+          <p:cNvPr id="65" name="TextBox 64"/>
+          <p:cNvSpPr txBox="1"/>
+          <p:nvPr/>
+        </p:nvSpPr>
+        <p:spPr>
+          <a:xfrm>
+            <a:off x="8156448" y="2395727"/>
+            <a:ext cx="3182112" cy="237744"/>
+          </a:xfrm>
+          <a:prstGeom prst="rect">
+            <a:avLst/>
+          </a:prstGeom>
+          <a:noFill/>
+        </p:spPr>
+        <p:txBody>
+          <a:bodyPr wrap="square">
+            <a:spAutoFit/>
+          </a:bodyPr>
+          <a:lstStyle/>
+          <a:p>
+            <a:pPr algn="l">
+              <a:lnSpc>
+                <a:spcPts val="983"/>
+              </a:lnSpc>
+              <a:spcAft>
+                <a:spcPts val="0"/>
+              </a:spcAft>
+              <a:defRPr sz="819" b="0">
+                <a:solidFill>
+                  <a:srgbClr val="006DB0"/>
+                </a:solidFill>
+                <a:latin typeface="Karla"/>
+              </a:defRPr>
+            </a:pPr>
+            <a:r>
+              <a:t>Formula: Ramp avg 100,000/mo × 12 = 1,200,000 orders/yr</a:t>
+            </a:r>
+          </a:p>
+        </p:txBody>
+      </p:sp>
+      <p:sp>
+        <p:nvSpPr>
+          <p:cNvPr id="66" name="Rectangle 65"/>
           <p:cNvSpPr/>
           <p:nvPr/>
         </p:nvSpPr>
         <p:spPr>
           <a:xfrm>
-            <a:off x="8046720" y="3017520"/>
-            <a:ext cx="3383280" cy="594360"/>
+            <a:off x="8046720" y="2724911"/>
+            <a:ext cx="3401568" cy="621792"/>
           </a:xfrm>
           <a:prstGeom prst="rect">
             <a:avLst/>
@@ -10755,8 +11495,10 @@
           <a:solidFill>
             <a:srgbClr val="FFFFFF"/>
           </a:solidFill>
-          <a:ln>
-            <a:noFill/>
+          <a:ln w="12700">
+            <a:solidFill>
+              <a:srgbClr val="E2E8F0"/>
+            </a:solidFill>
           </a:ln>
         </p:spPr>
         <p:style>
@@ -10783,14 +11525,14 @@
       </p:sp>
       <p:sp>
         <p:nvSpPr>
-          <p:cNvPr id="50" name="TextBox 49"/>
-          <p:cNvSpPr txBox="1"/>
-          <p:nvPr/>
-        </p:nvSpPr>
-        <p:spPr>
-          <a:xfrm>
-            <a:off x="8229600" y="3090672"/>
-            <a:ext cx="2011680" cy="457200"/>
+          <p:cNvPr id="67" name="TextBox 66"/>
+          <p:cNvSpPr txBox="1"/>
+          <p:nvPr/>
+        </p:nvSpPr>
+        <p:spPr>
+          <a:xfrm>
+            <a:off x="8156448" y="2761487"/>
+            <a:ext cx="1965960" cy="274320"/>
           </a:xfrm>
           <a:prstGeom prst="rect">
             <a:avLst/>
@@ -10805,14 +11547,14 @@
           <a:p>
             <a:pPr algn="l">
               <a:lnSpc>
-                <a:spcPts val="1100"/>
-              </a:lnSpc>
-              <a:spcAft>
-                <a:spcPts val="0"/>
-              </a:spcAft>
-              <a:defRPr sz="1000" b="0">
-                <a:solidFill>
-                  <a:srgbClr val="64748B"/>
+                <a:spcPts val="1140"/>
+              </a:lnSpc>
+              <a:spcAft>
+                <a:spcPts val="0"/>
+              </a:spcAft>
+              <a:defRPr sz="950" b="0">
+                <a:solidFill>
+                  <a:srgbClr val="334155"/>
                 </a:solidFill>
                 <a:latin typeface="Karla"/>
               </a:defRPr>
@@ -10825,14 +11567,14 @@
       </p:sp>
       <p:sp>
         <p:nvSpPr>
-          <p:cNvPr id="51" name="TextBox 50"/>
-          <p:cNvSpPr txBox="1"/>
-          <p:nvPr/>
-        </p:nvSpPr>
-        <p:spPr>
-          <a:xfrm>
-            <a:off x="10058400" y="3108960"/>
-            <a:ext cx="1188720" cy="411480"/>
+          <p:cNvPr id="68" name="TextBox 67"/>
+          <p:cNvSpPr txBox="1"/>
+          <p:nvPr/>
+        </p:nvSpPr>
+        <p:spPr>
+          <a:xfrm>
+            <a:off x="10012680" y="2761487"/>
+            <a:ext cx="1325880" cy="274320"/>
           </a:xfrm>
           <a:prstGeom prst="rect">
             <a:avLst/>
@@ -10847,16 +11589,16 @@
           <a:p>
             <a:pPr algn="r">
               <a:lnSpc>
-                <a:spcPts val="1560"/>
-              </a:lnSpc>
-              <a:spcAft>
-                <a:spcPts val="0"/>
-              </a:spcAft>
-              <a:defRPr sz="1300" b="1">
+                <a:spcPts val="1380"/>
+              </a:lnSpc>
+              <a:spcAft>
+                <a:spcPts val="0"/>
+              </a:spcAft>
+              <a:defRPr sz="1150" b="1">
                 <a:solidFill>
                   <a:srgbClr val="1E293B"/>
                 </a:solidFill>
-                <a:latin typeface="JetBrains Mono"/>
+                <a:latin typeface="Fredoka"/>
               </a:defRPr>
             </a:pPr>
             <a:r>
@@ -10867,14 +11609,56 @@
       </p:sp>
       <p:sp>
         <p:nvSpPr>
-          <p:cNvPr id="52" name="Rectangle 51"/>
+          <p:cNvPr id="69" name="TextBox 68"/>
+          <p:cNvSpPr txBox="1"/>
+          <p:nvPr/>
+        </p:nvSpPr>
+        <p:spPr>
+          <a:xfrm>
+            <a:off x="8156448" y="3054095"/>
+            <a:ext cx="3182112" cy="237744"/>
+          </a:xfrm>
+          <a:prstGeom prst="rect">
+            <a:avLst/>
+          </a:prstGeom>
+          <a:noFill/>
+        </p:spPr>
+        <p:txBody>
+          <a:bodyPr wrap="square">
+            <a:spAutoFit/>
+          </a:bodyPr>
+          <a:lstStyle/>
+          <a:p>
+            <a:pPr algn="l">
+              <a:lnSpc>
+                <a:spcPts val="983"/>
+              </a:lnSpc>
+              <a:spcAft>
+                <a:spcPts val="0"/>
+              </a:spcAft>
+              <a:defRPr sz="819" b="0">
+                <a:solidFill>
+                  <a:srgbClr val="006DB0"/>
+                </a:solidFill>
+                <a:latin typeface="Karla"/>
+              </a:defRPr>
+            </a:pPr>
+            <a:r>
+              <a:t>Formula: (960k retail × 255) + (240k wholesale × 2,170)</a:t>
+            </a:r>
+          </a:p>
+        </p:txBody>
+      </p:sp>
+      <p:sp>
+        <p:nvSpPr>
+          <p:cNvPr id="70" name="Rectangle 69"/>
           <p:cNvSpPr/>
           <p:nvPr/>
         </p:nvSpPr>
         <p:spPr>
           <a:xfrm>
-            <a:off x="8046720" y="3657600"/>
-            <a:ext cx="3383280" cy="594360"/>
+            <a:off x="8046720" y="3383279"/>
+            <a:ext cx="3401568" cy="621792"/>
           </a:xfrm>
           <a:prstGeom prst="rect">
             <a:avLst/>
@@ -10882,8 +11666,10 @@
           <a:solidFill>
             <a:srgbClr val="F8FAFC"/>
           </a:solidFill>
-          <a:ln>
-            <a:noFill/>
+          <a:ln w="12700">
+            <a:solidFill>
+              <a:srgbClr val="E2E8F0"/>
+            </a:solidFill>
           </a:ln>
         </p:spPr>
         <p:style>
@@ -10910,14 +11696,14 @@
       </p:sp>
       <p:sp>
         <p:nvSpPr>
-          <p:cNvPr id="53" name="TextBox 52"/>
-          <p:cNvSpPr txBox="1"/>
-          <p:nvPr/>
-        </p:nvSpPr>
-        <p:spPr>
-          <a:xfrm>
-            <a:off x="8229600" y="3730752"/>
-            <a:ext cx="1737360" cy="457200"/>
+          <p:cNvPr id="71" name="TextBox 70"/>
+          <p:cNvSpPr txBox="1"/>
+          <p:nvPr/>
+        </p:nvSpPr>
+        <p:spPr>
+          <a:xfrm>
+            <a:off x="8156448" y="3419855"/>
+            <a:ext cx="1965960" cy="274320"/>
           </a:xfrm>
           <a:prstGeom prst="rect">
             <a:avLst/>
@@ -10932,14 +11718,14 @@
           <a:p>
             <a:pPr algn="l">
               <a:lnSpc>
-                <a:spcPts val="1320"/>
-              </a:lnSpc>
-              <a:spcAft>
-                <a:spcPts val="0"/>
-              </a:spcAft>
-              <a:defRPr sz="1200" b="0">
-                <a:solidFill>
-                  <a:srgbClr val="64748B"/>
+                <a:spcPts val="1200"/>
+              </a:lnSpc>
+              <a:spcAft>
+                <a:spcPts val="0"/>
+              </a:spcAft>
+              <a:defRPr sz="1000" b="0">
+                <a:solidFill>
+                  <a:srgbClr val="334155"/>
                 </a:solidFill>
                 <a:latin typeface="Karla"/>
               </a:defRPr>
@@ -10952,14 +11738,14 @@
       </p:sp>
       <p:sp>
         <p:nvSpPr>
-          <p:cNvPr id="54" name="TextBox 53"/>
-          <p:cNvSpPr txBox="1"/>
-          <p:nvPr/>
-        </p:nvSpPr>
-        <p:spPr>
-          <a:xfrm>
-            <a:off x="9784080" y="3749040"/>
-            <a:ext cx="1371600" cy="411480"/>
+          <p:cNvPr id="72" name="TextBox 71"/>
+          <p:cNvSpPr txBox="1"/>
+          <p:nvPr/>
+        </p:nvSpPr>
+        <p:spPr>
+          <a:xfrm>
+            <a:off x="10012680" y="3419855"/>
+            <a:ext cx="1325880" cy="274320"/>
           </a:xfrm>
           <a:prstGeom prst="rect">
             <a:avLst/>
@@ -10974,16 +11760,16 @@
           <a:p>
             <a:pPr algn="r">
               <a:lnSpc>
-                <a:spcPts val="1560"/>
-              </a:lnSpc>
-              <a:spcAft>
-                <a:spcPts val="0"/>
-              </a:spcAft>
-              <a:defRPr sz="1300" b="1">
+                <a:spcPts val="1380"/>
+              </a:lnSpc>
+              <a:spcAft>
+                <a:spcPts val="0"/>
+              </a:spcAft>
+              <a:defRPr sz="1150" b="1">
                 <a:solidFill>
                   <a:srgbClr val="1E293B"/>
                 </a:solidFill>
-                <a:latin typeface="JetBrains Mono"/>
+                <a:latin typeface="Fredoka"/>
               </a:defRPr>
             </a:pPr>
             <a:r>
@@ -10994,14 +11780,56 @@
       </p:sp>
       <p:sp>
         <p:nvSpPr>
-          <p:cNvPr id="55" name="Rectangle 54"/>
+          <p:cNvPr id="73" name="TextBox 72"/>
+          <p:cNvSpPr txBox="1"/>
+          <p:nvPr/>
+        </p:nvSpPr>
+        <p:spPr>
+          <a:xfrm>
+            <a:off x="8156448" y="3712463"/>
+            <a:ext cx="3182112" cy="237744"/>
+          </a:xfrm>
+          <a:prstGeom prst="rect">
+            <a:avLst/>
+          </a:prstGeom>
+          <a:noFill/>
+        </p:spPr>
+        <p:txBody>
+          <a:bodyPr wrap="square">
+            <a:spAutoFit/>
+          </a:bodyPr>
+          <a:lstStyle/>
+          <a:p>
+            <a:pPr algn="l">
+              <a:lnSpc>
+                <a:spcPts val="983"/>
+              </a:lnSpc>
+              <a:spcAft>
+                <a:spcPts val="0"/>
+              </a:spcAft>
+              <a:defRPr sz="819" b="0">
+                <a:solidFill>
+                  <a:srgbClr val="006DB0"/>
+                </a:solidFill>
+                <a:latin typeface="Karla"/>
+              </a:defRPr>
+            </a:pPr>
+            <a:r>
+              <a:t>Formula: (960k retail × 52) + (240k wholesale × 222.50)</a:t>
+            </a:r>
+          </a:p>
+        </p:txBody>
+      </p:sp>
+      <p:sp>
+        <p:nvSpPr>
+          <p:cNvPr id="74" name="Rectangle 73"/>
           <p:cNvSpPr/>
           <p:nvPr/>
         </p:nvSpPr>
         <p:spPr>
           <a:xfrm>
-            <a:off x="8046720" y="4297679"/>
-            <a:ext cx="3383280" cy="594360"/>
+            <a:off x="8046720" y="4041648"/>
+            <a:ext cx="3401568" cy="621792"/>
           </a:xfrm>
           <a:prstGeom prst="rect">
             <a:avLst/>
@@ -11009,8 +11837,10 @@
           <a:solidFill>
             <a:srgbClr val="FFFFFF"/>
           </a:solidFill>
-          <a:ln>
-            <a:noFill/>
+          <a:ln w="12700">
+            <a:solidFill>
+              <a:srgbClr val="E2E8F0"/>
+            </a:solidFill>
           </a:ln>
         </p:spPr>
         <p:style>
@@ -11037,14 +11867,14 @@
       </p:sp>
       <p:sp>
         <p:nvSpPr>
-          <p:cNvPr id="56" name="TextBox 55"/>
-          <p:cNvSpPr txBox="1"/>
-          <p:nvPr/>
-        </p:nvSpPr>
-        <p:spPr>
-          <a:xfrm>
-            <a:off x="8229600" y="4370831"/>
-            <a:ext cx="1737360" cy="457200"/>
+          <p:cNvPr id="75" name="TextBox 74"/>
+          <p:cNvSpPr txBox="1"/>
+          <p:nvPr/>
+        </p:nvSpPr>
+        <p:spPr>
+          <a:xfrm>
+            <a:off x="8156448" y="4078224"/>
+            <a:ext cx="1965960" cy="274320"/>
           </a:xfrm>
           <a:prstGeom prst="rect">
             <a:avLst/>
@@ -11059,14 +11889,14 @@
           <a:p>
             <a:pPr algn="l">
               <a:lnSpc>
-                <a:spcPts val="1320"/>
-              </a:lnSpc>
-              <a:spcAft>
-                <a:spcPts val="0"/>
-              </a:spcAft>
-              <a:defRPr sz="1200" b="0">
-                <a:solidFill>
-                  <a:srgbClr val="64748B"/>
+                <a:spcPts val="1200"/>
+              </a:lnSpc>
+              <a:spcAft>
+                <a:spcPts val="0"/>
+              </a:spcAft>
+              <a:defRPr sz="1000" b="0">
+                <a:solidFill>
+                  <a:srgbClr val="334155"/>
                 </a:solidFill>
                 <a:latin typeface="Karla"/>
               </a:defRPr>
@@ -11079,14 +11909,14 @@
       </p:sp>
       <p:sp>
         <p:nvSpPr>
-          <p:cNvPr id="57" name="TextBox 56"/>
-          <p:cNvSpPr txBox="1"/>
-          <p:nvPr/>
-        </p:nvSpPr>
-        <p:spPr>
-          <a:xfrm>
-            <a:off x="9784080" y="4389119"/>
-            <a:ext cx="1371600" cy="411480"/>
+          <p:cNvPr id="76" name="TextBox 75"/>
+          <p:cNvSpPr txBox="1"/>
+          <p:nvPr/>
+        </p:nvSpPr>
+        <p:spPr>
+          <a:xfrm>
+            <a:off x="10012680" y="4078224"/>
+            <a:ext cx="1325880" cy="274320"/>
           </a:xfrm>
           <a:prstGeom prst="rect">
             <a:avLst/>
@@ -11101,16 +11931,16 @@
           <a:p>
             <a:pPr algn="r">
               <a:lnSpc>
-                <a:spcPts val="1560"/>
-              </a:lnSpc>
-              <a:spcAft>
-                <a:spcPts val="0"/>
-              </a:spcAft>
-              <a:defRPr sz="1300" b="1">
+                <a:spcPts val="1380"/>
+              </a:lnSpc>
+              <a:spcAft>
+                <a:spcPts val="0"/>
+              </a:spcAft>
+              <a:defRPr sz="1150" b="1">
                 <a:solidFill>
                   <a:srgbClr val="1E293B"/>
                 </a:solidFill>
-                <a:latin typeface="JetBrains Mono"/>
+                <a:latin typeface="Fredoka"/>
               </a:defRPr>
             </a:pPr>
             <a:r>
@@ -11121,14 +11951,56 @@
       </p:sp>
       <p:sp>
         <p:nvSpPr>
-          <p:cNvPr id="58" name="Rectangle 57"/>
+          <p:cNvPr id="77" name="TextBox 76"/>
+          <p:cNvSpPr txBox="1"/>
+          <p:nvPr/>
+        </p:nvSpPr>
+        <p:spPr>
+          <a:xfrm>
+            <a:off x="8156448" y="4370832"/>
+            <a:ext cx="3182112" cy="237744"/>
+          </a:xfrm>
+          <a:prstGeom prst="rect">
+            <a:avLst/>
+          </a:prstGeom>
+          <a:noFill/>
+        </p:spPr>
+        <p:txBody>
+          <a:bodyPr wrap="square">
+            <a:spAutoFit/>
+          </a:bodyPr>
+          <a:lstStyle/>
+          <a:p>
+            <a:pPr algn="l">
+              <a:lnSpc>
+                <a:spcPts val="983"/>
+              </a:lnSpc>
+              <a:spcAft>
+                <a:spcPts val="0"/>
+              </a:spcAft>
+              <a:defRPr sz="819" b="0">
+                <a:solidFill>
+                  <a:srgbClr val="006DB0"/>
+                </a:solidFill>
+                <a:latin typeface="Karla"/>
+              </a:defRPr>
+            </a:pPr>
+            <a:r>
+              <a:t>Formula: 1,200,000 total orders × KSH 15 M-Pesa fee</a:t>
+            </a:r>
+          </a:p>
+        </p:txBody>
+      </p:sp>
+      <p:sp>
+        <p:nvSpPr>
+          <p:cNvPr id="78" name="Rectangle 77"/>
           <p:cNvSpPr/>
           <p:nvPr/>
         </p:nvSpPr>
         <p:spPr>
           <a:xfrm>
-            <a:off x="8046720" y="4937760"/>
-            <a:ext cx="3383280" cy="594360"/>
+            <a:off x="8046720" y="4700016"/>
+            <a:ext cx="3401568" cy="621792"/>
           </a:xfrm>
           <a:prstGeom prst="rect">
             <a:avLst/>
@@ -11136,8 +12008,10 @@
           <a:solidFill>
             <a:srgbClr val="F8FAFC"/>
           </a:solidFill>
-          <a:ln>
-            <a:noFill/>
+          <a:ln w="12700">
+            <a:solidFill>
+              <a:srgbClr val="E2E8F0"/>
+            </a:solidFill>
           </a:ln>
         </p:spPr>
         <p:style>
@@ -11164,14 +12038,14 @@
       </p:sp>
       <p:sp>
         <p:nvSpPr>
-          <p:cNvPr id="59" name="TextBox 58"/>
-          <p:cNvSpPr txBox="1"/>
-          <p:nvPr/>
-        </p:nvSpPr>
-        <p:spPr>
-          <a:xfrm>
-            <a:off x="8229600" y="5010912"/>
-            <a:ext cx="1737360" cy="457200"/>
+          <p:cNvPr id="79" name="TextBox 78"/>
+          <p:cNvSpPr txBox="1"/>
+          <p:nvPr/>
+        </p:nvSpPr>
+        <p:spPr>
+          <a:xfrm>
+            <a:off x="8156448" y="4736592"/>
+            <a:ext cx="1965960" cy="274320"/>
           </a:xfrm>
           <a:prstGeom prst="rect">
             <a:avLst/>
@@ -11186,34 +12060,34 @@
           <a:p>
             <a:pPr algn="l">
               <a:lnSpc>
-                <a:spcPts val="1320"/>
-              </a:lnSpc>
-              <a:spcAft>
-                <a:spcPts val="0"/>
-              </a:spcAft>
-              <a:defRPr sz="1200" b="0">
-                <a:solidFill>
-                  <a:srgbClr val="64748B"/>
+                <a:spcPts val="1200"/>
+              </a:lnSpc>
+              <a:spcAft>
+                <a:spcPts val="0"/>
+              </a:spcAft>
+              <a:defRPr sz="1000" b="0">
+                <a:solidFill>
+                  <a:srgbClr val="334155"/>
                 </a:solidFill>
                 <a:latin typeface="Karla"/>
               </a:defRPr>
             </a:pPr>
             <a:r>
-              <a:t>Operating Costs</a:t>
-            </a:r>
-          </a:p>
-        </p:txBody>
-      </p:sp>
-      <p:sp>
-        <p:nvSpPr>
-          <p:cNvPr id="60" name="TextBox 59"/>
-          <p:cNvSpPr txBox="1"/>
-          <p:nvPr/>
-        </p:nvSpPr>
-        <p:spPr>
-          <a:xfrm>
-            <a:off x="9784080" y="5029200"/>
-            <a:ext cx="1371600" cy="411480"/>
+              <a:t>Operating Costs (OPEX)</a:t>
+            </a:r>
+          </a:p>
+        </p:txBody>
+      </p:sp>
+      <p:sp>
+        <p:nvSpPr>
+          <p:cNvPr id="80" name="TextBox 79"/>
+          <p:cNvSpPr txBox="1"/>
+          <p:nvPr/>
+        </p:nvSpPr>
+        <p:spPr>
+          <a:xfrm>
+            <a:off x="10012680" y="4736592"/>
+            <a:ext cx="1325880" cy="274320"/>
           </a:xfrm>
           <a:prstGeom prst="rect">
             <a:avLst/>
@@ -11228,16 +12102,16 @@
           <a:p>
             <a:pPr algn="r">
               <a:lnSpc>
-                <a:spcPts val="1560"/>
-              </a:lnSpc>
-              <a:spcAft>
-                <a:spcPts val="0"/>
-              </a:spcAft>
-              <a:defRPr sz="1300" b="1">
+                <a:spcPts val="1380"/>
+              </a:lnSpc>
+              <a:spcAft>
+                <a:spcPts val="0"/>
+              </a:spcAft>
+              <a:defRPr sz="1150" b="1">
                 <a:solidFill>
                   <a:srgbClr val="1E293B"/>
                 </a:solidFill>
-                <a:latin typeface="JetBrains Mono"/>
+                <a:latin typeface="Fredoka"/>
               </a:defRPr>
             </a:pPr>
             <a:r>
@@ -11248,14 +12122,56 @@
       </p:sp>
       <p:sp>
         <p:nvSpPr>
-          <p:cNvPr id="61" name="Rectangle 60"/>
+          <p:cNvPr id="81" name="TextBox 80"/>
+          <p:cNvSpPr txBox="1"/>
+          <p:nvPr/>
+        </p:nvSpPr>
+        <p:spPr>
+          <a:xfrm>
+            <a:off x="8156448" y="5029200"/>
+            <a:ext cx="3182112" cy="237744"/>
+          </a:xfrm>
+          <a:prstGeom prst="rect">
+            <a:avLst/>
+          </a:prstGeom>
+          <a:noFill/>
+        </p:spPr>
+        <p:txBody>
+          <a:bodyPr wrap="square">
+            <a:spAutoFit/>
+          </a:bodyPr>
+          <a:lstStyle/>
+          <a:p>
+            <a:pPr algn="l">
+              <a:lnSpc>
+                <a:spcPts val="983"/>
+              </a:lnSpc>
+              <a:spcAft>
+                <a:spcPts val="0"/>
+              </a:spcAft>
+              <a:defRPr sz="819" b="0">
+                <a:solidFill>
+                  <a:srgbClr val="006DB0"/>
+                </a:solidFill>
+                <a:latin typeface="Karla"/>
+              </a:defRPr>
+            </a:pPr>
+            <a:r>
+              <a:t>Formula: Multi-city scale (Mombasa, Kisumu, Nakuru)</a:t>
+            </a:r>
+          </a:p>
+        </p:txBody>
+      </p:sp>
+      <p:sp>
+        <p:nvSpPr>
+          <p:cNvPr id="82" name="Rectangle 81"/>
           <p:cNvSpPr/>
           <p:nvPr/>
         </p:nvSpPr>
         <p:spPr>
           <a:xfrm>
-            <a:off x="8046720" y="5577840"/>
-            <a:ext cx="3383280" cy="594360"/>
+            <a:off x="8046720" y="5358383"/>
+            <a:ext cx="3401568" cy="621792"/>
           </a:xfrm>
           <a:prstGeom prst="rect">
             <a:avLst/>
@@ -11263,8 +12179,10 @@
           <a:solidFill>
             <a:srgbClr val="FFFFFF"/>
           </a:solidFill>
-          <a:ln>
-            <a:noFill/>
+          <a:ln w="12700">
+            <a:solidFill>
+              <a:srgbClr val="E2E8F0"/>
+            </a:solidFill>
           </a:ln>
         </p:spPr>
         <p:style>
@@ -11291,14 +12209,14 @@
       </p:sp>
       <p:sp>
         <p:nvSpPr>
-          <p:cNvPr id="62" name="TextBox 61"/>
-          <p:cNvSpPr txBox="1"/>
-          <p:nvPr/>
-        </p:nvSpPr>
-        <p:spPr>
-          <a:xfrm>
-            <a:off x="8229600" y="5650992"/>
-            <a:ext cx="1737360" cy="457200"/>
+          <p:cNvPr id="83" name="TextBox 82"/>
+          <p:cNvSpPr txBox="1"/>
+          <p:nvPr/>
+        </p:nvSpPr>
+        <p:spPr>
+          <a:xfrm>
+            <a:off x="8156448" y="5394959"/>
+            <a:ext cx="1965960" cy="274320"/>
           </a:xfrm>
           <a:prstGeom prst="rect">
             <a:avLst/>
@@ -11313,34 +12231,34 @@
           <a:p>
             <a:pPr algn="l">
               <a:lnSpc>
-                <a:spcPts val="1320"/>
-              </a:lnSpc>
-              <a:spcAft>
-                <a:spcPts val="0"/>
-              </a:spcAft>
-              <a:defRPr sz="1200" b="1">
-                <a:solidFill>
-                  <a:srgbClr val="64748B"/>
+                <a:spcPts val="1200"/>
+              </a:lnSpc>
+              <a:spcAft>
+                <a:spcPts val="0"/>
+              </a:spcAft>
+              <a:defRPr sz="1000" b="1">
+                <a:solidFill>
+                  <a:srgbClr val="1E293B"/>
                 </a:solidFill>
                 <a:latin typeface="Karla"/>
               </a:defRPr>
             </a:pPr>
             <a:r>
-              <a:t>Net</a:t>
-            </a:r>
-          </a:p>
-        </p:txBody>
-      </p:sp>
-      <p:sp>
-        <p:nvSpPr>
-          <p:cNvPr id="63" name="TextBox 62"/>
-          <p:cNvSpPr txBox="1"/>
-          <p:nvPr/>
-        </p:nvSpPr>
-        <p:spPr>
-          <a:xfrm>
-            <a:off x="9784080" y="5669280"/>
-            <a:ext cx="1371600" cy="411480"/>
+              <a:t>Net Contribution</a:t>
+            </a:r>
+          </a:p>
+        </p:txBody>
+      </p:sp>
+      <p:sp>
+        <p:nvSpPr>
+          <p:cNvPr id="84" name="TextBox 83"/>
+          <p:cNvSpPr txBox="1"/>
+          <p:nvPr/>
+        </p:nvSpPr>
+        <p:spPr>
+          <a:xfrm>
+            <a:off x="10012680" y="5394959"/>
+            <a:ext cx="1325880" cy="274320"/>
           </a:xfrm>
           <a:prstGeom prst="rect">
             <a:avLst/>
@@ -11355,27 +12273,156 @@
           <a:p>
             <a:pPr algn="r">
               <a:lnSpc>
-                <a:spcPts val="1560"/>
-              </a:lnSpc>
-              <a:spcAft>
-                <a:spcPts val="0"/>
-              </a:spcAft>
-              <a:defRPr sz="1300" b="1">
+                <a:spcPts val="1380"/>
+              </a:lnSpc>
+              <a:spcAft>
+                <a:spcPts val="0"/>
+              </a:spcAft>
+              <a:defRPr sz="1150" b="1">
                 <a:solidFill>
                   <a:srgbClr val="16A34A"/>
                 </a:solidFill>
+                <a:latin typeface="Fredoka"/>
+              </a:defRPr>
+            </a:pPr>
+            <a:r>
+              <a:t>KSH 20.3M</a:t>
+            </a:r>
+          </a:p>
+        </p:txBody>
+      </p:sp>
+      <p:sp>
+        <p:nvSpPr>
+          <p:cNvPr id="85" name="TextBox 84"/>
+          <p:cNvSpPr txBox="1"/>
+          <p:nvPr/>
+        </p:nvSpPr>
+        <p:spPr>
+          <a:xfrm>
+            <a:off x="8156448" y="5687567"/>
+            <a:ext cx="3182112" cy="237744"/>
+          </a:xfrm>
+          <a:prstGeom prst="rect">
+            <a:avLst/>
+          </a:prstGeom>
+          <a:noFill/>
+        </p:spPr>
+        <p:txBody>
+          <a:bodyPr wrap="square">
+            <a:spAutoFit/>
+          </a:bodyPr>
+          <a:lstStyle/>
+          <a:p>
+            <a:pPr algn="l">
+              <a:lnSpc>
+                <a:spcPts val="983"/>
+              </a:lnSpc>
+              <a:spcAft>
+                <a:spcPts val="0"/>
+              </a:spcAft>
+              <a:defRPr sz="819" b="0">
+                <a:solidFill>
+                  <a:srgbClr val="15803D"/>
+                </a:solidFill>
+                <a:latin typeface="Karla"/>
+              </a:defRPr>
+            </a:pPr>
+            <a:r>
+              <a:t>Formula: Take (103.3M) - Payments (18.0M) - OPEX (65.0M)</a:t>
+            </a:r>
+          </a:p>
+        </p:txBody>
+      </p:sp>
+      <p:sp>
+        <p:nvSpPr>
+          <p:cNvPr id="86" name="Rectangle 85"/>
+          <p:cNvSpPr/>
+          <p:nvPr/>
+        </p:nvSpPr>
+        <p:spPr>
+          <a:xfrm>
+            <a:off x="731520" y="6108192"/>
+            <a:ext cx="10716768" cy="256032"/>
+          </a:xfrm>
+          <a:prstGeom prst="rect">
+            <a:avLst/>
+          </a:prstGeom>
+          <a:solidFill>
+            <a:srgbClr val="F1F5F9"/>
+          </a:solidFill>
+          <a:ln w="12700">
+            <a:solidFill>
+              <a:srgbClr val="E2E8F0"/>
+            </a:solidFill>
+          </a:ln>
+        </p:spPr>
+        <p:style>
+          <a:lnRef idx="1">
+            <a:schemeClr val="accent1"/>
+          </a:lnRef>
+          <a:fillRef idx="3">
+            <a:schemeClr val="accent1"/>
+          </a:fillRef>
+          <a:effectRef idx="2">
+            <a:schemeClr val="accent1"/>
+          </a:effectRef>
+          <a:fontRef idx="minor">
+            <a:schemeClr val="lt1"/>
+          </a:fontRef>
+        </p:style>
+        <p:txBody>
+          <a:bodyPr rtlCol="0" anchor="ctr"/>
+          <a:lstStyle/>
+          <a:p>
+            <a:pPr algn="ctr"/>
+          </a:p>
+        </p:txBody>
+      </p:sp>
+      <p:sp>
+        <p:nvSpPr>
+          <p:cNvPr id="87" name="TextBox 86"/>
+          <p:cNvSpPr txBox="1"/>
+          <p:nvPr/>
+        </p:nvSpPr>
+        <p:spPr>
+          <a:xfrm>
+            <a:off x="777240" y="6126480"/>
+            <a:ext cx="10625328" cy="219456"/>
+          </a:xfrm>
+          <a:prstGeom prst="rect">
+            <a:avLst/>
+          </a:prstGeom>
+          <a:noFill/>
+        </p:spPr>
+        <p:txBody>
+          <a:bodyPr wrap="square">
+            <a:spAutoFit/>
+          </a:bodyPr>
+          <a:lstStyle/>
+          <a:p>
+            <a:pPr algn="ctr">
+              <a:lnSpc>
+                <a:spcPts val="900"/>
+              </a:lnSpc>
+              <a:spcAft>
+                <a:spcPts val="0"/>
+              </a:spcAft>
+              <a:defRPr sz="750" b="1">
+                <a:solidFill>
+                  <a:srgbClr val="475569"/>
+                </a:solidFill>
                 <a:latin typeface="JetBrains Mono"/>
               </a:defRPr>
             </a:pPr>
             <a:r>
-              <a:t>KSH 20.3M</a:t>
-            </a:r>
-          </a:p>
-        </p:txBody>
-      </p:sp>
-      <p:sp>
-        <p:nvSpPr>
-          <p:cNvPr id="64" name="TextBox 63"/>
+              <a:t>MASTER FORMULAS:  GMV = Σ(Orders × AOV)   │   Take = (Retail Orders × KSH 52) + (Wholesale Orders × KSH 222.50)   │   Payments = Total Orders × KSH 15   │   Net = Take - Payments - OPEX</a:t>
+            </a:r>
+          </a:p>
+        </p:txBody>
+      </p:sp>
+      <p:sp>
+        <p:nvSpPr>
+          <p:cNvPr id="88" name="TextBox 87"/>
           <p:cNvSpPr txBox="1"/>
           <p:nvPr/>
         </p:nvSpPr>
@@ -11417,7 +12464,7 @@
       </p:sp>
       <p:sp>
         <p:nvSpPr>
-          <p:cNvPr id="65" name="TextBox 64"/>
+          <p:cNvPr id="89" name="TextBox 88"/>
           <p:cNvSpPr txBox="1"/>
           <p:nvPr/>
         </p:nvSpPr>

</xml_diff>